<commit_message>
Update CES parameter grids and optimization methods
Refined the rhoGrid_KL and rhoGrid_VAE parameter grids for more granular control in MERGE CES parameters.R. Limited the set of optimization methods to Newton, L-BFGS-B, BFGS, and DE for estimation. Added new descriptive statistics and regions proposal Excel files.
</commit_message>
<xml_diff>
--- a/Figures.pptx
+++ b/Figures.pptx
@@ -5,9 +5,10 @@
     <p:sldMasterId id="2147483648" r:id="rId1"/>
   </p:sldMasterIdLst>
   <p:sldIdLst>
-    <p:sldId id="256" r:id="rId2"/>
-    <p:sldId id="258" r:id="rId3"/>
-    <p:sldId id="257" r:id="rId4"/>
+    <p:sldId id="257" r:id="rId2"/>
+    <p:sldId id="256" r:id="rId3"/>
+    <p:sldId id="258" r:id="rId4"/>
+    <p:sldId id="259" r:id="rId5"/>
   </p:sldIdLst>
   <p:sldSz cx="12192000" cy="6858000"/>
   <p:notesSz cx="6858000" cy="9144000"/>
@@ -106,13 +107,19 @@
       </a:defRPr>
     </a:lvl9pPr>
   </p:defaultTextStyle>
+  <p:extLst>
+    <p:ext uri="{EFAFB233-063F-42B5-8137-9DF3F51BA10A}">
+      <p15:sldGuideLst xmlns:p15="http://schemas.microsoft.com/office/powerpoint/2012/main"/>
+    </p:ext>
+  </p:extLst>
 </p:presentation>
 </file>
 
 <file path=ppt/revisionInfo.xml><?xml version="1.0" encoding="utf-8"?>
 <p1510:revInfo xmlns:a="http://schemas.openxmlformats.org/drawingml/2006/main" xmlns:r="http://schemas.openxmlformats.org/officeDocument/2006/relationships" xmlns:p1510="http://schemas.microsoft.com/office/powerpoint/2015/10/main">
   <p1510:revLst>
-    <p1510:client id="{E3FB5A4F-832D-400F-A7A8-0647EE990C74}" v="15" dt="2025-11-16T15:42:07.805"/>
+    <p1510:client id="{66280F0E-0BFE-2246-9BFF-5E9DC2C2E8A1}" v="9" dt="2025-11-17T16:57:22.724"/>
+    <p1510:client id="{E3FB5A4F-832D-400F-A7A8-0647EE990C74}" v="4" dt="2025-11-18T15:18:05.865"/>
   </p1510:revLst>
 </p1510:revInfo>
 </file>
@@ -120,9 +127,120 @@
 <file path=ppt/changesInfos/changesInfo1.xml><?xml version="1.0" encoding="utf-8"?>
 <pc:chgInfo xmlns:a="http://schemas.openxmlformats.org/drawingml/2006/main" xmlns:r="http://schemas.openxmlformats.org/officeDocument/2006/relationships" xmlns:ac="http://schemas.microsoft.com/office/drawing/2013/main/command" xmlns:pc="http://schemas.microsoft.com/office/powerpoint/2013/main/command">
   <pc:docChgLst>
+    <pc:chgData name="Escamilla Garcia, Gerardo Alonso" userId="8ce80ce6-f1b6-4699-af6b-2369c5a25767" providerId="ADAL" clId="{141C959E-4585-599B-B6AB-EB47E5027B4C}"/>
+    <pc:docChg chg="custSel modSld sldOrd">
+      <pc:chgData name="Escamilla Garcia, Gerardo Alonso" userId="8ce80ce6-f1b6-4699-af6b-2369c5a25767" providerId="ADAL" clId="{141C959E-4585-599B-B6AB-EB47E5027B4C}" dt="2025-11-17T17:47:23.987" v="229" actId="732"/>
+      <pc:docMkLst>
+        <pc:docMk/>
+      </pc:docMkLst>
+      <pc:sldChg chg="addSp delSp modSp mod ord">
+        <pc:chgData name="Escamilla Garcia, Gerardo Alonso" userId="8ce80ce6-f1b6-4699-af6b-2369c5a25767" providerId="ADAL" clId="{141C959E-4585-599B-B6AB-EB47E5027B4C}" dt="2025-11-17T16:57:22.724" v="227"/>
+        <pc:sldMkLst>
+          <pc:docMk/>
+          <pc:sldMk cId="3115004336" sldId="257"/>
+        </pc:sldMkLst>
+        <pc:spChg chg="del">
+          <ac:chgData name="Escamilla Garcia, Gerardo Alonso" userId="8ce80ce6-f1b6-4699-af6b-2369c5a25767" providerId="ADAL" clId="{141C959E-4585-599B-B6AB-EB47E5027B4C}" dt="2025-11-17T16:51:25.517" v="9" actId="478"/>
+          <ac:spMkLst>
+            <pc:docMk/>
+            <pc:sldMk cId="3115004336" sldId="257"/>
+            <ac:spMk id="2" creationId="{57362C6B-CDE6-9A2D-6F67-9A014F61CE4B}"/>
+          </ac:spMkLst>
+        </pc:spChg>
+        <pc:spChg chg="del">
+          <ac:chgData name="Escamilla Garcia, Gerardo Alonso" userId="8ce80ce6-f1b6-4699-af6b-2369c5a25767" providerId="ADAL" clId="{141C959E-4585-599B-B6AB-EB47E5027B4C}" dt="2025-11-17T16:50:45.976" v="0" actId="478"/>
+          <ac:spMkLst>
+            <pc:docMk/>
+            <pc:sldMk cId="3115004336" sldId="257"/>
+            <ac:spMk id="3" creationId="{2F0624FE-28C1-0593-CDCE-7E7D2AAF89E0}"/>
+          </ac:spMkLst>
+        </pc:spChg>
+        <pc:spChg chg="add mod">
+          <ac:chgData name="Escamilla Garcia, Gerardo Alonso" userId="8ce80ce6-f1b6-4699-af6b-2369c5a25767" providerId="ADAL" clId="{141C959E-4585-599B-B6AB-EB47E5027B4C}" dt="2025-11-17T16:51:54.220" v="95" actId="20577"/>
+          <ac:spMkLst>
+            <pc:docMk/>
+            <pc:sldMk cId="3115004336" sldId="257"/>
+            <ac:spMk id="7" creationId="{0CDEC4EC-4157-A423-AF96-DF013CC33AF5}"/>
+          </ac:spMkLst>
+        </pc:spChg>
+        <pc:spChg chg="add mod">
+          <ac:chgData name="Escamilla Garcia, Gerardo Alonso" userId="8ce80ce6-f1b6-4699-af6b-2369c5a25767" providerId="ADAL" clId="{141C959E-4585-599B-B6AB-EB47E5027B4C}" dt="2025-11-17T16:52:38.476" v="221" actId="313"/>
+          <ac:spMkLst>
+            <pc:docMk/>
+            <pc:sldMk cId="3115004336" sldId="257"/>
+            <ac:spMk id="8" creationId="{5CB157B4-481F-79FA-4289-54BA5685A926}"/>
+          </ac:spMkLst>
+        </pc:spChg>
+        <pc:spChg chg="add del mod">
+          <ac:chgData name="Escamilla Garcia, Gerardo Alonso" userId="8ce80ce6-f1b6-4699-af6b-2369c5a25767" providerId="ADAL" clId="{141C959E-4585-599B-B6AB-EB47E5027B4C}" dt="2025-11-17T16:51:27.454" v="10" actId="478"/>
+          <ac:spMkLst>
+            <pc:docMk/>
+            <pc:sldMk cId="3115004336" sldId="257"/>
+            <ac:spMk id="10" creationId="{EB1071A8-5532-4BF3-3A72-8B2D0745DA81}"/>
+          </ac:spMkLst>
+        </pc:spChg>
+        <pc:graphicFrameChg chg="add mod">
+          <ac:chgData name="Escamilla Garcia, Gerardo Alonso" userId="8ce80ce6-f1b6-4699-af6b-2369c5a25767" providerId="ADAL" clId="{141C959E-4585-599B-B6AB-EB47E5027B4C}" dt="2025-11-17T16:50:56.300" v="3"/>
+          <ac:graphicFrameMkLst>
+            <pc:docMk/>
+            <pc:sldMk cId="3115004336" sldId="257"/>
+            <ac:graphicFrameMk id="4" creationId="{779CB155-7DE7-04E6-2186-0CFD809EC8E3}"/>
+          </ac:graphicFrameMkLst>
+        </pc:graphicFrameChg>
+        <pc:graphicFrameChg chg="add mod">
+          <ac:chgData name="Escamilla Garcia, Gerardo Alonso" userId="8ce80ce6-f1b6-4699-af6b-2369c5a25767" providerId="ADAL" clId="{141C959E-4585-599B-B6AB-EB47E5027B4C}" dt="2025-11-17T16:51:02.800" v="6"/>
+          <ac:graphicFrameMkLst>
+            <pc:docMk/>
+            <pc:sldMk cId="3115004336" sldId="257"/>
+            <ac:graphicFrameMk id="5" creationId="{779CB155-7DE7-04E6-2186-0CFD809EC8E3}"/>
+          </ac:graphicFrameMkLst>
+        </pc:graphicFrameChg>
+        <pc:graphicFrameChg chg="add mod">
+          <ac:chgData name="Escamilla Garcia, Gerardo Alonso" userId="8ce80ce6-f1b6-4699-af6b-2369c5a25767" providerId="ADAL" clId="{141C959E-4585-599B-B6AB-EB47E5027B4C}" dt="2025-11-17T16:57:17.251" v="226"/>
+          <ac:graphicFrameMkLst>
+            <pc:docMk/>
+            <pc:sldMk cId="3115004336" sldId="257"/>
+            <ac:graphicFrameMk id="11" creationId="{779CB155-7DE7-04E6-2186-0CFD809EC8E3}"/>
+          </ac:graphicFrameMkLst>
+        </pc:graphicFrameChg>
+        <pc:picChg chg="add del">
+          <ac:chgData name="Escamilla Garcia, Gerardo Alonso" userId="8ce80ce6-f1b6-4699-af6b-2369c5a25767" providerId="ADAL" clId="{141C959E-4585-599B-B6AB-EB47E5027B4C}" dt="2025-11-17T16:57:11.487" v="223" actId="478"/>
+          <ac:picMkLst>
+            <pc:docMk/>
+            <pc:sldMk cId="3115004336" sldId="257"/>
+            <ac:picMk id="6" creationId="{FC1089A2-4E68-35FD-E40E-4DBA2A3A481E}"/>
+          </ac:picMkLst>
+        </pc:picChg>
+        <pc:picChg chg="add">
+          <ac:chgData name="Escamilla Garcia, Gerardo Alonso" userId="8ce80ce6-f1b6-4699-af6b-2369c5a25767" providerId="ADAL" clId="{141C959E-4585-599B-B6AB-EB47E5027B4C}" dt="2025-11-17T16:57:22.724" v="227"/>
+          <ac:picMkLst>
+            <pc:docMk/>
+            <pc:sldMk cId="3115004336" sldId="257"/>
+            <ac:picMk id="12" creationId="{872101D7-FC0A-8F74-D2EC-723C0DB7C559}"/>
+          </ac:picMkLst>
+        </pc:picChg>
+      </pc:sldChg>
+      <pc:sldChg chg="modSp mod">
+        <pc:chgData name="Escamilla Garcia, Gerardo Alonso" userId="8ce80ce6-f1b6-4699-af6b-2369c5a25767" providerId="ADAL" clId="{141C959E-4585-599B-B6AB-EB47E5027B4C}" dt="2025-11-17T17:47:23.987" v="229" actId="732"/>
+        <pc:sldMkLst>
+          <pc:docMk/>
+          <pc:sldMk cId="4231950803" sldId="258"/>
+        </pc:sldMkLst>
+        <pc:picChg chg="mod modCrop">
+          <ac:chgData name="Escamilla Garcia, Gerardo Alonso" userId="8ce80ce6-f1b6-4699-af6b-2369c5a25767" providerId="ADAL" clId="{141C959E-4585-599B-B6AB-EB47E5027B4C}" dt="2025-11-17T17:47:23.987" v="229" actId="732"/>
+          <ac:picMkLst>
+            <pc:docMk/>
+            <pc:sldMk cId="4231950803" sldId="258"/>
+            <ac:picMk id="6" creationId="{B4F350FF-E790-556D-074F-36FA32D1E84D}"/>
+          </ac:picMkLst>
+        </pc:picChg>
+      </pc:sldChg>
+    </pc:docChg>
+  </pc:docChgLst>
+  <pc:docChgLst>
     <pc:chgData name="Escamilla Garcia, Gerardo Alonso" userId="8ce80ce6-f1b6-4699-af6b-2369c5a25767" providerId="ADAL" clId="{E3FB5A4F-832D-400F-A7A8-0647EE990C74}"/>
     <pc:docChg chg="undo redo custSel addSld delSld modSld">
-      <pc:chgData name="Escamilla Garcia, Gerardo Alonso" userId="8ce80ce6-f1b6-4699-af6b-2369c5a25767" providerId="ADAL" clId="{E3FB5A4F-832D-400F-A7A8-0647EE990C74}" dt="2025-11-16T15:42:24.575" v="393" actId="1076"/>
+      <pc:chgData name="Escamilla Garcia, Gerardo Alonso" userId="8ce80ce6-f1b6-4699-af6b-2369c5a25767" providerId="ADAL" clId="{E3FB5A4F-832D-400F-A7A8-0647EE990C74}" dt="2025-11-18T15:18:05.865" v="397" actId="1076"/>
       <pc:docMkLst>
         <pc:docMk/>
       </pc:docMkLst>
@@ -140,28 +258,12 @@
             <ac:spMk id="29" creationId="{E5BA9A4A-711C-D778-BAB3-B45E3621E96B}"/>
           </ac:spMkLst>
         </pc:spChg>
-        <pc:spChg chg="del mod">
-          <ac:chgData name="Escamilla Garcia, Gerardo Alonso" userId="8ce80ce6-f1b6-4699-af6b-2369c5a25767" providerId="ADAL" clId="{E3FB5A4F-832D-400F-A7A8-0647EE990C74}" dt="2025-11-16T15:36:29.376" v="288" actId="478"/>
-          <ac:spMkLst>
-            <pc:docMk/>
-            <pc:sldMk cId="601372393" sldId="256"/>
-            <ac:spMk id="31" creationId="{74496CA0-E5D7-E6C5-CF4D-E65D9E822E33}"/>
-          </ac:spMkLst>
-        </pc:spChg>
         <pc:spChg chg="mod">
           <ac:chgData name="Escamilla Garcia, Gerardo Alonso" userId="8ce80ce6-f1b6-4699-af6b-2369c5a25767" providerId="ADAL" clId="{E3FB5A4F-832D-400F-A7A8-0647EE990C74}" dt="2025-11-16T15:37:01.186" v="318" actId="1035"/>
           <ac:spMkLst>
             <pc:docMk/>
             <pc:sldMk cId="601372393" sldId="256"/>
             <ac:spMk id="32" creationId="{BDC14156-8C82-437B-E41D-FB43914FA9CA}"/>
-          </ac:spMkLst>
-        </pc:spChg>
-        <pc:spChg chg="add del">
-          <ac:chgData name="Escamilla Garcia, Gerardo Alonso" userId="8ce80ce6-f1b6-4699-af6b-2369c5a25767" providerId="ADAL" clId="{E3FB5A4F-832D-400F-A7A8-0647EE990C74}" dt="2025-11-16T14:59:34.388" v="5" actId="22"/>
-          <ac:spMkLst>
-            <pc:docMk/>
-            <pc:sldMk cId="601372393" sldId="256"/>
-            <ac:spMk id="34" creationId="{DE5E591A-FD87-E24E-9061-A071F5928D8C}"/>
           </ac:spMkLst>
         </pc:spChg>
         <pc:spChg chg="add mod">
@@ -178,22 +280,6 @@
             <pc:docMk/>
             <pc:sldMk cId="601372393" sldId="256"/>
             <ac:spMk id="37" creationId="{75C05A73-D57D-1ABD-9B78-F7573A3D9F7A}"/>
-          </ac:spMkLst>
-        </pc:spChg>
-        <pc:spChg chg="add del mod">
-          <ac:chgData name="Escamilla Garcia, Gerardo Alonso" userId="8ce80ce6-f1b6-4699-af6b-2369c5a25767" providerId="ADAL" clId="{E3FB5A4F-832D-400F-A7A8-0647EE990C74}" dt="2025-11-16T15:36:14.330" v="283" actId="478"/>
-          <ac:spMkLst>
-            <pc:docMk/>
-            <pc:sldMk cId="601372393" sldId="256"/>
-            <ac:spMk id="38" creationId="{749C3844-45DB-9598-E634-E3819F3CCB44}"/>
-          </ac:spMkLst>
-        </pc:spChg>
-        <pc:spChg chg="add mod">
-          <ac:chgData name="Escamilla Garcia, Gerardo Alonso" userId="8ce80ce6-f1b6-4699-af6b-2369c5a25767" providerId="ADAL" clId="{E3FB5A4F-832D-400F-A7A8-0647EE990C74}" dt="2025-11-16T15:36:33.326" v="290" actId="571"/>
-          <ac:spMkLst>
-            <pc:docMk/>
-            <pc:sldMk cId="601372393" sldId="256"/>
-            <ac:spMk id="39" creationId="{1BC33630-B84C-467F-A60F-F46E763F14B9}"/>
           </ac:spMkLst>
         </pc:spChg>
         <pc:spChg chg="add mod">
@@ -284,102 +370,6 @@
             <ac:picMk id="5" creationId="{916CD5CB-3038-8426-EBC7-DAFE9C293051}"/>
           </ac:picMkLst>
         </pc:picChg>
-        <pc:picChg chg="del">
-          <ac:chgData name="Escamilla Garcia, Gerardo Alonso" userId="8ce80ce6-f1b6-4699-af6b-2369c5a25767" providerId="ADAL" clId="{E3FB5A4F-832D-400F-A7A8-0647EE990C74}" dt="2025-11-16T15:34:52.917" v="239" actId="478"/>
-          <ac:picMkLst>
-            <pc:docMk/>
-            <pc:sldMk cId="601372393" sldId="256"/>
-            <ac:picMk id="7" creationId="{A3B6A8B6-4830-07B3-1C80-AB02A0D7C923}"/>
-          </ac:picMkLst>
-        </pc:picChg>
-        <pc:picChg chg="del mod">
-          <ac:chgData name="Escamilla Garcia, Gerardo Alonso" userId="8ce80ce6-f1b6-4699-af6b-2369c5a25767" providerId="ADAL" clId="{E3FB5A4F-832D-400F-A7A8-0647EE990C74}" dt="2025-11-16T15:38:39.946" v="377" actId="478"/>
-          <ac:picMkLst>
-            <pc:docMk/>
-            <pc:sldMk cId="601372393" sldId="256"/>
-            <ac:picMk id="9" creationId="{C066DAA2-6454-EF53-304A-F75EF61D5DD9}"/>
-          </ac:picMkLst>
-        </pc:picChg>
-        <pc:picChg chg="del">
-          <ac:chgData name="Escamilla Garcia, Gerardo Alonso" userId="8ce80ce6-f1b6-4699-af6b-2369c5a25767" providerId="ADAL" clId="{E3FB5A4F-832D-400F-A7A8-0647EE990C74}" dt="2025-11-16T15:37:35.579" v="361" actId="478"/>
-          <ac:picMkLst>
-            <pc:docMk/>
-            <pc:sldMk cId="601372393" sldId="256"/>
-            <ac:picMk id="14" creationId="{5D99B227-9A41-B11D-9779-4874CAE5827E}"/>
-          </ac:picMkLst>
-        </pc:picChg>
-        <pc:picChg chg="del mod">
-          <ac:chgData name="Escamilla Garcia, Gerardo Alonso" userId="8ce80ce6-f1b6-4699-af6b-2369c5a25767" providerId="ADAL" clId="{E3FB5A4F-832D-400F-A7A8-0647EE990C74}" dt="2025-11-16T15:37:39.186" v="363" actId="478"/>
-          <ac:picMkLst>
-            <pc:docMk/>
-            <pc:sldMk cId="601372393" sldId="256"/>
-            <ac:picMk id="15" creationId="{4E2DCD7C-4647-37B2-04D4-5754E1DEEEA1}"/>
-          </ac:picMkLst>
-        </pc:picChg>
-        <pc:picChg chg="del mod">
-          <ac:chgData name="Escamilla Garcia, Gerardo Alonso" userId="8ce80ce6-f1b6-4699-af6b-2369c5a25767" providerId="ADAL" clId="{E3FB5A4F-832D-400F-A7A8-0647EE990C74}" dt="2025-11-16T15:37:38.264" v="362" actId="478"/>
-          <ac:picMkLst>
-            <pc:docMk/>
-            <pc:sldMk cId="601372393" sldId="256"/>
-            <ac:picMk id="17" creationId="{94035B3B-0A18-8148-F018-829DA430E727}"/>
-          </ac:picMkLst>
-        </pc:picChg>
-        <pc:picChg chg="del">
-          <ac:chgData name="Escamilla Garcia, Gerardo Alonso" userId="8ce80ce6-f1b6-4699-af6b-2369c5a25767" providerId="ADAL" clId="{E3FB5A4F-832D-400F-A7A8-0647EE990C74}" dt="2025-11-16T15:38:40.930" v="378" actId="478"/>
-          <ac:picMkLst>
-            <pc:docMk/>
-            <pc:sldMk cId="601372393" sldId="256"/>
-            <ac:picMk id="19" creationId="{97F5252B-1DE8-C18A-47EE-7E84C17965D5}"/>
-          </ac:picMkLst>
-        </pc:picChg>
-        <pc:picChg chg="del mod">
-          <ac:chgData name="Escamilla Garcia, Gerardo Alonso" userId="8ce80ce6-f1b6-4699-af6b-2369c5a25767" providerId="ADAL" clId="{E3FB5A4F-832D-400F-A7A8-0647EE990C74}" dt="2025-11-16T15:38:10.568" v="371" actId="478"/>
-          <ac:picMkLst>
-            <pc:docMk/>
-            <pc:sldMk cId="601372393" sldId="256"/>
-            <ac:picMk id="20" creationId="{9A51B6D3-55F3-5EC5-BA72-DB903D0B72D7}"/>
-          </ac:picMkLst>
-        </pc:picChg>
-        <pc:picChg chg="del mod">
-          <ac:chgData name="Escamilla Garcia, Gerardo Alonso" userId="8ce80ce6-f1b6-4699-af6b-2369c5a25767" providerId="ADAL" clId="{E3FB5A4F-832D-400F-A7A8-0647EE990C74}" dt="2025-11-16T15:38:10.568" v="371" actId="478"/>
-          <ac:picMkLst>
-            <pc:docMk/>
-            <pc:sldMk cId="601372393" sldId="256"/>
-            <ac:picMk id="21" creationId="{0D2252F2-5B68-844F-1B03-3AC7274F44CA}"/>
-          </ac:picMkLst>
-        </pc:picChg>
-        <pc:picChg chg="del">
-          <ac:chgData name="Escamilla Garcia, Gerardo Alonso" userId="8ce80ce6-f1b6-4699-af6b-2369c5a25767" providerId="ADAL" clId="{E3FB5A4F-832D-400F-A7A8-0647EE990C74}" dt="2025-11-16T15:38:10.568" v="371" actId="478"/>
-          <ac:picMkLst>
-            <pc:docMk/>
-            <pc:sldMk cId="601372393" sldId="256"/>
-            <ac:picMk id="26" creationId="{60DFAD5E-AC97-1165-C217-0324E147715D}"/>
-          </ac:picMkLst>
-        </pc:picChg>
-        <pc:picChg chg="del">
-          <ac:chgData name="Escamilla Garcia, Gerardo Alonso" userId="8ce80ce6-f1b6-4699-af6b-2369c5a25767" providerId="ADAL" clId="{E3FB5A4F-832D-400F-A7A8-0647EE990C74}" dt="2025-11-16T15:38:42.158" v="379" actId="478"/>
-          <ac:picMkLst>
-            <pc:docMk/>
-            <pc:sldMk cId="601372393" sldId="256"/>
-            <ac:picMk id="27" creationId="{A365016D-65E4-D58D-829D-672F6049F3B4}"/>
-          </ac:picMkLst>
-        </pc:picChg>
-        <pc:picChg chg="del mod">
-          <ac:chgData name="Escamilla Garcia, Gerardo Alonso" userId="8ce80ce6-f1b6-4699-af6b-2369c5a25767" providerId="ADAL" clId="{E3FB5A4F-832D-400F-A7A8-0647EE990C74}" dt="2025-11-16T15:35:58.385" v="280" actId="478"/>
-          <ac:picMkLst>
-            <pc:docMk/>
-            <pc:sldMk cId="601372393" sldId="256"/>
-            <ac:picMk id="28" creationId="{9D142E88-414A-8266-CB48-FCED0BC55734}"/>
-          </ac:picMkLst>
-        </pc:picChg>
-        <pc:picChg chg="del mod">
-          <ac:chgData name="Escamilla Garcia, Gerardo Alonso" userId="8ce80ce6-f1b6-4699-af6b-2369c5a25767" providerId="ADAL" clId="{E3FB5A4F-832D-400F-A7A8-0647EE990C74}" dt="2025-11-16T15:35:57.299" v="279" actId="478"/>
-          <ac:picMkLst>
-            <pc:docMk/>
-            <pc:sldMk cId="601372393" sldId="256"/>
-            <ac:picMk id="30" creationId="{A7FD5816-5258-83EF-72A6-9F4B418169F1}"/>
-          </ac:picMkLst>
-        </pc:picChg>
       </pc:sldChg>
       <pc:sldChg chg="modSp new mod">
         <pc:chgData name="Escamilla Garcia, Gerardo Alonso" userId="8ce80ce6-f1b6-4699-af6b-2369c5a25767" providerId="ADAL" clId="{E3FB5A4F-832D-400F-A7A8-0647EE990C74}" dt="2025-11-16T14:59:21.646" v="1" actId="20577"/>
@@ -387,14 +377,6 @@
           <pc:docMk/>
           <pc:sldMk cId="3115004336" sldId="257"/>
         </pc:sldMkLst>
-        <pc:spChg chg="mod">
-          <ac:chgData name="Escamilla Garcia, Gerardo Alonso" userId="8ce80ce6-f1b6-4699-af6b-2369c5a25767" providerId="ADAL" clId="{E3FB5A4F-832D-400F-A7A8-0647EE990C74}" dt="2025-11-16T14:59:21.646" v="1" actId="20577"/>
-          <ac:spMkLst>
-            <pc:docMk/>
-            <pc:sldMk cId="3115004336" sldId="257"/>
-            <ac:spMk id="2" creationId="{57362C6B-CDE6-9A2D-6F67-9A014F61CE4B}"/>
-          </ac:spMkLst>
-        </pc:spChg>
       </pc:sldChg>
       <pc:sldChg chg="add del">
         <pc:chgData name="Escamilla Garcia, Gerardo Alonso" userId="8ce80ce6-f1b6-4699-af6b-2369c5a25767" providerId="ADAL" clId="{E3FB5A4F-832D-400F-A7A8-0647EE990C74}" dt="2025-11-16T14:59:28.535" v="3"/>
@@ -409,108 +391,35 @@
           <pc:docMk/>
           <pc:sldMk cId="4231950803" sldId="258"/>
         </pc:sldMkLst>
-        <pc:spChg chg="add del">
-          <ac:chgData name="Escamilla Garcia, Gerardo Alonso" userId="8ce80ce6-f1b6-4699-af6b-2369c5a25767" providerId="ADAL" clId="{E3FB5A4F-832D-400F-A7A8-0647EE990C74}" dt="2025-11-16T15:42:03.786" v="389" actId="22"/>
-          <ac:spMkLst>
-            <pc:docMk/>
-            <pc:sldMk cId="4231950803" sldId="258"/>
-            <ac:spMk id="3" creationId="{D7BAF083-9C0C-5AE7-F3B5-ED36B0AD9FE9}"/>
-          </ac:spMkLst>
-        </pc:spChg>
-        <pc:spChg chg="del">
-          <ac:chgData name="Escamilla Garcia, Gerardo Alonso" userId="8ce80ce6-f1b6-4699-af6b-2369c5a25767" providerId="ADAL" clId="{E3FB5A4F-832D-400F-A7A8-0647EE990C74}" dt="2025-11-16T15:42:02.385" v="387" actId="478"/>
-          <ac:spMkLst>
-            <pc:docMk/>
-            <pc:sldMk cId="4231950803" sldId="258"/>
-            <ac:spMk id="29" creationId="{F9590956-23E9-1613-6F04-87456A003863}"/>
-          </ac:spMkLst>
-        </pc:spChg>
-        <pc:spChg chg="del">
-          <ac:chgData name="Escamilla Garcia, Gerardo Alonso" userId="8ce80ce6-f1b6-4699-af6b-2369c5a25767" providerId="ADAL" clId="{E3FB5A4F-832D-400F-A7A8-0647EE990C74}" dt="2025-11-16T15:42:02.385" v="387" actId="478"/>
-          <ac:spMkLst>
-            <pc:docMk/>
-            <pc:sldMk cId="4231950803" sldId="258"/>
-            <ac:spMk id="41" creationId="{7F9971D4-F33E-997E-F445-6FC5DF4886AA}"/>
-          </ac:spMkLst>
-        </pc:spChg>
-        <pc:spChg chg="del">
-          <ac:chgData name="Escamilla Garcia, Gerardo Alonso" userId="8ce80ce6-f1b6-4699-af6b-2369c5a25767" providerId="ADAL" clId="{E3FB5A4F-832D-400F-A7A8-0647EE990C74}" dt="2025-11-16T15:42:02.385" v="387" actId="478"/>
-          <ac:spMkLst>
-            <pc:docMk/>
-            <pc:sldMk cId="4231950803" sldId="258"/>
-            <ac:spMk id="42" creationId="{E784E604-144C-6C1F-94A3-C2DD08D47360}"/>
-          </ac:spMkLst>
-        </pc:spChg>
-        <pc:spChg chg="del">
-          <ac:chgData name="Escamilla Garcia, Gerardo Alonso" userId="8ce80ce6-f1b6-4699-af6b-2369c5a25767" providerId="ADAL" clId="{E3FB5A4F-832D-400F-A7A8-0647EE990C74}" dt="2025-11-16T15:42:02.385" v="387" actId="478"/>
-          <ac:spMkLst>
-            <pc:docMk/>
-            <pc:sldMk cId="4231950803" sldId="258"/>
-            <ac:spMk id="43" creationId="{E2F3FD96-2550-3B24-E408-BF82A861DC59}"/>
-          </ac:spMkLst>
-        </pc:spChg>
-        <pc:spChg chg="del">
-          <ac:chgData name="Escamilla Garcia, Gerardo Alonso" userId="8ce80ce6-f1b6-4699-af6b-2369c5a25767" providerId="ADAL" clId="{E3FB5A4F-832D-400F-A7A8-0647EE990C74}" dt="2025-11-16T15:42:02.385" v="387" actId="478"/>
-          <ac:spMkLst>
-            <pc:docMk/>
-            <pc:sldMk cId="4231950803" sldId="258"/>
-            <ac:spMk id="44" creationId="{AD934E60-18D4-4428-B91A-79E4791CEF22}"/>
-          </ac:spMkLst>
-        </pc:spChg>
-        <pc:spChg chg="del">
-          <ac:chgData name="Escamilla Garcia, Gerardo Alonso" userId="8ce80ce6-f1b6-4699-af6b-2369c5a25767" providerId="ADAL" clId="{E3FB5A4F-832D-400F-A7A8-0647EE990C74}" dt="2025-11-16T15:42:02.385" v="387" actId="478"/>
-          <ac:spMkLst>
-            <pc:docMk/>
-            <pc:sldMk cId="4231950803" sldId="258"/>
-            <ac:spMk id="46" creationId="{138D7904-9692-8A24-A3A9-C2A17B963535}"/>
-          </ac:spMkLst>
-        </pc:spChg>
-        <pc:spChg chg="del">
-          <ac:chgData name="Escamilla Garcia, Gerardo Alonso" userId="8ce80ce6-f1b6-4699-af6b-2369c5a25767" providerId="ADAL" clId="{E3FB5A4F-832D-400F-A7A8-0647EE990C74}" dt="2025-11-16T15:42:02.385" v="387" actId="478"/>
-          <ac:spMkLst>
-            <pc:docMk/>
-            <pc:sldMk cId="4231950803" sldId="258"/>
-            <ac:spMk id="47" creationId="{AD1D4CE4-1ABE-F853-219E-D16D34992171}"/>
-          </ac:spMkLst>
-        </pc:spChg>
-        <pc:spChg chg="del">
-          <ac:chgData name="Escamilla Garcia, Gerardo Alonso" userId="8ce80ce6-f1b6-4699-af6b-2369c5a25767" providerId="ADAL" clId="{E3FB5A4F-832D-400F-A7A8-0647EE990C74}" dt="2025-11-16T15:42:02.385" v="387" actId="478"/>
-          <ac:spMkLst>
-            <pc:docMk/>
-            <pc:sldMk cId="4231950803" sldId="258"/>
-            <ac:spMk id="48" creationId="{6554B814-A921-7EF2-E9B9-FA0910ACDB07}"/>
-          </ac:spMkLst>
-        </pc:spChg>
-        <pc:spChg chg="del">
-          <ac:chgData name="Escamilla Garcia, Gerardo Alonso" userId="8ce80ce6-f1b6-4699-af6b-2369c5a25767" providerId="ADAL" clId="{E3FB5A4F-832D-400F-A7A8-0647EE990C74}" dt="2025-11-16T15:42:02.385" v="387" actId="478"/>
-          <ac:spMkLst>
-            <pc:docMk/>
-            <pc:sldMk cId="4231950803" sldId="258"/>
-            <ac:spMk id="49" creationId="{E324AEAF-6779-2CDA-5CDB-7EFDBCBF8F12}"/>
-          </ac:spMkLst>
-        </pc:spChg>
-        <pc:spChg chg="del">
-          <ac:chgData name="Escamilla Garcia, Gerardo Alonso" userId="8ce80ce6-f1b6-4699-af6b-2369c5a25767" providerId="ADAL" clId="{E3FB5A4F-832D-400F-A7A8-0647EE990C74}" dt="2025-11-16T15:42:02.385" v="387" actId="478"/>
-          <ac:spMkLst>
-            <pc:docMk/>
-            <pc:sldMk cId="4231950803" sldId="258"/>
-            <ac:spMk id="50" creationId="{DE5C4D21-81BB-F83F-2F6E-D573283935F8}"/>
-          </ac:spMkLst>
-        </pc:spChg>
-        <pc:picChg chg="del">
-          <ac:chgData name="Escamilla Garcia, Gerardo Alonso" userId="8ce80ce6-f1b6-4699-af6b-2369c5a25767" providerId="ADAL" clId="{E3FB5A4F-832D-400F-A7A8-0647EE990C74}" dt="2025-11-16T15:41:59.373" v="386" actId="478"/>
-          <ac:picMkLst>
-            <pc:docMk/>
-            <pc:sldMk cId="4231950803" sldId="258"/>
-            <ac:picMk id="5" creationId="{E4089F90-3C46-F94F-8CFB-C153DFF1C38B}"/>
-          </ac:picMkLst>
-        </pc:picChg>
         <pc:picChg chg="add mod">
           <ac:chgData name="Escamilla Garcia, Gerardo Alonso" userId="8ce80ce6-f1b6-4699-af6b-2369c5a25767" providerId="ADAL" clId="{E3FB5A4F-832D-400F-A7A8-0647EE990C74}" dt="2025-11-16T15:42:24.575" v="393" actId="1076"/>
           <ac:picMkLst>
             <pc:docMk/>
             <pc:sldMk cId="4231950803" sldId="258"/>
             <ac:picMk id="6" creationId="{B4F350FF-E790-556D-074F-36FA32D1E84D}"/>
+          </ac:picMkLst>
+        </pc:picChg>
+      </pc:sldChg>
+      <pc:sldChg chg="addSp delSp modSp add mod">
+        <pc:chgData name="Escamilla Garcia, Gerardo Alonso" userId="8ce80ce6-f1b6-4699-af6b-2369c5a25767" providerId="ADAL" clId="{E3FB5A4F-832D-400F-A7A8-0647EE990C74}" dt="2025-11-18T15:18:05.865" v="397" actId="1076"/>
+        <pc:sldMkLst>
+          <pc:docMk/>
+          <pc:sldMk cId="3692195626" sldId="259"/>
+        </pc:sldMkLst>
+        <pc:graphicFrameChg chg="add mod modGraphic">
+          <ac:chgData name="Escamilla Garcia, Gerardo Alonso" userId="8ce80ce6-f1b6-4699-af6b-2369c5a25767" providerId="ADAL" clId="{E3FB5A4F-832D-400F-A7A8-0647EE990C74}" dt="2025-11-18T15:18:05.865" v="397" actId="1076"/>
+          <ac:graphicFrameMkLst>
+            <pc:docMk/>
+            <pc:sldMk cId="3692195626" sldId="259"/>
+            <ac:graphicFrameMk id="2" creationId="{C7D311A9-E6B0-C18A-7D74-00D3BF4C60AE}"/>
+          </ac:graphicFrameMkLst>
+        </pc:graphicFrameChg>
+        <pc:picChg chg="del">
+          <ac:chgData name="Escamilla Garcia, Gerardo Alonso" userId="8ce80ce6-f1b6-4699-af6b-2369c5a25767" providerId="ADAL" clId="{E3FB5A4F-832D-400F-A7A8-0647EE990C74}" dt="2025-11-18T15:17:25.170" v="395" actId="478"/>
+          <ac:picMkLst>
+            <pc:docMk/>
+            <pc:sldMk cId="3692195626" sldId="259"/>
+            <ac:picMk id="6" creationId="{36A45F1F-8039-0C58-7DA4-EE369C7428DB}"/>
           </ac:picMkLst>
         </pc:picChg>
       </pc:sldChg>
@@ -524,6 +433,3172 @@
     </pc:docChg>
   </pc:docChgLst>
 </pc:chgInfo>
+</file>
+
+<file path=ppt/diagrams/colors1.xml><?xml version="1.0" encoding="utf-8"?>
+<dgm:colorsDef xmlns:dgm="http://schemas.openxmlformats.org/drawingml/2006/diagram" xmlns:a="http://schemas.openxmlformats.org/drawingml/2006/main" uniqueId="urn:microsoft.com/office/officeart/2005/8/colors/accent1_2">
+  <dgm:title val=""/>
+  <dgm:desc val=""/>
+  <dgm:catLst>
+    <dgm:cat type="accent1" pri="11200"/>
+  </dgm:catLst>
+  <dgm:styleLbl name="node0">
+    <dgm:fillClrLst meth="repeat">
+      <a:schemeClr val="accent1"/>
+    </dgm:fillClrLst>
+    <dgm:linClrLst meth="repeat">
+      <a:schemeClr val="lt1"/>
+    </dgm:linClrLst>
+    <dgm:effectClrLst/>
+    <dgm:txLinClrLst/>
+    <dgm:txFillClrLst/>
+    <dgm:txEffectClrLst/>
+  </dgm:styleLbl>
+  <dgm:styleLbl name="alignNode1">
+    <dgm:fillClrLst meth="repeat">
+      <a:schemeClr val="accent1"/>
+    </dgm:fillClrLst>
+    <dgm:linClrLst meth="repeat">
+      <a:schemeClr val="accent1"/>
+    </dgm:linClrLst>
+    <dgm:effectClrLst/>
+    <dgm:txLinClrLst/>
+    <dgm:txFillClrLst/>
+    <dgm:txEffectClrLst/>
+  </dgm:styleLbl>
+  <dgm:styleLbl name="node1">
+    <dgm:fillClrLst meth="repeat">
+      <a:schemeClr val="accent1"/>
+    </dgm:fillClrLst>
+    <dgm:linClrLst meth="repeat">
+      <a:schemeClr val="lt1"/>
+    </dgm:linClrLst>
+    <dgm:effectClrLst/>
+    <dgm:txLinClrLst/>
+    <dgm:txFillClrLst/>
+    <dgm:txEffectClrLst/>
+  </dgm:styleLbl>
+  <dgm:styleLbl name="lnNode1">
+    <dgm:fillClrLst meth="repeat">
+      <a:schemeClr val="accent1"/>
+    </dgm:fillClrLst>
+    <dgm:linClrLst meth="repeat">
+      <a:schemeClr val="lt1"/>
+    </dgm:linClrLst>
+    <dgm:effectClrLst/>
+    <dgm:txLinClrLst/>
+    <dgm:txFillClrLst/>
+    <dgm:txEffectClrLst/>
+  </dgm:styleLbl>
+  <dgm:styleLbl name="vennNode1">
+    <dgm:fillClrLst meth="repeat">
+      <a:schemeClr val="accent1">
+        <a:alpha val="50000"/>
+      </a:schemeClr>
+    </dgm:fillClrLst>
+    <dgm:linClrLst meth="repeat">
+      <a:schemeClr val="lt1"/>
+    </dgm:linClrLst>
+    <dgm:effectClrLst/>
+    <dgm:txLinClrLst/>
+    <dgm:txFillClrLst/>
+    <dgm:txEffectClrLst/>
+  </dgm:styleLbl>
+  <dgm:styleLbl name="node2">
+    <dgm:fillClrLst meth="repeat">
+      <a:schemeClr val="accent1"/>
+    </dgm:fillClrLst>
+    <dgm:linClrLst meth="repeat">
+      <a:schemeClr val="lt1"/>
+    </dgm:linClrLst>
+    <dgm:effectClrLst/>
+    <dgm:txLinClrLst/>
+    <dgm:txFillClrLst/>
+    <dgm:txEffectClrLst/>
+  </dgm:styleLbl>
+  <dgm:styleLbl name="node3">
+    <dgm:fillClrLst meth="repeat">
+      <a:schemeClr val="accent1"/>
+    </dgm:fillClrLst>
+    <dgm:linClrLst meth="repeat">
+      <a:schemeClr val="lt1"/>
+    </dgm:linClrLst>
+    <dgm:effectClrLst/>
+    <dgm:txLinClrLst/>
+    <dgm:txFillClrLst/>
+    <dgm:txEffectClrLst/>
+  </dgm:styleLbl>
+  <dgm:styleLbl name="node4">
+    <dgm:fillClrLst meth="repeat">
+      <a:schemeClr val="accent1"/>
+    </dgm:fillClrLst>
+    <dgm:linClrLst meth="repeat">
+      <a:schemeClr val="lt1"/>
+    </dgm:linClrLst>
+    <dgm:effectClrLst/>
+    <dgm:txLinClrLst/>
+    <dgm:txFillClrLst/>
+    <dgm:txEffectClrLst/>
+  </dgm:styleLbl>
+  <dgm:styleLbl name="fgImgPlace1">
+    <dgm:fillClrLst meth="repeat">
+      <a:schemeClr val="accent1">
+        <a:tint val="50000"/>
+      </a:schemeClr>
+    </dgm:fillClrLst>
+    <dgm:linClrLst meth="repeat">
+      <a:schemeClr val="lt1"/>
+    </dgm:linClrLst>
+    <dgm:effectClrLst/>
+    <dgm:txLinClrLst/>
+    <dgm:txFillClrLst meth="repeat">
+      <a:schemeClr val="lt1"/>
+    </dgm:txFillClrLst>
+    <dgm:txEffectClrLst/>
+  </dgm:styleLbl>
+  <dgm:styleLbl name="alignImgPlace1">
+    <dgm:fillClrLst meth="repeat">
+      <a:schemeClr val="accent1">
+        <a:tint val="50000"/>
+      </a:schemeClr>
+    </dgm:fillClrLst>
+    <dgm:linClrLst meth="repeat">
+      <a:schemeClr val="lt1"/>
+    </dgm:linClrLst>
+    <dgm:effectClrLst/>
+    <dgm:txLinClrLst/>
+    <dgm:txFillClrLst meth="repeat">
+      <a:schemeClr val="lt1"/>
+    </dgm:txFillClrLst>
+    <dgm:txEffectClrLst/>
+  </dgm:styleLbl>
+  <dgm:styleLbl name="bgImgPlace1">
+    <dgm:fillClrLst meth="repeat">
+      <a:schemeClr val="accent1">
+        <a:tint val="50000"/>
+      </a:schemeClr>
+    </dgm:fillClrLst>
+    <dgm:linClrLst meth="repeat">
+      <a:schemeClr val="lt1"/>
+    </dgm:linClrLst>
+    <dgm:effectClrLst/>
+    <dgm:txLinClrLst/>
+    <dgm:txFillClrLst meth="repeat">
+      <a:schemeClr val="lt1"/>
+    </dgm:txFillClrLst>
+    <dgm:txEffectClrLst/>
+  </dgm:styleLbl>
+  <dgm:styleLbl name="sibTrans2D1">
+    <dgm:fillClrLst meth="repeat">
+      <a:schemeClr val="accent1">
+        <a:tint val="60000"/>
+      </a:schemeClr>
+    </dgm:fillClrLst>
+    <dgm:linClrLst meth="repeat">
+      <a:schemeClr val="accent1">
+        <a:tint val="60000"/>
+      </a:schemeClr>
+    </dgm:linClrLst>
+    <dgm:effectClrLst/>
+    <dgm:txLinClrLst/>
+    <dgm:txFillClrLst/>
+    <dgm:txEffectClrLst/>
+  </dgm:styleLbl>
+  <dgm:styleLbl name="fgSibTrans2D1">
+    <dgm:fillClrLst meth="repeat">
+      <a:schemeClr val="accent1">
+        <a:tint val="60000"/>
+      </a:schemeClr>
+    </dgm:fillClrLst>
+    <dgm:linClrLst meth="repeat">
+      <a:schemeClr val="accent1">
+        <a:tint val="60000"/>
+      </a:schemeClr>
+    </dgm:linClrLst>
+    <dgm:effectClrLst/>
+    <dgm:txLinClrLst/>
+    <dgm:txFillClrLst/>
+    <dgm:txEffectClrLst/>
+  </dgm:styleLbl>
+  <dgm:styleLbl name="bgSibTrans2D1">
+    <dgm:fillClrLst meth="repeat">
+      <a:schemeClr val="accent1">
+        <a:tint val="60000"/>
+      </a:schemeClr>
+    </dgm:fillClrLst>
+    <dgm:linClrLst meth="repeat">
+      <a:schemeClr val="accent1">
+        <a:tint val="60000"/>
+      </a:schemeClr>
+    </dgm:linClrLst>
+    <dgm:effectClrLst/>
+    <dgm:txLinClrLst/>
+    <dgm:txFillClrLst/>
+    <dgm:txEffectClrLst/>
+  </dgm:styleLbl>
+  <dgm:styleLbl name="sibTrans1D1">
+    <dgm:fillClrLst meth="repeat">
+      <a:schemeClr val="accent1"/>
+    </dgm:fillClrLst>
+    <dgm:linClrLst meth="repeat">
+      <a:schemeClr val="accent1"/>
+    </dgm:linClrLst>
+    <dgm:effectClrLst/>
+    <dgm:txLinClrLst/>
+    <dgm:txFillClrLst meth="repeat">
+      <a:schemeClr val="tx1"/>
+    </dgm:txFillClrLst>
+    <dgm:txEffectClrLst/>
+  </dgm:styleLbl>
+  <dgm:styleLbl name="callout">
+    <dgm:fillClrLst meth="repeat">
+      <a:schemeClr val="accent1"/>
+    </dgm:fillClrLst>
+    <dgm:linClrLst meth="repeat">
+      <a:schemeClr val="accent1">
+        <a:tint val="50000"/>
+      </a:schemeClr>
+    </dgm:linClrLst>
+    <dgm:effectClrLst/>
+    <dgm:txLinClrLst/>
+    <dgm:txFillClrLst meth="repeat">
+      <a:schemeClr val="tx1"/>
+    </dgm:txFillClrLst>
+    <dgm:txEffectClrLst/>
+  </dgm:styleLbl>
+  <dgm:styleLbl name="asst0">
+    <dgm:fillClrLst meth="repeat">
+      <a:schemeClr val="accent1"/>
+    </dgm:fillClrLst>
+    <dgm:linClrLst meth="repeat">
+      <a:schemeClr val="lt1"/>
+    </dgm:linClrLst>
+    <dgm:effectClrLst/>
+    <dgm:txLinClrLst/>
+    <dgm:txFillClrLst/>
+    <dgm:txEffectClrLst/>
+  </dgm:styleLbl>
+  <dgm:styleLbl name="asst1">
+    <dgm:fillClrLst meth="repeat">
+      <a:schemeClr val="accent1"/>
+    </dgm:fillClrLst>
+    <dgm:linClrLst meth="repeat">
+      <a:schemeClr val="lt1"/>
+    </dgm:linClrLst>
+    <dgm:effectClrLst/>
+    <dgm:txLinClrLst/>
+    <dgm:txFillClrLst/>
+    <dgm:txEffectClrLst/>
+  </dgm:styleLbl>
+  <dgm:styleLbl name="asst2">
+    <dgm:fillClrLst meth="repeat">
+      <a:schemeClr val="accent1"/>
+    </dgm:fillClrLst>
+    <dgm:linClrLst meth="repeat">
+      <a:schemeClr val="lt1"/>
+    </dgm:linClrLst>
+    <dgm:effectClrLst/>
+    <dgm:txLinClrLst/>
+    <dgm:txFillClrLst/>
+    <dgm:txEffectClrLst/>
+  </dgm:styleLbl>
+  <dgm:styleLbl name="asst3">
+    <dgm:fillClrLst meth="repeat">
+      <a:schemeClr val="accent1"/>
+    </dgm:fillClrLst>
+    <dgm:linClrLst meth="repeat">
+      <a:schemeClr val="lt1"/>
+    </dgm:linClrLst>
+    <dgm:effectClrLst/>
+    <dgm:txLinClrLst/>
+    <dgm:txFillClrLst/>
+    <dgm:txEffectClrLst/>
+  </dgm:styleLbl>
+  <dgm:styleLbl name="asst4">
+    <dgm:fillClrLst meth="repeat">
+      <a:schemeClr val="accent1"/>
+    </dgm:fillClrLst>
+    <dgm:linClrLst meth="repeat">
+      <a:schemeClr val="lt1"/>
+    </dgm:linClrLst>
+    <dgm:effectClrLst/>
+    <dgm:txLinClrLst/>
+    <dgm:txFillClrLst/>
+    <dgm:txEffectClrLst/>
+  </dgm:styleLbl>
+  <dgm:styleLbl name="parChTrans2D1">
+    <dgm:fillClrLst meth="repeat">
+      <a:schemeClr val="accent1">
+        <a:tint val="60000"/>
+      </a:schemeClr>
+    </dgm:fillClrLst>
+    <dgm:linClrLst meth="repeat">
+      <a:schemeClr val="accent1">
+        <a:tint val="60000"/>
+      </a:schemeClr>
+    </dgm:linClrLst>
+    <dgm:effectClrLst/>
+    <dgm:txLinClrLst/>
+    <dgm:txFillClrLst meth="repeat">
+      <a:schemeClr val="lt1"/>
+    </dgm:txFillClrLst>
+    <dgm:txEffectClrLst/>
+  </dgm:styleLbl>
+  <dgm:styleLbl name="parChTrans2D2">
+    <dgm:fillClrLst meth="repeat">
+      <a:schemeClr val="accent1"/>
+    </dgm:fillClrLst>
+    <dgm:linClrLst meth="repeat">
+      <a:schemeClr val="accent1"/>
+    </dgm:linClrLst>
+    <dgm:effectClrLst/>
+    <dgm:txLinClrLst/>
+    <dgm:txFillClrLst meth="repeat">
+      <a:schemeClr val="lt1"/>
+    </dgm:txFillClrLst>
+    <dgm:txEffectClrLst/>
+  </dgm:styleLbl>
+  <dgm:styleLbl name="parChTrans2D3">
+    <dgm:fillClrLst meth="repeat">
+      <a:schemeClr val="accent1"/>
+    </dgm:fillClrLst>
+    <dgm:linClrLst meth="repeat">
+      <a:schemeClr val="accent1"/>
+    </dgm:linClrLst>
+    <dgm:effectClrLst/>
+    <dgm:txLinClrLst/>
+    <dgm:txFillClrLst meth="repeat">
+      <a:schemeClr val="lt1"/>
+    </dgm:txFillClrLst>
+    <dgm:txEffectClrLst/>
+  </dgm:styleLbl>
+  <dgm:styleLbl name="parChTrans2D4">
+    <dgm:fillClrLst meth="repeat">
+      <a:schemeClr val="accent1"/>
+    </dgm:fillClrLst>
+    <dgm:linClrLst meth="repeat">
+      <a:schemeClr val="accent1"/>
+    </dgm:linClrLst>
+    <dgm:effectClrLst/>
+    <dgm:txLinClrLst/>
+    <dgm:txFillClrLst meth="repeat">
+      <a:schemeClr val="lt1"/>
+    </dgm:txFillClrLst>
+    <dgm:txEffectClrLst/>
+  </dgm:styleLbl>
+  <dgm:styleLbl name="parChTrans1D1">
+    <dgm:fillClrLst meth="repeat">
+      <a:schemeClr val="accent1"/>
+    </dgm:fillClrLst>
+    <dgm:linClrLst meth="repeat">
+      <a:schemeClr val="accent1">
+        <a:shade val="60000"/>
+      </a:schemeClr>
+    </dgm:linClrLst>
+    <dgm:effectClrLst/>
+    <dgm:txLinClrLst/>
+    <dgm:txFillClrLst meth="repeat">
+      <a:schemeClr val="tx1"/>
+    </dgm:txFillClrLst>
+    <dgm:txEffectClrLst/>
+  </dgm:styleLbl>
+  <dgm:styleLbl name="parChTrans1D2">
+    <dgm:fillClrLst meth="repeat">
+      <a:schemeClr val="accent1"/>
+    </dgm:fillClrLst>
+    <dgm:linClrLst meth="repeat">
+      <a:schemeClr val="accent1">
+        <a:shade val="60000"/>
+      </a:schemeClr>
+    </dgm:linClrLst>
+    <dgm:effectClrLst/>
+    <dgm:txLinClrLst/>
+    <dgm:txFillClrLst meth="repeat">
+      <a:schemeClr val="tx1"/>
+    </dgm:txFillClrLst>
+    <dgm:txEffectClrLst/>
+  </dgm:styleLbl>
+  <dgm:styleLbl name="parChTrans1D3">
+    <dgm:fillClrLst meth="repeat">
+      <a:schemeClr val="accent1"/>
+    </dgm:fillClrLst>
+    <dgm:linClrLst meth="repeat">
+      <a:schemeClr val="accent1">
+        <a:shade val="80000"/>
+      </a:schemeClr>
+    </dgm:linClrLst>
+    <dgm:effectClrLst/>
+    <dgm:txLinClrLst/>
+    <dgm:txFillClrLst meth="repeat">
+      <a:schemeClr val="tx1"/>
+    </dgm:txFillClrLst>
+    <dgm:txEffectClrLst/>
+  </dgm:styleLbl>
+  <dgm:styleLbl name="parChTrans1D4">
+    <dgm:fillClrLst meth="repeat">
+      <a:schemeClr val="accent1"/>
+    </dgm:fillClrLst>
+    <dgm:linClrLst meth="repeat">
+      <a:schemeClr val="accent1">
+        <a:shade val="80000"/>
+      </a:schemeClr>
+    </dgm:linClrLst>
+    <dgm:effectClrLst/>
+    <dgm:txLinClrLst/>
+    <dgm:txFillClrLst meth="repeat">
+      <a:schemeClr val="tx1"/>
+    </dgm:txFillClrLst>
+    <dgm:txEffectClrLst/>
+  </dgm:styleLbl>
+  <dgm:styleLbl name="fgAcc1">
+    <dgm:fillClrLst meth="repeat">
+      <a:schemeClr val="lt1">
+        <a:alpha val="90000"/>
+      </a:schemeClr>
+    </dgm:fillClrLst>
+    <dgm:linClrLst meth="repeat">
+      <a:schemeClr val="accent1"/>
+    </dgm:linClrLst>
+    <dgm:effectClrLst/>
+    <dgm:txLinClrLst/>
+    <dgm:txFillClrLst meth="repeat">
+      <a:schemeClr val="dk1"/>
+    </dgm:txFillClrLst>
+    <dgm:txEffectClrLst/>
+  </dgm:styleLbl>
+  <dgm:styleLbl name="conFgAcc1">
+    <dgm:fillClrLst meth="repeat">
+      <a:schemeClr val="lt1">
+        <a:alpha val="90000"/>
+      </a:schemeClr>
+    </dgm:fillClrLst>
+    <dgm:linClrLst meth="repeat">
+      <a:schemeClr val="accent1"/>
+    </dgm:linClrLst>
+    <dgm:effectClrLst/>
+    <dgm:txLinClrLst/>
+    <dgm:txFillClrLst meth="repeat">
+      <a:schemeClr val="dk1"/>
+    </dgm:txFillClrLst>
+    <dgm:txEffectClrLst/>
+  </dgm:styleLbl>
+  <dgm:styleLbl name="alignAcc1">
+    <dgm:fillClrLst meth="repeat">
+      <a:schemeClr val="lt1">
+        <a:alpha val="90000"/>
+      </a:schemeClr>
+    </dgm:fillClrLst>
+    <dgm:linClrLst meth="repeat">
+      <a:schemeClr val="accent1"/>
+    </dgm:linClrLst>
+    <dgm:effectClrLst/>
+    <dgm:txLinClrLst/>
+    <dgm:txFillClrLst meth="repeat">
+      <a:schemeClr val="dk1"/>
+    </dgm:txFillClrLst>
+    <dgm:txEffectClrLst/>
+  </dgm:styleLbl>
+  <dgm:styleLbl name="trAlignAcc1">
+    <dgm:fillClrLst meth="repeat">
+      <a:schemeClr val="lt1">
+        <a:alpha val="40000"/>
+      </a:schemeClr>
+    </dgm:fillClrLst>
+    <dgm:linClrLst meth="repeat">
+      <a:schemeClr val="accent1"/>
+    </dgm:linClrLst>
+    <dgm:effectClrLst/>
+    <dgm:txLinClrLst/>
+    <dgm:txFillClrLst meth="repeat">
+      <a:schemeClr val="dk1"/>
+    </dgm:txFillClrLst>
+    <dgm:txEffectClrLst/>
+  </dgm:styleLbl>
+  <dgm:styleLbl name="bgAcc1">
+    <dgm:fillClrLst meth="repeat">
+      <a:schemeClr val="lt1">
+        <a:alpha val="90000"/>
+      </a:schemeClr>
+    </dgm:fillClrLst>
+    <dgm:linClrLst meth="repeat">
+      <a:schemeClr val="accent1"/>
+    </dgm:linClrLst>
+    <dgm:effectClrLst/>
+    <dgm:txLinClrLst/>
+    <dgm:txFillClrLst meth="repeat">
+      <a:schemeClr val="dk1"/>
+    </dgm:txFillClrLst>
+    <dgm:txEffectClrLst/>
+  </dgm:styleLbl>
+  <dgm:styleLbl name="solidFgAcc1">
+    <dgm:fillClrLst meth="repeat">
+      <a:schemeClr val="lt1"/>
+    </dgm:fillClrLst>
+    <dgm:linClrLst meth="repeat">
+      <a:schemeClr val="accent1"/>
+    </dgm:linClrLst>
+    <dgm:effectClrLst/>
+    <dgm:txLinClrLst/>
+    <dgm:txFillClrLst meth="repeat">
+      <a:schemeClr val="dk1"/>
+    </dgm:txFillClrLst>
+    <dgm:txEffectClrLst/>
+  </dgm:styleLbl>
+  <dgm:styleLbl name="solidAlignAcc1">
+    <dgm:fillClrLst meth="repeat">
+      <a:schemeClr val="lt1"/>
+    </dgm:fillClrLst>
+    <dgm:linClrLst meth="repeat">
+      <a:schemeClr val="accent1"/>
+    </dgm:linClrLst>
+    <dgm:effectClrLst/>
+    <dgm:txLinClrLst/>
+    <dgm:txFillClrLst meth="repeat">
+      <a:schemeClr val="dk1"/>
+    </dgm:txFillClrLst>
+    <dgm:txEffectClrLst/>
+  </dgm:styleLbl>
+  <dgm:styleLbl name="solidBgAcc1">
+    <dgm:fillClrLst meth="repeat">
+      <a:schemeClr val="lt1"/>
+    </dgm:fillClrLst>
+    <dgm:linClrLst meth="repeat">
+      <a:schemeClr val="accent1"/>
+    </dgm:linClrLst>
+    <dgm:effectClrLst/>
+    <dgm:txLinClrLst/>
+    <dgm:txFillClrLst meth="repeat">
+      <a:schemeClr val="dk1"/>
+    </dgm:txFillClrLst>
+    <dgm:txEffectClrLst/>
+  </dgm:styleLbl>
+  <dgm:styleLbl name="fgAccFollowNode1">
+    <dgm:fillClrLst meth="repeat">
+      <a:schemeClr val="accent1">
+        <a:alpha val="90000"/>
+        <a:tint val="40000"/>
+      </a:schemeClr>
+    </dgm:fillClrLst>
+    <dgm:linClrLst meth="repeat">
+      <a:schemeClr val="accent1">
+        <a:alpha val="90000"/>
+        <a:tint val="40000"/>
+      </a:schemeClr>
+    </dgm:linClrLst>
+    <dgm:effectClrLst/>
+    <dgm:txLinClrLst/>
+    <dgm:txFillClrLst meth="repeat">
+      <a:schemeClr val="dk1"/>
+    </dgm:txFillClrLst>
+    <dgm:txEffectClrLst/>
+  </dgm:styleLbl>
+  <dgm:styleLbl name="alignAccFollowNode1">
+    <dgm:fillClrLst meth="repeat">
+      <a:schemeClr val="accent1">
+        <a:alpha val="90000"/>
+        <a:tint val="40000"/>
+      </a:schemeClr>
+    </dgm:fillClrLst>
+    <dgm:linClrLst meth="repeat">
+      <a:schemeClr val="accent1">
+        <a:alpha val="90000"/>
+        <a:tint val="40000"/>
+      </a:schemeClr>
+    </dgm:linClrLst>
+    <dgm:effectClrLst/>
+    <dgm:txLinClrLst/>
+    <dgm:txFillClrLst meth="repeat">
+      <a:schemeClr val="dk1"/>
+    </dgm:txFillClrLst>
+    <dgm:txEffectClrLst/>
+  </dgm:styleLbl>
+  <dgm:styleLbl name="bgAccFollowNode1">
+    <dgm:fillClrLst meth="repeat">
+      <a:schemeClr val="accent1">
+        <a:alpha val="90000"/>
+        <a:tint val="40000"/>
+      </a:schemeClr>
+    </dgm:fillClrLst>
+    <dgm:linClrLst meth="repeat">
+      <a:schemeClr val="accent1">
+        <a:alpha val="90000"/>
+        <a:tint val="40000"/>
+      </a:schemeClr>
+    </dgm:linClrLst>
+    <dgm:effectClrLst/>
+    <dgm:txLinClrLst/>
+    <dgm:txFillClrLst meth="repeat">
+      <a:schemeClr val="dk1"/>
+    </dgm:txFillClrLst>
+    <dgm:txEffectClrLst/>
+  </dgm:styleLbl>
+  <dgm:styleLbl name="fgAcc0">
+    <dgm:fillClrLst meth="repeat">
+      <a:schemeClr val="lt1">
+        <a:alpha val="90000"/>
+      </a:schemeClr>
+    </dgm:fillClrLst>
+    <dgm:linClrLst meth="repeat">
+      <a:schemeClr val="accent1"/>
+    </dgm:linClrLst>
+    <dgm:effectClrLst/>
+    <dgm:txLinClrLst/>
+    <dgm:txFillClrLst meth="repeat">
+      <a:schemeClr val="dk1"/>
+    </dgm:txFillClrLst>
+    <dgm:txEffectClrLst/>
+  </dgm:styleLbl>
+  <dgm:styleLbl name="fgAcc2">
+    <dgm:fillClrLst meth="repeat">
+      <a:schemeClr val="lt1">
+        <a:alpha val="90000"/>
+      </a:schemeClr>
+    </dgm:fillClrLst>
+    <dgm:linClrLst meth="repeat">
+      <a:schemeClr val="accent1"/>
+    </dgm:linClrLst>
+    <dgm:effectClrLst/>
+    <dgm:txLinClrLst/>
+    <dgm:txFillClrLst meth="repeat">
+      <a:schemeClr val="dk1"/>
+    </dgm:txFillClrLst>
+    <dgm:txEffectClrLst/>
+  </dgm:styleLbl>
+  <dgm:styleLbl name="fgAcc3">
+    <dgm:fillClrLst meth="repeat">
+      <a:schemeClr val="lt1">
+        <a:alpha val="90000"/>
+      </a:schemeClr>
+    </dgm:fillClrLst>
+    <dgm:linClrLst meth="repeat">
+      <a:schemeClr val="accent1"/>
+    </dgm:linClrLst>
+    <dgm:effectClrLst/>
+    <dgm:txLinClrLst/>
+    <dgm:txFillClrLst meth="repeat">
+      <a:schemeClr val="dk1"/>
+    </dgm:txFillClrLst>
+    <dgm:txEffectClrLst/>
+  </dgm:styleLbl>
+  <dgm:styleLbl name="fgAcc4">
+    <dgm:fillClrLst meth="repeat">
+      <a:schemeClr val="lt1">
+        <a:alpha val="90000"/>
+      </a:schemeClr>
+    </dgm:fillClrLst>
+    <dgm:linClrLst meth="repeat">
+      <a:schemeClr val="accent1"/>
+    </dgm:linClrLst>
+    <dgm:effectClrLst/>
+    <dgm:txLinClrLst/>
+    <dgm:txFillClrLst meth="repeat">
+      <a:schemeClr val="dk1"/>
+    </dgm:txFillClrLst>
+    <dgm:txEffectClrLst/>
+  </dgm:styleLbl>
+  <dgm:styleLbl name="bgShp">
+    <dgm:fillClrLst meth="repeat">
+      <a:schemeClr val="accent1">
+        <a:tint val="40000"/>
+      </a:schemeClr>
+    </dgm:fillClrLst>
+    <dgm:linClrLst meth="repeat">
+      <a:schemeClr val="accent1"/>
+    </dgm:linClrLst>
+    <dgm:effectClrLst/>
+    <dgm:txLinClrLst/>
+    <dgm:txFillClrLst meth="repeat">
+      <a:schemeClr val="dk1"/>
+    </dgm:txFillClrLst>
+    <dgm:txEffectClrLst/>
+  </dgm:styleLbl>
+  <dgm:styleLbl name="dkBgShp">
+    <dgm:fillClrLst meth="repeat">
+      <a:schemeClr val="accent1">
+        <a:shade val="80000"/>
+      </a:schemeClr>
+    </dgm:fillClrLst>
+    <dgm:linClrLst meth="repeat">
+      <a:schemeClr val="accent1"/>
+    </dgm:linClrLst>
+    <dgm:effectClrLst/>
+    <dgm:txLinClrLst/>
+    <dgm:txFillClrLst meth="repeat">
+      <a:schemeClr val="lt1"/>
+    </dgm:txFillClrLst>
+    <dgm:txEffectClrLst/>
+  </dgm:styleLbl>
+  <dgm:styleLbl name="trBgShp">
+    <dgm:fillClrLst meth="repeat">
+      <a:schemeClr val="accent1">
+        <a:tint val="50000"/>
+        <a:alpha val="40000"/>
+      </a:schemeClr>
+    </dgm:fillClrLst>
+    <dgm:linClrLst meth="repeat">
+      <a:schemeClr val="accent1"/>
+    </dgm:linClrLst>
+    <dgm:effectClrLst/>
+    <dgm:txLinClrLst/>
+    <dgm:txFillClrLst meth="repeat">
+      <a:schemeClr val="lt1"/>
+    </dgm:txFillClrLst>
+    <dgm:txEffectClrLst/>
+  </dgm:styleLbl>
+  <dgm:styleLbl name="fgShp">
+    <dgm:fillClrLst meth="repeat">
+      <a:schemeClr val="accent1">
+        <a:tint val="60000"/>
+      </a:schemeClr>
+    </dgm:fillClrLst>
+    <dgm:linClrLst meth="repeat">
+      <a:schemeClr val="lt1"/>
+    </dgm:linClrLst>
+    <dgm:effectClrLst/>
+    <dgm:txLinClrLst/>
+    <dgm:txFillClrLst meth="repeat">
+      <a:schemeClr val="dk1"/>
+    </dgm:txFillClrLst>
+    <dgm:txEffectClrLst/>
+  </dgm:styleLbl>
+  <dgm:styleLbl name="revTx">
+    <dgm:fillClrLst meth="repeat">
+      <a:schemeClr val="lt1">
+        <a:alpha val="0"/>
+      </a:schemeClr>
+    </dgm:fillClrLst>
+    <dgm:linClrLst meth="repeat">
+      <a:schemeClr val="dk1">
+        <a:alpha val="0"/>
+      </a:schemeClr>
+    </dgm:linClrLst>
+    <dgm:effectClrLst/>
+    <dgm:txLinClrLst/>
+    <dgm:txFillClrLst meth="repeat">
+      <a:schemeClr val="tx1"/>
+    </dgm:txFillClrLst>
+    <dgm:txEffectClrLst/>
+  </dgm:styleLbl>
+</dgm:colorsDef>
+</file>
+
+<file path=ppt/diagrams/data1.xml><?xml version="1.0" encoding="utf-8"?>
+<dgm:dataModel xmlns:dgm="http://schemas.openxmlformats.org/drawingml/2006/diagram" xmlns:a="http://schemas.openxmlformats.org/drawingml/2006/main">
+  <dgm:ptLst>
+    <dgm:pt modelId="{BF55CBDA-CFB4-41A2-B147-2688FD9105E9}" type="doc">
+      <dgm:prSet loTypeId="urn:microsoft.com/office/officeart/2005/8/layout/hierarchy4" loCatId="relationship" qsTypeId="urn:microsoft.com/office/officeart/2005/8/quickstyle/simple1" qsCatId="simple" csTypeId="urn:microsoft.com/office/officeart/2005/8/colors/accent1_2" csCatId="accent1" phldr="0"/>
+      <dgm:spPr/>
+      <dgm:t>
+        <a:bodyPr/>
+        <a:lstStyle/>
+        <a:p>
+          <a:endParaRPr lang="en-GB"/>
+        </a:p>
+      </dgm:t>
+    </dgm:pt>
+    <dgm:pt modelId="{9EBACEE9-4484-40AE-B42A-0EE8E0D86C00}">
+      <dgm:prSet phldrT="[Text]" phldr="1"/>
+      <dgm:spPr/>
+      <dgm:t>
+        <a:bodyPr/>
+        <a:lstStyle/>
+        <a:p>
+          <a:endParaRPr lang="en-GB"/>
+        </a:p>
+      </dgm:t>
+    </dgm:pt>
+    <dgm:pt modelId="{BA67CDFE-77AF-4A8C-88EC-55B1BF1BA6EF}" type="parTrans" cxnId="{8579115E-8B96-4CE3-834A-ED4E162D50AC}">
+      <dgm:prSet/>
+      <dgm:spPr/>
+      <dgm:t>
+        <a:bodyPr/>
+        <a:lstStyle/>
+        <a:p>
+          <a:endParaRPr lang="en-GB"/>
+        </a:p>
+      </dgm:t>
+    </dgm:pt>
+    <dgm:pt modelId="{1A3FDFEC-117C-437F-84C3-479D08B1EE10}" type="sibTrans" cxnId="{8579115E-8B96-4CE3-834A-ED4E162D50AC}">
+      <dgm:prSet/>
+      <dgm:spPr/>
+      <dgm:t>
+        <a:bodyPr/>
+        <a:lstStyle/>
+        <a:p>
+          <a:endParaRPr lang="en-GB"/>
+        </a:p>
+      </dgm:t>
+    </dgm:pt>
+    <dgm:pt modelId="{A0F92E95-5464-47FC-A521-3B5754D48AB0}">
+      <dgm:prSet phldrT="[Text]" phldr="1"/>
+      <dgm:spPr/>
+      <dgm:t>
+        <a:bodyPr/>
+        <a:lstStyle/>
+        <a:p>
+          <a:endParaRPr lang="en-GB"/>
+        </a:p>
+      </dgm:t>
+    </dgm:pt>
+    <dgm:pt modelId="{1C5F4AA3-95AA-498E-994E-8435CC0A25DC}" type="parTrans" cxnId="{AFEF8102-3DA8-454C-BDF5-0AC9FE062DB2}">
+      <dgm:prSet/>
+      <dgm:spPr/>
+      <dgm:t>
+        <a:bodyPr/>
+        <a:lstStyle/>
+        <a:p>
+          <a:endParaRPr lang="en-GB"/>
+        </a:p>
+      </dgm:t>
+    </dgm:pt>
+    <dgm:pt modelId="{AAF527B9-6913-4441-AFD4-B1E5D8EE0B28}" type="sibTrans" cxnId="{AFEF8102-3DA8-454C-BDF5-0AC9FE062DB2}">
+      <dgm:prSet/>
+      <dgm:spPr/>
+      <dgm:t>
+        <a:bodyPr/>
+        <a:lstStyle/>
+        <a:p>
+          <a:endParaRPr lang="en-GB"/>
+        </a:p>
+      </dgm:t>
+    </dgm:pt>
+    <dgm:pt modelId="{62F8C152-76C8-42D0-B3DE-D4905309402B}">
+      <dgm:prSet phldrT="[Text]" phldr="1"/>
+      <dgm:spPr/>
+      <dgm:t>
+        <a:bodyPr/>
+        <a:lstStyle/>
+        <a:p>
+          <a:endParaRPr lang="en-GB"/>
+        </a:p>
+      </dgm:t>
+    </dgm:pt>
+    <dgm:pt modelId="{4D48D1F2-7912-4695-9B71-E818361355FA}" type="parTrans" cxnId="{EFB0AD94-F900-4812-AEA7-A61F1BC3E761}">
+      <dgm:prSet/>
+      <dgm:spPr/>
+      <dgm:t>
+        <a:bodyPr/>
+        <a:lstStyle/>
+        <a:p>
+          <a:endParaRPr lang="en-GB"/>
+        </a:p>
+      </dgm:t>
+    </dgm:pt>
+    <dgm:pt modelId="{7899B6D5-4D10-45C4-AE67-E250823E82D6}" type="sibTrans" cxnId="{EFB0AD94-F900-4812-AEA7-A61F1BC3E761}">
+      <dgm:prSet/>
+      <dgm:spPr/>
+      <dgm:t>
+        <a:bodyPr/>
+        <a:lstStyle/>
+        <a:p>
+          <a:endParaRPr lang="en-GB"/>
+        </a:p>
+      </dgm:t>
+    </dgm:pt>
+    <dgm:pt modelId="{ED0B512D-A516-41B0-A1B4-D198DC3373AF}">
+      <dgm:prSet phldrT="[Text]" phldr="1"/>
+      <dgm:spPr/>
+      <dgm:t>
+        <a:bodyPr/>
+        <a:lstStyle/>
+        <a:p>
+          <a:endParaRPr lang="en-GB"/>
+        </a:p>
+      </dgm:t>
+    </dgm:pt>
+    <dgm:pt modelId="{773955EF-4E3F-4E8A-9449-B285C01ACC6F}" type="parTrans" cxnId="{C26A2F9D-D589-4E6F-8261-F46B398D2C15}">
+      <dgm:prSet/>
+      <dgm:spPr/>
+      <dgm:t>
+        <a:bodyPr/>
+        <a:lstStyle/>
+        <a:p>
+          <a:endParaRPr lang="en-GB"/>
+        </a:p>
+      </dgm:t>
+    </dgm:pt>
+    <dgm:pt modelId="{60B79A70-0116-452C-9F00-FC400C62BA02}" type="sibTrans" cxnId="{C26A2F9D-D589-4E6F-8261-F46B398D2C15}">
+      <dgm:prSet/>
+      <dgm:spPr/>
+      <dgm:t>
+        <a:bodyPr/>
+        <a:lstStyle/>
+        <a:p>
+          <a:endParaRPr lang="en-GB"/>
+        </a:p>
+      </dgm:t>
+    </dgm:pt>
+    <dgm:pt modelId="{2119E684-95D4-414B-B613-2F7A2AE41D3B}">
+      <dgm:prSet phldrT="[Text]" phldr="1"/>
+      <dgm:spPr/>
+      <dgm:t>
+        <a:bodyPr/>
+        <a:lstStyle/>
+        <a:p>
+          <a:endParaRPr lang="en-GB"/>
+        </a:p>
+      </dgm:t>
+    </dgm:pt>
+    <dgm:pt modelId="{50E796F8-72F2-432A-A0D1-FD25AAF3B40B}" type="parTrans" cxnId="{6D8931D0-1E2A-48B6-AA63-68770A4954D3}">
+      <dgm:prSet/>
+      <dgm:spPr/>
+      <dgm:t>
+        <a:bodyPr/>
+        <a:lstStyle/>
+        <a:p>
+          <a:endParaRPr lang="en-GB"/>
+        </a:p>
+      </dgm:t>
+    </dgm:pt>
+    <dgm:pt modelId="{382CE42E-D2BD-42FD-B8EF-E2BC0643C4BE}" type="sibTrans" cxnId="{6D8931D0-1E2A-48B6-AA63-68770A4954D3}">
+      <dgm:prSet/>
+      <dgm:spPr/>
+      <dgm:t>
+        <a:bodyPr/>
+        <a:lstStyle/>
+        <a:p>
+          <a:endParaRPr lang="en-GB"/>
+        </a:p>
+      </dgm:t>
+    </dgm:pt>
+    <dgm:pt modelId="{5344F3BC-69B7-46E5-A1D8-8321697D1EA9}">
+      <dgm:prSet phldrT="[Text]" phldr="1"/>
+      <dgm:spPr/>
+      <dgm:t>
+        <a:bodyPr/>
+        <a:lstStyle/>
+        <a:p>
+          <a:endParaRPr lang="en-GB"/>
+        </a:p>
+      </dgm:t>
+    </dgm:pt>
+    <dgm:pt modelId="{3C8338D5-6A06-4908-AD2C-013920092B4D}" type="parTrans" cxnId="{D588B49B-8FA7-4808-B95E-0201B851283E}">
+      <dgm:prSet/>
+      <dgm:spPr/>
+      <dgm:t>
+        <a:bodyPr/>
+        <a:lstStyle/>
+        <a:p>
+          <a:endParaRPr lang="en-GB"/>
+        </a:p>
+      </dgm:t>
+    </dgm:pt>
+    <dgm:pt modelId="{002FBC27-AB53-420F-ABFA-0475A4CFE521}" type="sibTrans" cxnId="{D588B49B-8FA7-4808-B95E-0201B851283E}">
+      <dgm:prSet/>
+      <dgm:spPr/>
+      <dgm:t>
+        <a:bodyPr/>
+        <a:lstStyle/>
+        <a:p>
+          <a:endParaRPr lang="en-GB"/>
+        </a:p>
+      </dgm:t>
+    </dgm:pt>
+    <dgm:pt modelId="{9620CF0C-6C1F-4CEB-BA70-47082C968EEB}" type="pres">
+      <dgm:prSet presAssocID="{BF55CBDA-CFB4-41A2-B147-2688FD9105E9}" presName="Name0" presStyleCnt="0">
+        <dgm:presLayoutVars>
+          <dgm:chPref val="1"/>
+          <dgm:dir/>
+          <dgm:animOne val="branch"/>
+          <dgm:animLvl val="lvl"/>
+          <dgm:resizeHandles/>
+        </dgm:presLayoutVars>
+      </dgm:prSet>
+      <dgm:spPr/>
+    </dgm:pt>
+    <dgm:pt modelId="{AD3417B4-2511-4C7E-8E17-8CC957C3E7C4}" type="pres">
+      <dgm:prSet presAssocID="{9EBACEE9-4484-40AE-B42A-0EE8E0D86C00}" presName="vertOne" presStyleCnt="0"/>
+      <dgm:spPr/>
+    </dgm:pt>
+    <dgm:pt modelId="{3F00401D-E535-44A7-B7DF-456F2E7C7E78}" type="pres">
+      <dgm:prSet presAssocID="{9EBACEE9-4484-40AE-B42A-0EE8E0D86C00}" presName="txOne" presStyleLbl="node0" presStyleIdx="0" presStyleCnt="1">
+        <dgm:presLayoutVars>
+          <dgm:chPref val="3"/>
+        </dgm:presLayoutVars>
+      </dgm:prSet>
+      <dgm:spPr/>
+    </dgm:pt>
+    <dgm:pt modelId="{514CF210-A163-4106-A036-FC4929863BDA}" type="pres">
+      <dgm:prSet presAssocID="{9EBACEE9-4484-40AE-B42A-0EE8E0D86C00}" presName="parTransOne" presStyleCnt="0"/>
+      <dgm:spPr/>
+    </dgm:pt>
+    <dgm:pt modelId="{18176594-7E51-4FBD-8023-92463CE355F4}" type="pres">
+      <dgm:prSet presAssocID="{9EBACEE9-4484-40AE-B42A-0EE8E0D86C00}" presName="horzOne" presStyleCnt="0"/>
+      <dgm:spPr/>
+    </dgm:pt>
+    <dgm:pt modelId="{CC7BA731-3936-4513-A726-33FFEBD1F0B5}" type="pres">
+      <dgm:prSet presAssocID="{A0F92E95-5464-47FC-A521-3B5754D48AB0}" presName="vertTwo" presStyleCnt="0"/>
+      <dgm:spPr/>
+    </dgm:pt>
+    <dgm:pt modelId="{EBC95740-427A-4774-B695-CA3B3288FFEF}" type="pres">
+      <dgm:prSet presAssocID="{A0F92E95-5464-47FC-A521-3B5754D48AB0}" presName="txTwo" presStyleLbl="node2" presStyleIdx="0" presStyleCnt="2">
+        <dgm:presLayoutVars>
+          <dgm:chPref val="3"/>
+        </dgm:presLayoutVars>
+      </dgm:prSet>
+      <dgm:spPr/>
+    </dgm:pt>
+    <dgm:pt modelId="{D276CA00-24A2-4A06-97D7-841152C70F94}" type="pres">
+      <dgm:prSet presAssocID="{A0F92E95-5464-47FC-A521-3B5754D48AB0}" presName="parTransTwo" presStyleCnt="0"/>
+      <dgm:spPr/>
+    </dgm:pt>
+    <dgm:pt modelId="{D9857921-84C4-4CF2-A2B1-ECA705DF9B9F}" type="pres">
+      <dgm:prSet presAssocID="{A0F92E95-5464-47FC-A521-3B5754D48AB0}" presName="horzTwo" presStyleCnt="0"/>
+      <dgm:spPr/>
+    </dgm:pt>
+    <dgm:pt modelId="{7E07DDE4-5E0F-450A-89E7-1A21B3E4D12C}" type="pres">
+      <dgm:prSet presAssocID="{62F8C152-76C8-42D0-B3DE-D4905309402B}" presName="vertThree" presStyleCnt="0"/>
+      <dgm:spPr/>
+    </dgm:pt>
+    <dgm:pt modelId="{4E4B5D82-F094-4117-BA5A-AE50309C681E}" type="pres">
+      <dgm:prSet presAssocID="{62F8C152-76C8-42D0-B3DE-D4905309402B}" presName="txThree" presStyleLbl="node3" presStyleIdx="0" presStyleCnt="3">
+        <dgm:presLayoutVars>
+          <dgm:chPref val="3"/>
+        </dgm:presLayoutVars>
+      </dgm:prSet>
+      <dgm:spPr/>
+    </dgm:pt>
+    <dgm:pt modelId="{57F1B384-16AC-4D48-AD7B-3E0AD804E0DA}" type="pres">
+      <dgm:prSet presAssocID="{62F8C152-76C8-42D0-B3DE-D4905309402B}" presName="horzThree" presStyleCnt="0"/>
+      <dgm:spPr/>
+    </dgm:pt>
+    <dgm:pt modelId="{06F41DF7-92F1-43D0-9FB1-7CA9953D0F8E}" type="pres">
+      <dgm:prSet presAssocID="{7899B6D5-4D10-45C4-AE67-E250823E82D6}" presName="sibSpaceThree" presStyleCnt="0"/>
+      <dgm:spPr/>
+    </dgm:pt>
+    <dgm:pt modelId="{9A085E36-0038-47A9-BD1B-E635AA5325A5}" type="pres">
+      <dgm:prSet presAssocID="{ED0B512D-A516-41B0-A1B4-D198DC3373AF}" presName="vertThree" presStyleCnt="0"/>
+      <dgm:spPr/>
+    </dgm:pt>
+    <dgm:pt modelId="{6ABD528C-1080-4F7A-B271-80FCE46B825C}" type="pres">
+      <dgm:prSet presAssocID="{ED0B512D-A516-41B0-A1B4-D198DC3373AF}" presName="txThree" presStyleLbl="node3" presStyleIdx="1" presStyleCnt="3">
+        <dgm:presLayoutVars>
+          <dgm:chPref val="3"/>
+        </dgm:presLayoutVars>
+      </dgm:prSet>
+      <dgm:spPr/>
+    </dgm:pt>
+    <dgm:pt modelId="{E1E518C9-A657-499E-A451-3B8367E98A2C}" type="pres">
+      <dgm:prSet presAssocID="{ED0B512D-A516-41B0-A1B4-D198DC3373AF}" presName="horzThree" presStyleCnt="0"/>
+      <dgm:spPr/>
+    </dgm:pt>
+    <dgm:pt modelId="{22A46785-CC93-4AD6-9BCB-B183CD74CCE1}" type="pres">
+      <dgm:prSet presAssocID="{AAF527B9-6913-4441-AFD4-B1E5D8EE0B28}" presName="sibSpaceTwo" presStyleCnt="0"/>
+      <dgm:spPr/>
+    </dgm:pt>
+    <dgm:pt modelId="{23B4ED7C-3B13-43C9-82B8-07F660EDC1BB}" type="pres">
+      <dgm:prSet presAssocID="{2119E684-95D4-414B-B613-2F7A2AE41D3B}" presName="vertTwo" presStyleCnt="0"/>
+      <dgm:spPr/>
+    </dgm:pt>
+    <dgm:pt modelId="{A44D9E7A-8498-41EB-9614-74C0C3D1AB15}" type="pres">
+      <dgm:prSet presAssocID="{2119E684-95D4-414B-B613-2F7A2AE41D3B}" presName="txTwo" presStyleLbl="node2" presStyleIdx="1" presStyleCnt="2">
+        <dgm:presLayoutVars>
+          <dgm:chPref val="3"/>
+        </dgm:presLayoutVars>
+      </dgm:prSet>
+      <dgm:spPr/>
+    </dgm:pt>
+    <dgm:pt modelId="{8BCA783A-E08D-4223-9033-BCCF92E9AC30}" type="pres">
+      <dgm:prSet presAssocID="{2119E684-95D4-414B-B613-2F7A2AE41D3B}" presName="parTransTwo" presStyleCnt="0"/>
+      <dgm:spPr/>
+    </dgm:pt>
+    <dgm:pt modelId="{F7D3704D-CB29-4DF3-AAAD-1F0CA35D4478}" type="pres">
+      <dgm:prSet presAssocID="{2119E684-95D4-414B-B613-2F7A2AE41D3B}" presName="horzTwo" presStyleCnt="0"/>
+      <dgm:spPr/>
+    </dgm:pt>
+    <dgm:pt modelId="{CEFD8B21-37D4-4CC5-B9E9-721F42A57CF1}" type="pres">
+      <dgm:prSet presAssocID="{5344F3BC-69B7-46E5-A1D8-8321697D1EA9}" presName="vertThree" presStyleCnt="0"/>
+      <dgm:spPr/>
+    </dgm:pt>
+    <dgm:pt modelId="{283550C5-8B28-461D-9657-9B2E07169954}" type="pres">
+      <dgm:prSet presAssocID="{5344F3BC-69B7-46E5-A1D8-8321697D1EA9}" presName="txThree" presStyleLbl="node3" presStyleIdx="2" presStyleCnt="3">
+        <dgm:presLayoutVars>
+          <dgm:chPref val="3"/>
+        </dgm:presLayoutVars>
+      </dgm:prSet>
+      <dgm:spPr/>
+    </dgm:pt>
+    <dgm:pt modelId="{B0A668E1-968E-4C26-81F9-6CFF85576F32}" type="pres">
+      <dgm:prSet presAssocID="{5344F3BC-69B7-46E5-A1D8-8321697D1EA9}" presName="horzThree" presStyleCnt="0"/>
+      <dgm:spPr/>
+    </dgm:pt>
+  </dgm:ptLst>
+  <dgm:cxnLst>
+    <dgm:cxn modelId="{AFEF8102-3DA8-454C-BDF5-0AC9FE062DB2}" srcId="{9EBACEE9-4484-40AE-B42A-0EE8E0D86C00}" destId="{A0F92E95-5464-47FC-A521-3B5754D48AB0}" srcOrd="0" destOrd="0" parTransId="{1C5F4AA3-95AA-498E-994E-8435CC0A25DC}" sibTransId="{AAF527B9-6913-4441-AFD4-B1E5D8EE0B28}"/>
+    <dgm:cxn modelId="{AE70B220-AB74-4BC2-B162-3C1BEDC326B9}" type="presOf" srcId="{A0F92E95-5464-47FC-A521-3B5754D48AB0}" destId="{EBC95740-427A-4774-B695-CA3B3288FFEF}" srcOrd="0" destOrd="0" presId="urn:microsoft.com/office/officeart/2005/8/layout/hierarchy4"/>
+    <dgm:cxn modelId="{34D07C26-28CF-4128-BEF6-96F7056AD867}" type="presOf" srcId="{2119E684-95D4-414B-B613-2F7A2AE41D3B}" destId="{A44D9E7A-8498-41EB-9614-74C0C3D1AB15}" srcOrd="0" destOrd="0" presId="urn:microsoft.com/office/officeart/2005/8/layout/hierarchy4"/>
+    <dgm:cxn modelId="{8579115E-8B96-4CE3-834A-ED4E162D50AC}" srcId="{BF55CBDA-CFB4-41A2-B147-2688FD9105E9}" destId="{9EBACEE9-4484-40AE-B42A-0EE8E0D86C00}" srcOrd="0" destOrd="0" parTransId="{BA67CDFE-77AF-4A8C-88EC-55B1BF1BA6EF}" sibTransId="{1A3FDFEC-117C-437F-84C3-479D08B1EE10}"/>
+    <dgm:cxn modelId="{22BE2664-5536-4DFC-ADCF-87837926FFD4}" type="presOf" srcId="{9EBACEE9-4484-40AE-B42A-0EE8E0D86C00}" destId="{3F00401D-E535-44A7-B7DF-456F2E7C7E78}" srcOrd="0" destOrd="0" presId="urn:microsoft.com/office/officeart/2005/8/layout/hierarchy4"/>
+    <dgm:cxn modelId="{6F5FBD4B-9865-407C-B768-D1339F3A9BA2}" type="presOf" srcId="{BF55CBDA-CFB4-41A2-B147-2688FD9105E9}" destId="{9620CF0C-6C1F-4CEB-BA70-47082C968EEB}" srcOrd="0" destOrd="0" presId="urn:microsoft.com/office/officeart/2005/8/layout/hierarchy4"/>
+    <dgm:cxn modelId="{D879AD56-BD3D-4991-8DDE-32FB937D2ED9}" type="presOf" srcId="{62F8C152-76C8-42D0-B3DE-D4905309402B}" destId="{4E4B5D82-F094-4117-BA5A-AE50309C681E}" srcOrd="0" destOrd="0" presId="urn:microsoft.com/office/officeart/2005/8/layout/hierarchy4"/>
+    <dgm:cxn modelId="{EFB0AD94-F900-4812-AEA7-A61F1BC3E761}" srcId="{A0F92E95-5464-47FC-A521-3B5754D48AB0}" destId="{62F8C152-76C8-42D0-B3DE-D4905309402B}" srcOrd="0" destOrd="0" parTransId="{4D48D1F2-7912-4695-9B71-E818361355FA}" sibTransId="{7899B6D5-4D10-45C4-AE67-E250823E82D6}"/>
+    <dgm:cxn modelId="{D588B49B-8FA7-4808-B95E-0201B851283E}" srcId="{2119E684-95D4-414B-B613-2F7A2AE41D3B}" destId="{5344F3BC-69B7-46E5-A1D8-8321697D1EA9}" srcOrd="0" destOrd="0" parTransId="{3C8338D5-6A06-4908-AD2C-013920092B4D}" sibTransId="{002FBC27-AB53-420F-ABFA-0475A4CFE521}"/>
+    <dgm:cxn modelId="{C26A2F9D-D589-4E6F-8261-F46B398D2C15}" srcId="{A0F92E95-5464-47FC-A521-3B5754D48AB0}" destId="{ED0B512D-A516-41B0-A1B4-D198DC3373AF}" srcOrd="1" destOrd="0" parTransId="{773955EF-4E3F-4E8A-9449-B285C01ACC6F}" sibTransId="{60B79A70-0116-452C-9F00-FC400C62BA02}"/>
+    <dgm:cxn modelId="{557909AF-46D9-4330-97C7-3A4724F2325D}" type="presOf" srcId="{ED0B512D-A516-41B0-A1B4-D198DC3373AF}" destId="{6ABD528C-1080-4F7A-B271-80FCE46B825C}" srcOrd="0" destOrd="0" presId="urn:microsoft.com/office/officeart/2005/8/layout/hierarchy4"/>
+    <dgm:cxn modelId="{6D8931D0-1E2A-48B6-AA63-68770A4954D3}" srcId="{9EBACEE9-4484-40AE-B42A-0EE8E0D86C00}" destId="{2119E684-95D4-414B-B613-2F7A2AE41D3B}" srcOrd="1" destOrd="0" parTransId="{50E796F8-72F2-432A-A0D1-FD25AAF3B40B}" sibTransId="{382CE42E-D2BD-42FD-B8EF-E2BC0643C4BE}"/>
+    <dgm:cxn modelId="{87313CD7-09F3-4080-AC4E-E57866204221}" type="presOf" srcId="{5344F3BC-69B7-46E5-A1D8-8321697D1EA9}" destId="{283550C5-8B28-461D-9657-9B2E07169954}" srcOrd="0" destOrd="0" presId="urn:microsoft.com/office/officeart/2005/8/layout/hierarchy4"/>
+    <dgm:cxn modelId="{E14E4456-98B7-41DC-AB7A-7A331929552C}" type="presParOf" srcId="{9620CF0C-6C1F-4CEB-BA70-47082C968EEB}" destId="{AD3417B4-2511-4C7E-8E17-8CC957C3E7C4}" srcOrd="0" destOrd="0" presId="urn:microsoft.com/office/officeart/2005/8/layout/hierarchy4"/>
+    <dgm:cxn modelId="{4DB1F718-F1EF-4D59-87BE-DB622B287DD5}" type="presParOf" srcId="{AD3417B4-2511-4C7E-8E17-8CC957C3E7C4}" destId="{3F00401D-E535-44A7-B7DF-456F2E7C7E78}" srcOrd="0" destOrd="0" presId="urn:microsoft.com/office/officeart/2005/8/layout/hierarchy4"/>
+    <dgm:cxn modelId="{96EC2F4C-B68C-4B88-AA2B-C348B50CAC55}" type="presParOf" srcId="{AD3417B4-2511-4C7E-8E17-8CC957C3E7C4}" destId="{514CF210-A163-4106-A036-FC4929863BDA}" srcOrd="1" destOrd="0" presId="urn:microsoft.com/office/officeart/2005/8/layout/hierarchy4"/>
+    <dgm:cxn modelId="{57C4AD68-C6B0-4DDE-AFEF-3275E2B83297}" type="presParOf" srcId="{AD3417B4-2511-4C7E-8E17-8CC957C3E7C4}" destId="{18176594-7E51-4FBD-8023-92463CE355F4}" srcOrd="2" destOrd="0" presId="urn:microsoft.com/office/officeart/2005/8/layout/hierarchy4"/>
+    <dgm:cxn modelId="{A0959622-4557-4FF2-A8DE-CFDC49FF379F}" type="presParOf" srcId="{18176594-7E51-4FBD-8023-92463CE355F4}" destId="{CC7BA731-3936-4513-A726-33FFEBD1F0B5}" srcOrd="0" destOrd="0" presId="urn:microsoft.com/office/officeart/2005/8/layout/hierarchy4"/>
+    <dgm:cxn modelId="{CCF714A5-7D9A-47BD-B9BD-412EF5A3CB38}" type="presParOf" srcId="{CC7BA731-3936-4513-A726-33FFEBD1F0B5}" destId="{EBC95740-427A-4774-B695-CA3B3288FFEF}" srcOrd="0" destOrd="0" presId="urn:microsoft.com/office/officeart/2005/8/layout/hierarchy4"/>
+    <dgm:cxn modelId="{C4EAB7B9-4AF1-453D-AF50-70E3FCC60725}" type="presParOf" srcId="{CC7BA731-3936-4513-A726-33FFEBD1F0B5}" destId="{D276CA00-24A2-4A06-97D7-841152C70F94}" srcOrd="1" destOrd="0" presId="urn:microsoft.com/office/officeart/2005/8/layout/hierarchy4"/>
+    <dgm:cxn modelId="{9FF64B4B-77FB-4FCA-B170-809F7446BE5C}" type="presParOf" srcId="{CC7BA731-3936-4513-A726-33FFEBD1F0B5}" destId="{D9857921-84C4-4CF2-A2B1-ECA705DF9B9F}" srcOrd="2" destOrd="0" presId="urn:microsoft.com/office/officeart/2005/8/layout/hierarchy4"/>
+    <dgm:cxn modelId="{CEDCFD27-589B-4CE5-A928-B92916B020F8}" type="presParOf" srcId="{D9857921-84C4-4CF2-A2B1-ECA705DF9B9F}" destId="{7E07DDE4-5E0F-450A-89E7-1A21B3E4D12C}" srcOrd="0" destOrd="0" presId="urn:microsoft.com/office/officeart/2005/8/layout/hierarchy4"/>
+    <dgm:cxn modelId="{8403F192-4766-4411-BDBC-C77A3AB12B91}" type="presParOf" srcId="{7E07DDE4-5E0F-450A-89E7-1A21B3E4D12C}" destId="{4E4B5D82-F094-4117-BA5A-AE50309C681E}" srcOrd="0" destOrd="0" presId="urn:microsoft.com/office/officeart/2005/8/layout/hierarchy4"/>
+    <dgm:cxn modelId="{7BC69218-04E7-498C-B4F8-06097662BBBB}" type="presParOf" srcId="{7E07DDE4-5E0F-450A-89E7-1A21B3E4D12C}" destId="{57F1B384-16AC-4D48-AD7B-3E0AD804E0DA}" srcOrd="1" destOrd="0" presId="urn:microsoft.com/office/officeart/2005/8/layout/hierarchy4"/>
+    <dgm:cxn modelId="{14F50D98-12F9-45D5-8A41-BDCDBA066739}" type="presParOf" srcId="{D9857921-84C4-4CF2-A2B1-ECA705DF9B9F}" destId="{06F41DF7-92F1-43D0-9FB1-7CA9953D0F8E}" srcOrd="1" destOrd="0" presId="urn:microsoft.com/office/officeart/2005/8/layout/hierarchy4"/>
+    <dgm:cxn modelId="{57526956-F467-4A88-88AC-6249D50B7291}" type="presParOf" srcId="{D9857921-84C4-4CF2-A2B1-ECA705DF9B9F}" destId="{9A085E36-0038-47A9-BD1B-E635AA5325A5}" srcOrd="2" destOrd="0" presId="urn:microsoft.com/office/officeart/2005/8/layout/hierarchy4"/>
+    <dgm:cxn modelId="{B6AA220B-90D9-45BE-BBD5-B1D14773A9E1}" type="presParOf" srcId="{9A085E36-0038-47A9-BD1B-E635AA5325A5}" destId="{6ABD528C-1080-4F7A-B271-80FCE46B825C}" srcOrd="0" destOrd="0" presId="urn:microsoft.com/office/officeart/2005/8/layout/hierarchy4"/>
+    <dgm:cxn modelId="{0CDD6832-2038-44DF-B4F8-41E0FE59AC41}" type="presParOf" srcId="{9A085E36-0038-47A9-BD1B-E635AA5325A5}" destId="{E1E518C9-A657-499E-A451-3B8367E98A2C}" srcOrd="1" destOrd="0" presId="urn:microsoft.com/office/officeart/2005/8/layout/hierarchy4"/>
+    <dgm:cxn modelId="{2713BE26-9711-4909-B218-5C74107E5946}" type="presParOf" srcId="{18176594-7E51-4FBD-8023-92463CE355F4}" destId="{22A46785-CC93-4AD6-9BCB-B183CD74CCE1}" srcOrd="1" destOrd="0" presId="urn:microsoft.com/office/officeart/2005/8/layout/hierarchy4"/>
+    <dgm:cxn modelId="{4C290381-04CF-4F36-8381-E02989C693B1}" type="presParOf" srcId="{18176594-7E51-4FBD-8023-92463CE355F4}" destId="{23B4ED7C-3B13-43C9-82B8-07F660EDC1BB}" srcOrd="2" destOrd="0" presId="urn:microsoft.com/office/officeart/2005/8/layout/hierarchy4"/>
+    <dgm:cxn modelId="{64BC897B-19A6-4B06-B7FB-11DB86EF4556}" type="presParOf" srcId="{23B4ED7C-3B13-43C9-82B8-07F660EDC1BB}" destId="{A44D9E7A-8498-41EB-9614-74C0C3D1AB15}" srcOrd="0" destOrd="0" presId="urn:microsoft.com/office/officeart/2005/8/layout/hierarchy4"/>
+    <dgm:cxn modelId="{7D29B4F2-647A-4BEF-B30E-5A6EDE693A3D}" type="presParOf" srcId="{23B4ED7C-3B13-43C9-82B8-07F660EDC1BB}" destId="{8BCA783A-E08D-4223-9033-BCCF92E9AC30}" srcOrd="1" destOrd="0" presId="urn:microsoft.com/office/officeart/2005/8/layout/hierarchy4"/>
+    <dgm:cxn modelId="{1913F89C-C06D-441A-A5E9-DE2A7A7AD890}" type="presParOf" srcId="{23B4ED7C-3B13-43C9-82B8-07F660EDC1BB}" destId="{F7D3704D-CB29-4DF3-AAAD-1F0CA35D4478}" srcOrd="2" destOrd="0" presId="urn:microsoft.com/office/officeart/2005/8/layout/hierarchy4"/>
+    <dgm:cxn modelId="{20E631B9-D118-49C5-B517-F79DA13121E4}" type="presParOf" srcId="{F7D3704D-CB29-4DF3-AAAD-1F0CA35D4478}" destId="{CEFD8B21-37D4-4CC5-B9E9-721F42A57CF1}" srcOrd="0" destOrd="0" presId="urn:microsoft.com/office/officeart/2005/8/layout/hierarchy4"/>
+    <dgm:cxn modelId="{90040D83-1831-4C91-8E4F-585746EF2961}" type="presParOf" srcId="{CEFD8B21-37D4-4CC5-B9E9-721F42A57CF1}" destId="{283550C5-8B28-461D-9657-9B2E07169954}" srcOrd="0" destOrd="0" presId="urn:microsoft.com/office/officeart/2005/8/layout/hierarchy4"/>
+    <dgm:cxn modelId="{D894BC55-8F5C-46D0-BF8F-70B88CB51486}" type="presParOf" srcId="{CEFD8B21-37D4-4CC5-B9E9-721F42A57CF1}" destId="{B0A668E1-968E-4C26-81F9-6CFF85576F32}" srcOrd="1" destOrd="0" presId="urn:microsoft.com/office/officeart/2005/8/layout/hierarchy4"/>
+  </dgm:cxnLst>
+  <dgm:bg/>
+  <dgm:whole/>
+  <dgm:extLst>
+    <a:ext uri="http://schemas.microsoft.com/office/drawing/2008/diagram">
+      <dsp:dataModelExt xmlns:dsp="http://schemas.microsoft.com/office/drawing/2008/diagram" relId="rId6" minVer="http://schemas.openxmlformats.org/drawingml/2006/diagram"/>
+    </a:ext>
+  </dgm:extLst>
+</dgm:dataModel>
+</file>
+
+<file path=ppt/diagrams/drawing1.xml><?xml version="1.0" encoding="utf-8"?>
+<dsp:drawing xmlns:dgm="http://schemas.openxmlformats.org/drawingml/2006/diagram" xmlns:dsp="http://schemas.microsoft.com/office/drawing/2008/diagram" xmlns:a="http://schemas.openxmlformats.org/drawingml/2006/main">
+  <dsp:spTree>
+    <dsp:nvGrpSpPr>
+      <dsp:cNvPr id="0" name=""/>
+      <dsp:cNvGrpSpPr/>
+    </dsp:nvGrpSpPr>
+    <dsp:grpSpPr/>
+    <dsp:sp modelId="{3F00401D-E535-44A7-B7DF-456F2E7C7E78}">
+      <dsp:nvSpPr>
+        <dsp:cNvPr id="0" name=""/>
+        <dsp:cNvSpPr/>
+      </dsp:nvSpPr>
+      <dsp:spPr>
+        <a:xfrm>
+          <a:off x="932" y="1947"/>
+          <a:ext cx="8126134" cy="1709208"/>
+        </a:xfrm>
+        <a:prstGeom prst="roundRect">
+          <a:avLst>
+            <a:gd name="adj" fmla="val 10000"/>
+          </a:avLst>
+        </a:prstGeom>
+        <a:solidFill>
+          <a:schemeClr val="accent1">
+            <a:hueOff val="0"/>
+            <a:satOff val="0"/>
+            <a:lumOff val="0"/>
+            <a:alphaOff val="0"/>
+          </a:schemeClr>
+        </a:solidFill>
+        <a:ln w="19050" cap="flat" cmpd="sng" algn="ctr">
+          <a:solidFill>
+            <a:schemeClr val="lt1">
+              <a:hueOff val="0"/>
+              <a:satOff val="0"/>
+              <a:lumOff val="0"/>
+              <a:alphaOff val="0"/>
+            </a:schemeClr>
+          </a:solidFill>
+          <a:prstDash val="solid"/>
+          <a:miter lim="800000"/>
+        </a:ln>
+        <a:effectLst/>
+      </dsp:spPr>
+      <dsp:style>
+        <a:lnRef idx="2">
+          <a:scrgbClr r="0" g="0" b="0"/>
+        </a:lnRef>
+        <a:fillRef idx="1">
+          <a:scrgbClr r="0" g="0" b="0"/>
+        </a:fillRef>
+        <a:effectRef idx="0">
+          <a:scrgbClr r="0" g="0" b="0"/>
+        </a:effectRef>
+        <a:fontRef idx="minor">
+          <a:schemeClr val="lt1"/>
+        </a:fontRef>
+      </dsp:style>
+      <dsp:txBody>
+        <a:bodyPr spcFirstLastPara="0" vert="horz" wrap="square" lIns="247650" tIns="247650" rIns="247650" bIns="247650" numCol="1" spcCol="1270" anchor="ctr" anchorCtr="0">
+          <a:noAutofit/>
+        </a:bodyPr>
+        <a:lstStyle/>
+        <a:p>
+          <a:pPr marL="0" lvl="0" indent="0" algn="ctr" defTabSz="2889250">
+            <a:lnSpc>
+              <a:spcPct val="90000"/>
+            </a:lnSpc>
+            <a:spcBef>
+              <a:spcPct val="0"/>
+            </a:spcBef>
+            <a:spcAft>
+              <a:spcPct val="35000"/>
+            </a:spcAft>
+            <a:buNone/>
+          </a:pPr>
+          <a:endParaRPr lang="en-GB" sz="6500" kern="1200"/>
+        </a:p>
+      </dsp:txBody>
+      <dsp:txXfrm>
+        <a:off x="50993" y="52008"/>
+        <a:ext cx="8026012" cy="1609086"/>
+      </dsp:txXfrm>
+    </dsp:sp>
+    <dsp:sp modelId="{EBC95740-427A-4774-B695-CA3B3288FFEF}">
+      <dsp:nvSpPr>
+        <dsp:cNvPr id="0" name=""/>
+        <dsp:cNvSpPr/>
+      </dsp:nvSpPr>
+      <dsp:spPr>
+        <a:xfrm>
+          <a:off x="932" y="1854729"/>
+          <a:ext cx="5308242" cy="1709208"/>
+        </a:xfrm>
+        <a:prstGeom prst="roundRect">
+          <a:avLst>
+            <a:gd name="adj" fmla="val 10000"/>
+          </a:avLst>
+        </a:prstGeom>
+        <a:solidFill>
+          <a:schemeClr val="accent1">
+            <a:hueOff val="0"/>
+            <a:satOff val="0"/>
+            <a:lumOff val="0"/>
+            <a:alphaOff val="0"/>
+          </a:schemeClr>
+        </a:solidFill>
+        <a:ln w="19050" cap="flat" cmpd="sng" algn="ctr">
+          <a:solidFill>
+            <a:schemeClr val="lt1">
+              <a:hueOff val="0"/>
+              <a:satOff val="0"/>
+              <a:lumOff val="0"/>
+              <a:alphaOff val="0"/>
+            </a:schemeClr>
+          </a:solidFill>
+          <a:prstDash val="solid"/>
+          <a:miter lim="800000"/>
+        </a:ln>
+        <a:effectLst/>
+      </dsp:spPr>
+      <dsp:style>
+        <a:lnRef idx="2">
+          <a:scrgbClr r="0" g="0" b="0"/>
+        </a:lnRef>
+        <a:fillRef idx="1">
+          <a:scrgbClr r="0" g="0" b="0"/>
+        </a:fillRef>
+        <a:effectRef idx="0">
+          <a:scrgbClr r="0" g="0" b="0"/>
+        </a:effectRef>
+        <a:fontRef idx="minor">
+          <a:schemeClr val="lt1"/>
+        </a:fontRef>
+      </dsp:style>
+      <dsp:txBody>
+        <a:bodyPr spcFirstLastPara="0" vert="horz" wrap="square" lIns="247650" tIns="247650" rIns="247650" bIns="247650" numCol="1" spcCol="1270" anchor="ctr" anchorCtr="0">
+          <a:noAutofit/>
+        </a:bodyPr>
+        <a:lstStyle/>
+        <a:p>
+          <a:pPr marL="0" lvl="0" indent="0" algn="ctr" defTabSz="2889250">
+            <a:lnSpc>
+              <a:spcPct val="90000"/>
+            </a:lnSpc>
+            <a:spcBef>
+              <a:spcPct val="0"/>
+            </a:spcBef>
+            <a:spcAft>
+              <a:spcPct val="35000"/>
+            </a:spcAft>
+            <a:buNone/>
+          </a:pPr>
+          <a:endParaRPr lang="en-GB" sz="6500" kern="1200"/>
+        </a:p>
+      </dsp:txBody>
+      <dsp:txXfrm>
+        <a:off x="50993" y="1904790"/>
+        <a:ext cx="5208120" cy="1609086"/>
+      </dsp:txXfrm>
+    </dsp:sp>
+    <dsp:sp modelId="{4E4B5D82-F094-4117-BA5A-AE50309C681E}">
+      <dsp:nvSpPr>
+        <dsp:cNvPr id="0" name=""/>
+        <dsp:cNvSpPr/>
+      </dsp:nvSpPr>
+      <dsp:spPr>
+        <a:xfrm>
+          <a:off x="932" y="3707511"/>
+          <a:ext cx="2599531" cy="1709208"/>
+        </a:xfrm>
+        <a:prstGeom prst="roundRect">
+          <a:avLst>
+            <a:gd name="adj" fmla="val 10000"/>
+          </a:avLst>
+        </a:prstGeom>
+        <a:solidFill>
+          <a:schemeClr val="accent1">
+            <a:hueOff val="0"/>
+            <a:satOff val="0"/>
+            <a:lumOff val="0"/>
+            <a:alphaOff val="0"/>
+          </a:schemeClr>
+        </a:solidFill>
+        <a:ln w="19050" cap="flat" cmpd="sng" algn="ctr">
+          <a:solidFill>
+            <a:schemeClr val="lt1">
+              <a:hueOff val="0"/>
+              <a:satOff val="0"/>
+              <a:lumOff val="0"/>
+              <a:alphaOff val="0"/>
+            </a:schemeClr>
+          </a:solidFill>
+          <a:prstDash val="solid"/>
+          <a:miter lim="800000"/>
+        </a:ln>
+        <a:effectLst/>
+      </dsp:spPr>
+      <dsp:style>
+        <a:lnRef idx="2">
+          <a:scrgbClr r="0" g="0" b="0"/>
+        </a:lnRef>
+        <a:fillRef idx="1">
+          <a:scrgbClr r="0" g="0" b="0"/>
+        </a:fillRef>
+        <a:effectRef idx="0">
+          <a:scrgbClr r="0" g="0" b="0"/>
+        </a:effectRef>
+        <a:fontRef idx="minor">
+          <a:schemeClr val="lt1"/>
+        </a:fontRef>
+      </dsp:style>
+      <dsp:txBody>
+        <a:bodyPr spcFirstLastPara="0" vert="horz" wrap="square" lIns="247650" tIns="247650" rIns="247650" bIns="247650" numCol="1" spcCol="1270" anchor="ctr" anchorCtr="0">
+          <a:noAutofit/>
+        </a:bodyPr>
+        <a:lstStyle/>
+        <a:p>
+          <a:pPr marL="0" lvl="0" indent="0" algn="ctr" defTabSz="2889250">
+            <a:lnSpc>
+              <a:spcPct val="90000"/>
+            </a:lnSpc>
+            <a:spcBef>
+              <a:spcPct val="0"/>
+            </a:spcBef>
+            <a:spcAft>
+              <a:spcPct val="35000"/>
+            </a:spcAft>
+            <a:buNone/>
+          </a:pPr>
+          <a:endParaRPr lang="en-GB" sz="6500" kern="1200"/>
+        </a:p>
+      </dsp:txBody>
+      <dsp:txXfrm>
+        <a:off x="50993" y="3757572"/>
+        <a:ext cx="2499409" cy="1609086"/>
+      </dsp:txXfrm>
+    </dsp:sp>
+    <dsp:sp modelId="{6ABD528C-1080-4F7A-B271-80FCE46B825C}">
+      <dsp:nvSpPr>
+        <dsp:cNvPr id="0" name=""/>
+        <dsp:cNvSpPr/>
+      </dsp:nvSpPr>
+      <dsp:spPr>
+        <a:xfrm>
+          <a:off x="2709644" y="3707511"/>
+          <a:ext cx="2599531" cy="1709208"/>
+        </a:xfrm>
+        <a:prstGeom prst="roundRect">
+          <a:avLst>
+            <a:gd name="adj" fmla="val 10000"/>
+          </a:avLst>
+        </a:prstGeom>
+        <a:solidFill>
+          <a:schemeClr val="accent1">
+            <a:hueOff val="0"/>
+            <a:satOff val="0"/>
+            <a:lumOff val="0"/>
+            <a:alphaOff val="0"/>
+          </a:schemeClr>
+        </a:solidFill>
+        <a:ln w="19050" cap="flat" cmpd="sng" algn="ctr">
+          <a:solidFill>
+            <a:schemeClr val="lt1">
+              <a:hueOff val="0"/>
+              <a:satOff val="0"/>
+              <a:lumOff val="0"/>
+              <a:alphaOff val="0"/>
+            </a:schemeClr>
+          </a:solidFill>
+          <a:prstDash val="solid"/>
+          <a:miter lim="800000"/>
+        </a:ln>
+        <a:effectLst/>
+      </dsp:spPr>
+      <dsp:style>
+        <a:lnRef idx="2">
+          <a:scrgbClr r="0" g="0" b="0"/>
+        </a:lnRef>
+        <a:fillRef idx="1">
+          <a:scrgbClr r="0" g="0" b="0"/>
+        </a:fillRef>
+        <a:effectRef idx="0">
+          <a:scrgbClr r="0" g="0" b="0"/>
+        </a:effectRef>
+        <a:fontRef idx="minor">
+          <a:schemeClr val="lt1"/>
+        </a:fontRef>
+      </dsp:style>
+      <dsp:txBody>
+        <a:bodyPr spcFirstLastPara="0" vert="horz" wrap="square" lIns="247650" tIns="247650" rIns="247650" bIns="247650" numCol="1" spcCol="1270" anchor="ctr" anchorCtr="0">
+          <a:noAutofit/>
+        </a:bodyPr>
+        <a:lstStyle/>
+        <a:p>
+          <a:pPr marL="0" lvl="0" indent="0" algn="ctr" defTabSz="2889250">
+            <a:lnSpc>
+              <a:spcPct val="90000"/>
+            </a:lnSpc>
+            <a:spcBef>
+              <a:spcPct val="0"/>
+            </a:spcBef>
+            <a:spcAft>
+              <a:spcPct val="35000"/>
+            </a:spcAft>
+            <a:buNone/>
+          </a:pPr>
+          <a:endParaRPr lang="en-GB" sz="6500" kern="1200"/>
+        </a:p>
+      </dsp:txBody>
+      <dsp:txXfrm>
+        <a:off x="2759705" y="3757572"/>
+        <a:ext cx="2499409" cy="1609086"/>
+      </dsp:txXfrm>
+    </dsp:sp>
+    <dsp:sp modelId="{A44D9E7A-8498-41EB-9614-74C0C3D1AB15}">
+      <dsp:nvSpPr>
+        <dsp:cNvPr id="0" name=""/>
+        <dsp:cNvSpPr/>
+      </dsp:nvSpPr>
+      <dsp:spPr>
+        <a:xfrm>
+          <a:off x="5527536" y="1854729"/>
+          <a:ext cx="2599531" cy="1709208"/>
+        </a:xfrm>
+        <a:prstGeom prst="roundRect">
+          <a:avLst>
+            <a:gd name="adj" fmla="val 10000"/>
+          </a:avLst>
+        </a:prstGeom>
+        <a:solidFill>
+          <a:schemeClr val="accent1">
+            <a:hueOff val="0"/>
+            <a:satOff val="0"/>
+            <a:lumOff val="0"/>
+            <a:alphaOff val="0"/>
+          </a:schemeClr>
+        </a:solidFill>
+        <a:ln w="19050" cap="flat" cmpd="sng" algn="ctr">
+          <a:solidFill>
+            <a:schemeClr val="lt1">
+              <a:hueOff val="0"/>
+              <a:satOff val="0"/>
+              <a:lumOff val="0"/>
+              <a:alphaOff val="0"/>
+            </a:schemeClr>
+          </a:solidFill>
+          <a:prstDash val="solid"/>
+          <a:miter lim="800000"/>
+        </a:ln>
+        <a:effectLst/>
+      </dsp:spPr>
+      <dsp:style>
+        <a:lnRef idx="2">
+          <a:scrgbClr r="0" g="0" b="0"/>
+        </a:lnRef>
+        <a:fillRef idx="1">
+          <a:scrgbClr r="0" g="0" b="0"/>
+        </a:fillRef>
+        <a:effectRef idx="0">
+          <a:scrgbClr r="0" g="0" b="0"/>
+        </a:effectRef>
+        <a:fontRef idx="minor">
+          <a:schemeClr val="lt1"/>
+        </a:fontRef>
+      </dsp:style>
+      <dsp:txBody>
+        <a:bodyPr spcFirstLastPara="0" vert="horz" wrap="square" lIns="247650" tIns="247650" rIns="247650" bIns="247650" numCol="1" spcCol="1270" anchor="ctr" anchorCtr="0">
+          <a:noAutofit/>
+        </a:bodyPr>
+        <a:lstStyle/>
+        <a:p>
+          <a:pPr marL="0" lvl="0" indent="0" algn="ctr" defTabSz="2889250">
+            <a:lnSpc>
+              <a:spcPct val="90000"/>
+            </a:lnSpc>
+            <a:spcBef>
+              <a:spcPct val="0"/>
+            </a:spcBef>
+            <a:spcAft>
+              <a:spcPct val="35000"/>
+            </a:spcAft>
+            <a:buNone/>
+          </a:pPr>
+          <a:endParaRPr lang="en-GB" sz="6500" kern="1200"/>
+        </a:p>
+      </dsp:txBody>
+      <dsp:txXfrm>
+        <a:off x="5577597" y="1904790"/>
+        <a:ext cx="2499409" cy="1609086"/>
+      </dsp:txXfrm>
+    </dsp:sp>
+    <dsp:sp modelId="{283550C5-8B28-461D-9657-9B2E07169954}">
+      <dsp:nvSpPr>
+        <dsp:cNvPr id="0" name=""/>
+        <dsp:cNvSpPr/>
+      </dsp:nvSpPr>
+      <dsp:spPr>
+        <a:xfrm>
+          <a:off x="5527536" y="3707511"/>
+          <a:ext cx="2599531" cy="1709208"/>
+        </a:xfrm>
+        <a:prstGeom prst="roundRect">
+          <a:avLst>
+            <a:gd name="adj" fmla="val 10000"/>
+          </a:avLst>
+        </a:prstGeom>
+        <a:solidFill>
+          <a:schemeClr val="accent1">
+            <a:hueOff val="0"/>
+            <a:satOff val="0"/>
+            <a:lumOff val="0"/>
+            <a:alphaOff val="0"/>
+          </a:schemeClr>
+        </a:solidFill>
+        <a:ln w="19050" cap="flat" cmpd="sng" algn="ctr">
+          <a:solidFill>
+            <a:schemeClr val="lt1">
+              <a:hueOff val="0"/>
+              <a:satOff val="0"/>
+              <a:lumOff val="0"/>
+              <a:alphaOff val="0"/>
+            </a:schemeClr>
+          </a:solidFill>
+          <a:prstDash val="solid"/>
+          <a:miter lim="800000"/>
+        </a:ln>
+        <a:effectLst/>
+      </dsp:spPr>
+      <dsp:style>
+        <a:lnRef idx="2">
+          <a:scrgbClr r="0" g="0" b="0"/>
+        </a:lnRef>
+        <a:fillRef idx="1">
+          <a:scrgbClr r="0" g="0" b="0"/>
+        </a:fillRef>
+        <a:effectRef idx="0">
+          <a:scrgbClr r="0" g="0" b="0"/>
+        </a:effectRef>
+        <a:fontRef idx="minor">
+          <a:schemeClr val="lt1"/>
+        </a:fontRef>
+      </dsp:style>
+      <dsp:txBody>
+        <a:bodyPr spcFirstLastPara="0" vert="horz" wrap="square" lIns="247650" tIns="247650" rIns="247650" bIns="247650" numCol="1" spcCol="1270" anchor="ctr" anchorCtr="0">
+          <a:noAutofit/>
+        </a:bodyPr>
+        <a:lstStyle/>
+        <a:p>
+          <a:pPr marL="0" lvl="0" indent="0" algn="ctr" defTabSz="2889250">
+            <a:lnSpc>
+              <a:spcPct val="90000"/>
+            </a:lnSpc>
+            <a:spcBef>
+              <a:spcPct val="0"/>
+            </a:spcBef>
+            <a:spcAft>
+              <a:spcPct val="35000"/>
+            </a:spcAft>
+            <a:buNone/>
+          </a:pPr>
+          <a:endParaRPr lang="en-GB" sz="6500" kern="1200"/>
+        </a:p>
+      </dsp:txBody>
+      <dsp:txXfrm>
+        <a:off x="5577597" y="3757572"/>
+        <a:ext cx="2499409" cy="1609086"/>
+      </dsp:txXfrm>
+    </dsp:sp>
+  </dsp:spTree>
+</dsp:drawing>
+</file>
+
+<file path=ppt/diagrams/layout1.xml><?xml version="1.0" encoding="utf-8"?>
+<dgm:layoutDef xmlns:dgm="http://schemas.openxmlformats.org/drawingml/2006/diagram" xmlns:a="http://schemas.openxmlformats.org/drawingml/2006/main" uniqueId="urn:microsoft.com/office/officeart/2005/8/layout/hierarchy4">
+  <dgm:title val=""/>
+  <dgm:desc val=""/>
+  <dgm:catLst>
+    <dgm:cat type="hierarchy" pri="4000"/>
+    <dgm:cat type="list" pri="24000"/>
+    <dgm:cat type="relationship" pri="10000"/>
+  </dgm:catLst>
+  <dgm:sampData>
+    <dgm:dataModel>
+      <dgm:ptLst>
+        <dgm:pt modelId="0" type="doc"/>
+        <dgm:pt modelId="1">
+          <dgm:prSet phldr="1"/>
+        </dgm:pt>
+        <dgm:pt modelId="2">
+          <dgm:prSet phldr="1"/>
+        </dgm:pt>
+        <dgm:pt modelId="21">
+          <dgm:prSet phldr="1"/>
+        </dgm:pt>
+        <dgm:pt modelId="22">
+          <dgm:prSet phldr="1"/>
+        </dgm:pt>
+        <dgm:pt modelId="3">
+          <dgm:prSet phldr="1"/>
+        </dgm:pt>
+        <dgm:pt modelId="31">
+          <dgm:prSet phldr="1"/>
+        </dgm:pt>
+      </dgm:ptLst>
+      <dgm:cxnLst>
+        <dgm:cxn modelId="4" srcId="0" destId="1" srcOrd="0" destOrd="0"/>
+        <dgm:cxn modelId="5" srcId="1" destId="2" srcOrd="0" destOrd="0"/>
+        <dgm:cxn modelId="6" srcId="1" destId="3" srcOrd="1" destOrd="0"/>
+        <dgm:cxn modelId="23" srcId="2" destId="21" srcOrd="0" destOrd="0"/>
+        <dgm:cxn modelId="24" srcId="2" destId="22" srcOrd="1" destOrd="0"/>
+        <dgm:cxn modelId="33" srcId="3" destId="31" srcOrd="0" destOrd="0"/>
+      </dgm:cxnLst>
+      <dgm:bg/>
+      <dgm:whole/>
+    </dgm:dataModel>
+  </dgm:sampData>
+  <dgm:styleData>
+    <dgm:dataModel>
+      <dgm:ptLst>
+        <dgm:pt modelId="0" type="doc"/>
+        <dgm:pt modelId="1"/>
+        <dgm:pt modelId="11"/>
+        <dgm:pt modelId="12"/>
+      </dgm:ptLst>
+      <dgm:cxnLst>
+        <dgm:cxn modelId="2" srcId="0" destId="1" srcOrd="0" destOrd="0"/>
+        <dgm:cxn modelId="13" srcId="1" destId="11" srcOrd="0" destOrd="0"/>
+        <dgm:cxn modelId="14" srcId="1" destId="12" srcOrd="1" destOrd="0"/>
+      </dgm:cxnLst>
+      <dgm:bg/>
+      <dgm:whole/>
+    </dgm:dataModel>
+  </dgm:styleData>
+  <dgm:clrData>
+    <dgm:dataModel>
+      <dgm:ptLst>
+        <dgm:pt modelId="0" type="doc"/>
+        <dgm:pt modelId="1"/>
+        <dgm:pt modelId="2"/>
+        <dgm:pt modelId="21"/>
+        <dgm:pt modelId="211"/>
+        <dgm:pt modelId="3"/>
+        <dgm:pt modelId="31"/>
+        <dgm:pt modelId="311"/>
+      </dgm:ptLst>
+      <dgm:cxnLst>
+        <dgm:cxn modelId="4" srcId="0" destId="1" srcOrd="0" destOrd="0"/>
+        <dgm:cxn modelId="5" srcId="1" destId="2" srcOrd="0" destOrd="0"/>
+        <dgm:cxn modelId="6" srcId="1" destId="3" srcOrd="1" destOrd="0"/>
+        <dgm:cxn modelId="23" srcId="2" destId="21" srcOrd="0" destOrd="0"/>
+        <dgm:cxn modelId="24" srcId="21" destId="211" srcOrd="0" destOrd="0"/>
+        <dgm:cxn modelId="33" srcId="3" destId="31" srcOrd="0" destOrd="0"/>
+        <dgm:cxn modelId="34" srcId="31" destId="311" srcOrd="0" destOrd="0"/>
+      </dgm:cxnLst>
+      <dgm:bg/>
+      <dgm:whole/>
+    </dgm:dataModel>
+  </dgm:clrData>
+  <dgm:layoutNode name="Name0">
+    <dgm:varLst>
+      <dgm:chPref val="1"/>
+      <dgm:dir/>
+      <dgm:animOne val="branch"/>
+      <dgm:animLvl val="lvl"/>
+      <dgm:resizeHandles/>
+    </dgm:varLst>
+    <dgm:choose name="Name1">
+      <dgm:if name="Name2" func="var" arg="dir" op="equ" val="norm">
+        <dgm:alg type="lin">
+          <dgm:param type="linDir" val="fromL"/>
+          <dgm:param type="nodeVertAlign" val="t"/>
+        </dgm:alg>
+      </dgm:if>
+      <dgm:else name="Name3">
+        <dgm:alg type="lin">
+          <dgm:param type="linDir" val="fromR"/>
+          <dgm:param type="nodeVertAlign" val="t"/>
+        </dgm:alg>
+      </dgm:else>
+    </dgm:choose>
+    <dgm:shape xmlns:r="http://schemas.openxmlformats.org/officeDocument/2006/relationships" r:blip="">
+      <dgm:adjLst/>
+    </dgm:shape>
+    <dgm:presOf/>
+    <dgm:constrLst>
+      <dgm:constr type="w" for="ch" forName="vertOne" refType="w"/>
+      <dgm:constr type="w" for="des" forName="horzOne" refType="w"/>
+      <dgm:constr type="w" for="des" forName="txOne" refType="w"/>
+      <dgm:constr type="w" for="des" forName="vertTwo" refType="w"/>
+      <dgm:constr type="w" for="des" forName="horzTwo" refType="w"/>
+      <dgm:constr type="w" for="des" forName="txTwo" refType="w"/>
+      <dgm:constr type="w" for="des" forName="vertThree" refType="w"/>
+      <dgm:constr type="w" for="des" forName="horzThree" refType="w"/>
+      <dgm:constr type="w" for="des" forName="txThree" refType="w"/>
+      <dgm:constr type="w" for="des" forName="vertFour" refType="w"/>
+      <dgm:constr type="w" for="des" forName="horzFour" refType="w"/>
+      <dgm:constr type="w" for="des" forName="txFour" refType="w"/>
+      <dgm:constr type="h" for="des" ptType="node" op="equ"/>
+      <dgm:constr type="h" for="des" forName="txOne" refType="h"/>
+      <dgm:constr type="userH" for="des" ptType="node" refType="h" refFor="des" refForName="txOne"/>
+      <dgm:constr type="primFontSz" for="des" forName="txOne" val="65"/>
+      <dgm:constr type="primFontSz" for="des" forName="txTwo" val="65"/>
+      <dgm:constr type="primFontSz" for="des" forName="txTwo" refType="primFontSz" refFor="des" refForName="txOne" op="lte"/>
+      <dgm:constr type="primFontSz" for="des" forName="txThree" val="65"/>
+      <dgm:constr type="primFontSz" for="des" forName="txThree" refType="primFontSz" refFor="des" refForName="txOne" op="lte"/>
+      <dgm:constr type="primFontSz" for="des" forName="txThree" refType="primFontSz" refFor="des" refForName="txTwo" op="lte"/>
+      <dgm:constr type="primFontSz" for="des" forName="txFour" val="65"/>
+      <dgm:constr type="primFontSz" for="des" forName="txFour" refType="primFontSz" refFor="des" refForName="txOne" op="lte"/>
+      <dgm:constr type="primFontSz" for="des" forName="txFour" refType="primFontSz" refFor="des" refForName="txTwo" op="lte"/>
+      <dgm:constr type="primFontSz" for="des" forName="txFour" refType="primFontSz" refFor="des" refForName="txThree" op="lte"/>
+      <dgm:constr type="w" for="des" forName="sibSpaceOne" refType="w" fact="0.168"/>
+      <dgm:constr type="w" for="des" forName="sibSpaceTwo" refType="w" refFor="des" refForName="sibSpaceOne" op="equ" fact="0.5"/>
+      <dgm:constr type="w" for="des" forName="sibSpaceThree" refType="w" refFor="des" refForName="sibSpaceTwo" op="equ" fact="0.5"/>
+      <dgm:constr type="w" for="des" forName="sibSpaceFour" refType="w" refFor="des" refForName="sibSpaceThree" op="equ" fact="0.5"/>
+      <dgm:constr type="h" for="des" forName="parTransOne" refType="w" fact="0.056"/>
+      <dgm:constr type="h" for="des" forName="parTransTwo" refType="h" refFor="des" refForName="parTransOne" op="equ"/>
+      <dgm:constr type="h" for="des" forName="parTransThree" refType="h" refFor="des" refForName="parTransTwo" op="equ"/>
+      <dgm:constr type="h" for="des" forName="parTransFour" refType="h" refFor="des" refForName="parTransThree" op="equ"/>
+    </dgm:constrLst>
+    <dgm:ruleLst/>
+    <dgm:forEach name="Name4" axis="ch" ptType="node">
+      <dgm:layoutNode name="vertOne">
+        <dgm:alg type="lin">
+          <dgm:param type="linDir" val="fromT"/>
+        </dgm:alg>
+        <dgm:shape xmlns:r="http://schemas.openxmlformats.org/officeDocument/2006/relationships" r:blip="">
+          <dgm:adjLst/>
+        </dgm:shape>
+        <dgm:presOf/>
+        <dgm:constrLst>
+          <dgm:constr type="w" for="ch" forName="txOne" refType="w" refFor="ch" refForName="horzOne" op="gte"/>
+        </dgm:constrLst>
+        <dgm:ruleLst/>
+        <dgm:layoutNode name="txOne" styleLbl="node0">
+          <dgm:varLst>
+            <dgm:chPref val="3"/>
+          </dgm:varLst>
+          <dgm:alg type="tx"/>
+          <dgm:shape xmlns:r="http://schemas.openxmlformats.org/officeDocument/2006/relationships" type="roundRect" r:blip="">
+            <dgm:adjLst>
+              <dgm:adj idx="1" val="0.1"/>
+            </dgm:adjLst>
+          </dgm:shape>
+          <dgm:presOf axis="self"/>
+          <dgm:constrLst>
+            <dgm:constr type="tMarg" refType="primFontSz" fact="0.3"/>
+            <dgm:constr type="bMarg" refType="primFontSz" fact="0.3"/>
+            <dgm:constr type="lMarg" refType="primFontSz" fact="0.3"/>
+            <dgm:constr type="rMarg" refType="primFontSz" fact="0.3"/>
+          </dgm:constrLst>
+          <dgm:ruleLst>
+            <dgm:rule type="primFontSz" val="5" fact="NaN" max="NaN"/>
+          </dgm:ruleLst>
+        </dgm:layoutNode>
+        <dgm:choose name="Name5">
+          <dgm:if name="Name6" axis="des" ptType="node" func="cnt" op="gt" val="0">
+            <dgm:layoutNode name="parTransOne">
+              <dgm:alg type="sp"/>
+              <dgm:shape xmlns:r="http://schemas.openxmlformats.org/officeDocument/2006/relationships" r:blip="">
+                <dgm:adjLst/>
+              </dgm:shape>
+              <dgm:presOf/>
+              <dgm:constrLst/>
+              <dgm:ruleLst/>
+            </dgm:layoutNode>
+          </dgm:if>
+          <dgm:else name="Name7"/>
+        </dgm:choose>
+        <dgm:layoutNode name="horzOne">
+          <dgm:choose name="Name8">
+            <dgm:if name="Name9" func="var" arg="dir" op="equ" val="norm">
+              <dgm:alg type="lin">
+                <dgm:param type="linDir" val="fromL"/>
+                <dgm:param type="nodeVertAlign" val="t"/>
+              </dgm:alg>
+            </dgm:if>
+            <dgm:else name="Name10">
+              <dgm:alg type="lin">
+                <dgm:param type="linDir" val="fromR"/>
+                <dgm:param type="nodeVertAlign" val="t"/>
+              </dgm:alg>
+            </dgm:else>
+          </dgm:choose>
+          <dgm:shape xmlns:r="http://schemas.openxmlformats.org/officeDocument/2006/relationships" r:blip="">
+            <dgm:adjLst/>
+          </dgm:shape>
+          <dgm:presOf/>
+          <dgm:constrLst/>
+          <dgm:ruleLst>
+            <dgm:rule type="w" val="INF" fact="NaN" max="NaN"/>
+          </dgm:ruleLst>
+          <dgm:forEach name="Name11" axis="ch" ptType="node">
+            <dgm:layoutNode name="vertTwo">
+              <dgm:alg type="lin">
+                <dgm:param type="linDir" val="fromT"/>
+              </dgm:alg>
+              <dgm:shape xmlns:r="http://schemas.openxmlformats.org/officeDocument/2006/relationships" r:blip="">
+                <dgm:adjLst/>
+              </dgm:shape>
+              <dgm:presOf/>
+              <dgm:constrLst>
+                <dgm:constr type="w" for="ch" forName="txTwo" refType="w" refFor="ch" refForName="horzTwo" op="gte"/>
+              </dgm:constrLst>
+              <dgm:ruleLst/>
+              <dgm:layoutNode name="txTwo">
+                <dgm:varLst>
+                  <dgm:chPref val="3"/>
+                </dgm:varLst>
+                <dgm:alg type="tx"/>
+                <dgm:shape xmlns:r="http://schemas.openxmlformats.org/officeDocument/2006/relationships" type="roundRect" r:blip="">
+                  <dgm:adjLst>
+                    <dgm:adj idx="1" val="0.1"/>
+                  </dgm:adjLst>
+                </dgm:shape>
+                <dgm:presOf axis="self"/>
+                <dgm:constrLst>
+                  <dgm:constr type="userH"/>
+                  <dgm:constr type="h" refType="userH"/>
+                  <dgm:constr type="tMarg" refType="primFontSz" fact="0.3"/>
+                  <dgm:constr type="bMarg" refType="primFontSz" fact="0.3"/>
+                  <dgm:constr type="lMarg" refType="primFontSz" fact="0.3"/>
+                  <dgm:constr type="rMarg" refType="primFontSz" fact="0.3"/>
+                </dgm:constrLst>
+                <dgm:ruleLst>
+                  <dgm:rule type="primFontSz" val="5" fact="NaN" max="NaN"/>
+                </dgm:ruleLst>
+              </dgm:layoutNode>
+              <dgm:choose name="Name12">
+                <dgm:if name="Name13" axis="des" ptType="node" func="cnt" op="gt" val="0">
+                  <dgm:layoutNode name="parTransTwo">
+                    <dgm:alg type="sp"/>
+                    <dgm:shape xmlns:r="http://schemas.openxmlformats.org/officeDocument/2006/relationships" r:blip="">
+                      <dgm:adjLst/>
+                    </dgm:shape>
+                    <dgm:presOf/>
+                    <dgm:constrLst/>
+                    <dgm:ruleLst/>
+                  </dgm:layoutNode>
+                </dgm:if>
+                <dgm:else name="Name14"/>
+              </dgm:choose>
+              <dgm:layoutNode name="horzTwo">
+                <dgm:choose name="Name15">
+                  <dgm:if name="Name16" func="var" arg="dir" op="equ" val="norm">
+                    <dgm:alg type="lin">
+                      <dgm:param type="linDir" val="fromL"/>
+                      <dgm:param type="nodeVertAlign" val="t"/>
+                    </dgm:alg>
+                  </dgm:if>
+                  <dgm:else name="Name17">
+                    <dgm:alg type="lin">
+                      <dgm:param type="linDir" val="fromR"/>
+                      <dgm:param type="nodeVertAlign" val="t"/>
+                    </dgm:alg>
+                  </dgm:else>
+                </dgm:choose>
+                <dgm:shape xmlns:r="http://schemas.openxmlformats.org/officeDocument/2006/relationships" r:blip="">
+                  <dgm:adjLst/>
+                </dgm:shape>
+                <dgm:presOf/>
+                <dgm:constrLst/>
+                <dgm:ruleLst>
+                  <dgm:rule type="w" val="INF" fact="NaN" max="NaN"/>
+                </dgm:ruleLst>
+                <dgm:forEach name="Name18" axis="ch" ptType="node">
+                  <dgm:layoutNode name="vertThree">
+                    <dgm:alg type="lin">
+                      <dgm:param type="linDir" val="fromT"/>
+                    </dgm:alg>
+                    <dgm:shape xmlns:r="http://schemas.openxmlformats.org/officeDocument/2006/relationships" r:blip="">
+                      <dgm:adjLst/>
+                    </dgm:shape>
+                    <dgm:presOf/>
+                    <dgm:constrLst>
+                      <dgm:constr type="w" for="ch" forName="txThree" refType="w" refFor="ch" refForName="horzThree" op="gte"/>
+                    </dgm:constrLst>
+                    <dgm:ruleLst/>
+                    <dgm:layoutNode name="txThree">
+                      <dgm:varLst>
+                        <dgm:chPref val="3"/>
+                      </dgm:varLst>
+                      <dgm:alg type="tx"/>
+                      <dgm:shape xmlns:r="http://schemas.openxmlformats.org/officeDocument/2006/relationships" type="roundRect" r:blip="">
+                        <dgm:adjLst>
+                          <dgm:adj idx="1" val="0.1"/>
+                        </dgm:adjLst>
+                      </dgm:shape>
+                      <dgm:presOf axis="self"/>
+                      <dgm:constrLst>
+                        <dgm:constr type="userH"/>
+                        <dgm:constr type="h" refType="userH"/>
+                        <dgm:constr type="tMarg" refType="primFontSz" fact="0.3"/>
+                        <dgm:constr type="bMarg" refType="primFontSz" fact="0.3"/>
+                        <dgm:constr type="lMarg" refType="primFontSz" fact="0.3"/>
+                        <dgm:constr type="rMarg" refType="primFontSz" fact="0.3"/>
+                      </dgm:constrLst>
+                      <dgm:ruleLst>
+                        <dgm:rule type="primFontSz" val="5" fact="NaN" max="NaN"/>
+                      </dgm:ruleLst>
+                    </dgm:layoutNode>
+                    <dgm:choose name="Name19">
+                      <dgm:if name="Name20" axis="des" ptType="node" func="cnt" op="gt" val="0">
+                        <dgm:layoutNode name="parTransThree">
+                          <dgm:alg type="sp"/>
+                          <dgm:shape xmlns:r="http://schemas.openxmlformats.org/officeDocument/2006/relationships" r:blip="">
+                            <dgm:adjLst/>
+                          </dgm:shape>
+                          <dgm:presOf/>
+                          <dgm:constrLst/>
+                          <dgm:ruleLst/>
+                        </dgm:layoutNode>
+                      </dgm:if>
+                      <dgm:else name="Name21"/>
+                    </dgm:choose>
+                    <dgm:layoutNode name="horzThree">
+                      <dgm:choose name="Name22">
+                        <dgm:if name="Name23" func="var" arg="dir" op="equ" val="norm">
+                          <dgm:alg type="lin">
+                            <dgm:param type="linDir" val="fromL"/>
+                            <dgm:param type="nodeVertAlign" val="t"/>
+                          </dgm:alg>
+                        </dgm:if>
+                        <dgm:else name="Name24">
+                          <dgm:alg type="lin">
+                            <dgm:param type="linDir" val="fromR"/>
+                            <dgm:param type="nodeVertAlign" val="t"/>
+                          </dgm:alg>
+                        </dgm:else>
+                      </dgm:choose>
+                      <dgm:shape xmlns:r="http://schemas.openxmlformats.org/officeDocument/2006/relationships" r:blip="">
+                        <dgm:adjLst/>
+                      </dgm:shape>
+                      <dgm:presOf/>
+                      <dgm:constrLst/>
+                      <dgm:ruleLst>
+                        <dgm:rule type="w" val="INF" fact="NaN" max="NaN"/>
+                      </dgm:ruleLst>
+                      <dgm:forEach name="repeat" axis="ch" ptType="node">
+                        <dgm:layoutNode name="vertFour">
+                          <dgm:varLst>
+                            <dgm:chPref val="3"/>
+                          </dgm:varLst>
+                          <dgm:alg type="lin">
+                            <dgm:param type="linDir" val="fromT"/>
+                          </dgm:alg>
+                          <dgm:shape xmlns:r="http://schemas.openxmlformats.org/officeDocument/2006/relationships" r:blip="">
+                            <dgm:adjLst/>
+                          </dgm:shape>
+                          <dgm:presOf/>
+                          <dgm:constrLst>
+                            <dgm:constr type="w" for="ch" forName="txFour" refType="w" refFor="ch" refForName="horzFour" op="gte"/>
+                          </dgm:constrLst>
+                          <dgm:ruleLst/>
+                          <dgm:layoutNode name="txFour">
+                            <dgm:varLst>
+                              <dgm:chPref val="3"/>
+                            </dgm:varLst>
+                            <dgm:alg type="tx"/>
+                            <dgm:shape xmlns:r="http://schemas.openxmlformats.org/officeDocument/2006/relationships" type="roundRect" r:blip="">
+                              <dgm:adjLst>
+                                <dgm:adj idx="1" val="0.1"/>
+                              </dgm:adjLst>
+                            </dgm:shape>
+                            <dgm:presOf axis="self"/>
+                            <dgm:constrLst>
+                              <dgm:constr type="userH"/>
+                              <dgm:constr type="h" refType="userH"/>
+                              <dgm:constr type="tMarg" refType="primFontSz" fact="0.3"/>
+                              <dgm:constr type="bMarg" refType="primFontSz" fact="0.3"/>
+                              <dgm:constr type="lMarg" refType="primFontSz" fact="0.3"/>
+                              <dgm:constr type="rMarg" refType="primFontSz" fact="0.3"/>
+                            </dgm:constrLst>
+                            <dgm:ruleLst>
+                              <dgm:rule type="primFontSz" val="5" fact="NaN" max="NaN"/>
+                            </dgm:ruleLst>
+                          </dgm:layoutNode>
+                          <dgm:choose name="Name25">
+                            <dgm:if name="Name26" axis="des" ptType="node" func="cnt" op="gt" val="0">
+                              <dgm:layoutNode name="parTransFour">
+                                <dgm:alg type="sp"/>
+                                <dgm:shape xmlns:r="http://schemas.openxmlformats.org/officeDocument/2006/relationships" r:blip="">
+                                  <dgm:adjLst/>
+                                </dgm:shape>
+                                <dgm:presOf/>
+                                <dgm:constrLst/>
+                                <dgm:ruleLst/>
+                              </dgm:layoutNode>
+                            </dgm:if>
+                            <dgm:else name="Name27"/>
+                          </dgm:choose>
+                          <dgm:layoutNode name="horzFour">
+                            <dgm:choose name="Name28">
+                              <dgm:if name="Name29" func="var" arg="dir" op="equ" val="norm">
+                                <dgm:alg type="lin">
+                                  <dgm:param type="linDir" val="fromL"/>
+                                  <dgm:param type="nodeVertAlign" val="t"/>
+                                </dgm:alg>
+                              </dgm:if>
+                              <dgm:else name="Name30">
+                                <dgm:alg type="lin">
+                                  <dgm:param type="linDir" val="fromR"/>
+                                  <dgm:param type="nodeVertAlign" val="t"/>
+                                </dgm:alg>
+                              </dgm:else>
+                            </dgm:choose>
+                            <dgm:shape xmlns:r="http://schemas.openxmlformats.org/officeDocument/2006/relationships" r:blip="">
+                              <dgm:adjLst/>
+                            </dgm:shape>
+                            <dgm:presOf/>
+                            <dgm:constrLst/>
+                            <dgm:ruleLst>
+                              <dgm:rule type="w" val="INF" fact="NaN" max="NaN"/>
+                            </dgm:ruleLst>
+                            <dgm:forEach name="Name31" ref="repeat"/>
+                          </dgm:layoutNode>
+                        </dgm:layoutNode>
+                        <dgm:choose name="Name32">
+                          <dgm:if name="Name33" axis="self" ptType="node" func="revPos" op="gte" val="2">
+                            <dgm:forEach name="Name34" axis="followSib" ptType="sibTrans" cnt="1">
+                              <dgm:layoutNode name="sibSpaceFour">
+                                <dgm:alg type="sp"/>
+                                <dgm:shape xmlns:r="http://schemas.openxmlformats.org/officeDocument/2006/relationships" r:blip="">
+                                  <dgm:adjLst/>
+                                </dgm:shape>
+                                <dgm:presOf/>
+                                <dgm:constrLst/>
+                                <dgm:ruleLst/>
+                              </dgm:layoutNode>
+                            </dgm:forEach>
+                          </dgm:if>
+                          <dgm:else name="Name35"/>
+                        </dgm:choose>
+                      </dgm:forEach>
+                    </dgm:layoutNode>
+                  </dgm:layoutNode>
+                  <dgm:choose name="Name36">
+                    <dgm:if name="Name37" axis="self" ptType="node" func="revPos" op="gte" val="2">
+                      <dgm:forEach name="Name38" axis="followSib" ptType="sibTrans" cnt="1">
+                        <dgm:layoutNode name="sibSpaceThree">
+                          <dgm:alg type="sp"/>
+                          <dgm:shape xmlns:r="http://schemas.openxmlformats.org/officeDocument/2006/relationships" r:blip="">
+                            <dgm:adjLst/>
+                          </dgm:shape>
+                          <dgm:presOf/>
+                          <dgm:constrLst/>
+                          <dgm:ruleLst/>
+                        </dgm:layoutNode>
+                      </dgm:forEach>
+                    </dgm:if>
+                    <dgm:else name="Name39"/>
+                  </dgm:choose>
+                </dgm:forEach>
+              </dgm:layoutNode>
+            </dgm:layoutNode>
+            <dgm:choose name="Name40">
+              <dgm:if name="Name41" axis="self" ptType="node" func="revPos" op="gte" val="2">
+                <dgm:forEach name="Name42" axis="followSib" ptType="sibTrans" cnt="1">
+                  <dgm:layoutNode name="sibSpaceTwo">
+                    <dgm:alg type="sp"/>
+                    <dgm:shape xmlns:r="http://schemas.openxmlformats.org/officeDocument/2006/relationships" r:blip="">
+                      <dgm:adjLst/>
+                    </dgm:shape>
+                    <dgm:presOf/>
+                    <dgm:constrLst/>
+                    <dgm:ruleLst/>
+                  </dgm:layoutNode>
+                </dgm:forEach>
+              </dgm:if>
+              <dgm:else name="Name43"/>
+            </dgm:choose>
+          </dgm:forEach>
+        </dgm:layoutNode>
+      </dgm:layoutNode>
+      <dgm:choose name="Name44">
+        <dgm:if name="Name45" axis="self" ptType="node" func="revPos" op="gte" val="2">
+          <dgm:forEach name="Name46" axis="followSib" ptType="sibTrans" cnt="1">
+            <dgm:layoutNode name="sibSpaceOne">
+              <dgm:alg type="sp"/>
+              <dgm:shape xmlns:r="http://schemas.openxmlformats.org/officeDocument/2006/relationships" r:blip="">
+                <dgm:adjLst/>
+              </dgm:shape>
+              <dgm:presOf/>
+              <dgm:constrLst/>
+              <dgm:ruleLst/>
+            </dgm:layoutNode>
+          </dgm:forEach>
+        </dgm:if>
+        <dgm:else name="Name47"/>
+      </dgm:choose>
+    </dgm:forEach>
+  </dgm:layoutNode>
+</dgm:layoutDef>
+</file>
+
+<file path=ppt/diagrams/quickStyle1.xml><?xml version="1.0" encoding="utf-8"?>
+<dgm:styleDef xmlns:dgm="http://schemas.openxmlformats.org/drawingml/2006/diagram" xmlns:a="http://schemas.openxmlformats.org/drawingml/2006/main" uniqueId="urn:microsoft.com/office/officeart/2005/8/quickstyle/simple1">
+  <dgm:title val=""/>
+  <dgm:desc val=""/>
+  <dgm:catLst>
+    <dgm:cat type="simple" pri="10100"/>
+  </dgm:catLst>
+  <dgm:scene3d>
+    <a:camera prst="orthographicFront"/>
+    <a:lightRig rig="threePt" dir="t"/>
+  </dgm:scene3d>
+  <dgm:styleLbl name="node0">
+    <dgm:scene3d>
+      <a:camera prst="orthographicFront"/>
+      <a:lightRig rig="threePt" dir="t"/>
+    </dgm:scene3d>
+    <dgm:sp3d/>
+    <dgm:txPr/>
+    <dgm:style>
+      <a:lnRef idx="2">
+        <a:scrgbClr r="0" g="0" b="0"/>
+      </a:lnRef>
+      <a:fillRef idx="1">
+        <a:scrgbClr r="0" g="0" b="0"/>
+      </a:fillRef>
+      <a:effectRef idx="0">
+        <a:scrgbClr r="0" g="0" b="0"/>
+      </a:effectRef>
+      <a:fontRef idx="minor">
+        <a:schemeClr val="lt1"/>
+      </a:fontRef>
+    </dgm:style>
+  </dgm:styleLbl>
+  <dgm:styleLbl name="lnNode1">
+    <dgm:scene3d>
+      <a:camera prst="orthographicFront"/>
+      <a:lightRig rig="threePt" dir="t"/>
+    </dgm:scene3d>
+    <dgm:sp3d/>
+    <dgm:txPr/>
+    <dgm:style>
+      <a:lnRef idx="2">
+        <a:scrgbClr r="0" g="0" b="0"/>
+      </a:lnRef>
+      <a:fillRef idx="1">
+        <a:scrgbClr r="0" g="0" b="0"/>
+      </a:fillRef>
+      <a:effectRef idx="0">
+        <a:scrgbClr r="0" g="0" b="0"/>
+      </a:effectRef>
+      <a:fontRef idx="minor">
+        <a:schemeClr val="lt1"/>
+      </a:fontRef>
+    </dgm:style>
+  </dgm:styleLbl>
+  <dgm:styleLbl name="vennNode1">
+    <dgm:scene3d>
+      <a:camera prst="orthographicFront"/>
+      <a:lightRig rig="threePt" dir="t"/>
+    </dgm:scene3d>
+    <dgm:sp3d/>
+    <dgm:txPr/>
+    <dgm:style>
+      <a:lnRef idx="2">
+        <a:scrgbClr r="0" g="0" b="0"/>
+      </a:lnRef>
+      <a:fillRef idx="1">
+        <a:scrgbClr r="0" g="0" b="0"/>
+      </a:fillRef>
+      <a:effectRef idx="0">
+        <a:scrgbClr r="0" g="0" b="0"/>
+      </a:effectRef>
+      <a:fontRef idx="minor">
+        <a:schemeClr val="tx1"/>
+      </a:fontRef>
+    </dgm:style>
+  </dgm:styleLbl>
+  <dgm:styleLbl name="alignNode1">
+    <dgm:scene3d>
+      <a:camera prst="orthographicFront"/>
+      <a:lightRig rig="threePt" dir="t"/>
+    </dgm:scene3d>
+    <dgm:sp3d/>
+    <dgm:txPr/>
+    <dgm:style>
+      <a:lnRef idx="2">
+        <a:scrgbClr r="0" g="0" b="0"/>
+      </a:lnRef>
+      <a:fillRef idx="1">
+        <a:scrgbClr r="0" g="0" b="0"/>
+      </a:fillRef>
+      <a:effectRef idx="0">
+        <a:scrgbClr r="0" g="0" b="0"/>
+      </a:effectRef>
+      <a:fontRef idx="minor">
+        <a:schemeClr val="lt1"/>
+      </a:fontRef>
+    </dgm:style>
+  </dgm:styleLbl>
+  <dgm:styleLbl name="node1">
+    <dgm:scene3d>
+      <a:camera prst="orthographicFront"/>
+      <a:lightRig rig="threePt" dir="t"/>
+    </dgm:scene3d>
+    <dgm:sp3d/>
+    <dgm:txPr/>
+    <dgm:style>
+      <a:lnRef idx="2">
+        <a:scrgbClr r="0" g="0" b="0"/>
+      </a:lnRef>
+      <a:fillRef idx="1">
+        <a:scrgbClr r="0" g="0" b="0"/>
+      </a:fillRef>
+      <a:effectRef idx="0">
+        <a:scrgbClr r="0" g="0" b="0"/>
+      </a:effectRef>
+      <a:fontRef idx="minor">
+        <a:schemeClr val="lt1"/>
+      </a:fontRef>
+    </dgm:style>
+  </dgm:styleLbl>
+  <dgm:styleLbl name="node2">
+    <dgm:scene3d>
+      <a:camera prst="orthographicFront"/>
+      <a:lightRig rig="threePt" dir="t"/>
+    </dgm:scene3d>
+    <dgm:sp3d/>
+    <dgm:txPr/>
+    <dgm:style>
+      <a:lnRef idx="2">
+        <a:scrgbClr r="0" g="0" b="0"/>
+      </a:lnRef>
+      <a:fillRef idx="1">
+        <a:scrgbClr r="0" g="0" b="0"/>
+      </a:fillRef>
+      <a:effectRef idx="0">
+        <a:scrgbClr r="0" g="0" b="0"/>
+      </a:effectRef>
+      <a:fontRef idx="minor">
+        <a:schemeClr val="lt1"/>
+      </a:fontRef>
+    </dgm:style>
+  </dgm:styleLbl>
+  <dgm:styleLbl name="node3">
+    <dgm:scene3d>
+      <a:camera prst="orthographicFront"/>
+      <a:lightRig rig="threePt" dir="t"/>
+    </dgm:scene3d>
+    <dgm:sp3d/>
+    <dgm:txPr/>
+    <dgm:style>
+      <a:lnRef idx="2">
+        <a:scrgbClr r="0" g="0" b="0"/>
+      </a:lnRef>
+      <a:fillRef idx="1">
+        <a:scrgbClr r="0" g="0" b="0"/>
+      </a:fillRef>
+      <a:effectRef idx="0">
+        <a:scrgbClr r="0" g="0" b="0"/>
+      </a:effectRef>
+      <a:fontRef idx="minor">
+        <a:schemeClr val="lt1"/>
+      </a:fontRef>
+    </dgm:style>
+  </dgm:styleLbl>
+  <dgm:styleLbl name="node4">
+    <dgm:scene3d>
+      <a:camera prst="orthographicFront"/>
+      <a:lightRig rig="threePt" dir="t"/>
+    </dgm:scene3d>
+    <dgm:sp3d/>
+    <dgm:txPr/>
+    <dgm:style>
+      <a:lnRef idx="2">
+        <a:scrgbClr r="0" g="0" b="0"/>
+      </a:lnRef>
+      <a:fillRef idx="1">
+        <a:scrgbClr r="0" g="0" b="0"/>
+      </a:fillRef>
+      <a:effectRef idx="0">
+        <a:scrgbClr r="0" g="0" b="0"/>
+      </a:effectRef>
+      <a:fontRef idx="minor">
+        <a:schemeClr val="lt1"/>
+      </a:fontRef>
+    </dgm:style>
+  </dgm:styleLbl>
+  <dgm:styleLbl name="fgImgPlace1">
+    <dgm:scene3d>
+      <a:camera prst="orthographicFront"/>
+      <a:lightRig rig="threePt" dir="t"/>
+    </dgm:scene3d>
+    <dgm:sp3d/>
+    <dgm:txPr/>
+    <dgm:style>
+      <a:lnRef idx="2">
+        <a:scrgbClr r="0" g="0" b="0"/>
+      </a:lnRef>
+      <a:fillRef idx="1">
+        <a:scrgbClr r="0" g="0" b="0"/>
+      </a:fillRef>
+      <a:effectRef idx="0">
+        <a:scrgbClr r="0" g="0" b="0"/>
+      </a:effectRef>
+      <a:fontRef idx="minor"/>
+    </dgm:style>
+  </dgm:styleLbl>
+  <dgm:styleLbl name="alignImgPlace1">
+    <dgm:scene3d>
+      <a:camera prst="orthographicFront"/>
+      <a:lightRig rig="threePt" dir="t"/>
+    </dgm:scene3d>
+    <dgm:sp3d/>
+    <dgm:txPr/>
+    <dgm:style>
+      <a:lnRef idx="2">
+        <a:scrgbClr r="0" g="0" b="0"/>
+      </a:lnRef>
+      <a:fillRef idx="1">
+        <a:scrgbClr r="0" g="0" b="0"/>
+      </a:fillRef>
+      <a:effectRef idx="0">
+        <a:scrgbClr r="0" g="0" b="0"/>
+      </a:effectRef>
+      <a:fontRef idx="minor"/>
+    </dgm:style>
+  </dgm:styleLbl>
+  <dgm:styleLbl name="bgImgPlace1">
+    <dgm:scene3d>
+      <a:camera prst="orthographicFront"/>
+      <a:lightRig rig="threePt" dir="t"/>
+    </dgm:scene3d>
+    <dgm:sp3d/>
+    <dgm:txPr/>
+    <dgm:style>
+      <a:lnRef idx="2">
+        <a:scrgbClr r="0" g="0" b="0"/>
+      </a:lnRef>
+      <a:fillRef idx="1">
+        <a:scrgbClr r="0" g="0" b="0"/>
+      </a:fillRef>
+      <a:effectRef idx="0">
+        <a:scrgbClr r="0" g="0" b="0"/>
+      </a:effectRef>
+      <a:fontRef idx="minor"/>
+    </dgm:style>
+  </dgm:styleLbl>
+  <dgm:styleLbl name="sibTrans2D1">
+    <dgm:scene3d>
+      <a:camera prst="orthographicFront"/>
+      <a:lightRig rig="threePt" dir="t"/>
+    </dgm:scene3d>
+    <dgm:sp3d/>
+    <dgm:txPr/>
+    <dgm:style>
+      <a:lnRef idx="0">
+        <a:scrgbClr r="0" g="0" b="0"/>
+      </a:lnRef>
+      <a:fillRef idx="1">
+        <a:scrgbClr r="0" g="0" b="0"/>
+      </a:fillRef>
+      <a:effectRef idx="0">
+        <a:scrgbClr r="0" g="0" b="0"/>
+      </a:effectRef>
+      <a:fontRef idx="minor">
+        <a:schemeClr val="lt1"/>
+      </a:fontRef>
+    </dgm:style>
+  </dgm:styleLbl>
+  <dgm:styleLbl name="fgSibTrans2D1">
+    <dgm:scene3d>
+      <a:camera prst="orthographicFront"/>
+      <a:lightRig rig="threePt" dir="t"/>
+    </dgm:scene3d>
+    <dgm:sp3d/>
+    <dgm:txPr/>
+    <dgm:style>
+      <a:lnRef idx="0">
+        <a:scrgbClr r="0" g="0" b="0"/>
+      </a:lnRef>
+      <a:fillRef idx="1">
+        <a:scrgbClr r="0" g="0" b="0"/>
+      </a:fillRef>
+      <a:effectRef idx="0">
+        <a:scrgbClr r="0" g="0" b="0"/>
+      </a:effectRef>
+      <a:fontRef idx="minor">
+        <a:schemeClr val="lt1"/>
+      </a:fontRef>
+    </dgm:style>
+  </dgm:styleLbl>
+  <dgm:styleLbl name="bgSibTrans2D1">
+    <dgm:scene3d>
+      <a:camera prst="orthographicFront"/>
+      <a:lightRig rig="threePt" dir="t"/>
+    </dgm:scene3d>
+    <dgm:sp3d/>
+    <dgm:txPr/>
+    <dgm:style>
+      <a:lnRef idx="0">
+        <a:scrgbClr r="0" g="0" b="0"/>
+      </a:lnRef>
+      <a:fillRef idx="1">
+        <a:scrgbClr r="0" g="0" b="0"/>
+      </a:fillRef>
+      <a:effectRef idx="0">
+        <a:scrgbClr r="0" g="0" b="0"/>
+      </a:effectRef>
+      <a:fontRef idx="minor">
+        <a:schemeClr val="lt1"/>
+      </a:fontRef>
+    </dgm:style>
+  </dgm:styleLbl>
+  <dgm:styleLbl name="sibTrans1D1">
+    <dgm:scene3d>
+      <a:camera prst="orthographicFront"/>
+      <a:lightRig rig="threePt" dir="t"/>
+    </dgm:scene3d>
+    <dgm:sp3d/>
+    <dgm:txPr/>
+    <dgm:style>
+      <a:lnRef idx="1">
+        <a:scrgbClr r="0" g="0" b="0"/>
+      </a:lnRef>
+      <a:fillRef idx="0">
+        <a:scrgbClr r="0" g="0" b="0"/>
+      </a:fillRef>
+      <a:effectRef idx="0">
+        <a:scrgbClr r="0" g="0" b="0"/>
+      </a:effectRef>
+      <a:fontRef idx="minor"/>
+    </dgm:style>
+  </dgm:styleLbl>
+  <dgm:styleLbl name="callout">
+    <dgm:scene3d>
+      <a:camera prst="orthographicFront"/>
+      <a:lightRig rig="threePt" dir="t"/>
+    </dgm:scene3d>
+    <dgm:sp3d/>
+    <dgm:txPr/>
+    <dgm:style>
+      <a:lnRef idx="2">
+        <a:scrgbClr r="0" g="0" b="0"/>
+      </a:lnRef>
+      <a:fillRef idx="1">
+        <a:scrgbClr r="0" g="0" b="0"/>
+      </a:fillRef>
+      <a:effectRef idx="0">
+        <a:scrgbClr r="0" g="0" b="0"/>
+      </a:effectRef>
+      <a:fontRef idx="minor"/>
+    </dgm:style>
+  </dgm:styleLbl>
+  <dgm:styleLbl name="asst0">
+    <dgm:scene3d>
+      <a:camera prst="orthographicFront"/>
+      <a:lightRig rig="threePt" dir="t"/>
+    </dgm:scene3d>
+    <dgm:sp3d/>
+    <dgm:txPr/>
+    <dgm:style>
+      <a:lnRef idx="2">
+        <a:scrgbClr r="0" g="0" b="0"/>
+      </a:lnRef>
+      <a:fillRef idx="1">
+        <a:scrgbClr r="0" g="0" b="0"/>
+      </a:fillRef>
+      <a:effectRef idx="0">
+        <a:scrgbClr r="0" g="0" b="0"/>
+      </a:effectRef>
+      <a:fontRef idx="minor">
+        <a:schemeClr val="lt1"/>
+      </a:fontRef>
+    </dgm:style>
+  </dgm:styleLbl>
+  <dgm:styleLbl name="asst1">
+    <dgm:scene3d>
+      <a:camera prst="orthographicFront"/>
+      <a:lightRig rig="threePt" dir="t"/>
+    </dgm:scene3d>
+    <dgm:sp3d/>
+    <dgm:txPr/>
+    <dgm:style>
+      <a:lnRef idx="2">
+        <a:scrgbClr r="0" g="0" b="0"/>
+      </a:lnRef>
+      <a:fillRef idx="1">
+        <a:scrgbClr r="0" g="0" b="0"/>
+      </a:fillRef>
+      <a:effectRef idx="0">
+        <a:scrgbClr r="0" g="0" b="0"/>
+      </a:effectRef>
+      <a:fontRef idx="minor">
+        <a:schemeClr val="lt1"/>
+      </a:fontRef>
+    </dgm:style>
+  </dgm:styleLbl>
+  <dgm:styleLbl name="asst2">
+    <dgm:scene3d>
+      <a:camera prst="orthographicFront"/>
+      <a:lightRig rig="threePt" dir="t"/>
+    </dgm:scene3d>
+    <dgm:sp3d/>
+    <dgm:txPr/>
+    <dgm:style>
+      <a:lnRef idx="2">
+        <a:scrgbClr r="0" g="0" b="0"/>
+      </a:lnRef>
+      <a:fillRef idx="1">
+        <a:scrgbClr r="0" g="0" b="0"/>
+      </a:fillRef>
+      <a:effectRef idx="0">
+        <a:scrgbClr r="0" g="0" b="0"/>
+      </a:effectRef>
+      <a:fontRef idx="minor">
+        <a:schemeClr val="lt1"/>
+      </a:fontRef>
+    </dgm:style>
+  </dgm:styleLbl>
+  <dgm:styleLbl name="asst3">
+    <dgm:scene3d>
+      <a:camera prst="orthographicFront"/>
+      <a:lightRig rig="threePt" dir="t"/>
+    </dgm:scene3d>
+    <dgm:sp3d/>
+    <dgm:txPr/>
+    <dgm:style>
+      <a:lnRef idx="2">
+        <a:scrgbClr r="0" g="0" b="0"/>
+      </a:lnRef>
+      <a:fillRef idx="1">
+        <a:scrgbClr r="0" g="0" b="0"/>
+      </a:fillRef>
+      <a:effectRef idx="0">
+        <a:scrgbClr r="0" g="0" b="0"/>
+      </a:effectRef>
+      <a:fontRef idx="minor">
+        <a:schemeClr val="lt1"/>
+      </a:fontRef>
+    </dgm:style>
+  </dgm:styleLbl>
+  <dgm:styleLbl name="asst4">
+    <dgm:scene3d>
+      <a:camera prst="orthographicFront"/>
+      <a:lightRig rig="threePt" dir="t"/>
+    </dgm:scene3d>
+    <dgm:sp3d/>
+    <dgm:txPr/>
+    <dgm:style>
+      <a:lnRef idx="2">
+        <a:scrgbClr r="0" g="0" b="0"/>
+      </a:lnRef>
+      <a:fillRef idx="1">
+        <a:scrgbClr r="0" g="0" b="0"/>
+      </a:fillRef>
+      <a:effectRef idx="0">
+        <a:scrgbClr r="0" g="0" b="0"/>
+      </a:effectRef>
+      <a:fontRef idx="minor">
+        <a:schemeClr val="lt1"/>
+      </a:fontRef>
+    </dgm:style>
+  </dgm:styleLbl>
+  <dgm:styleLbl name="parChTrans2D1">
+    <dgm:scene3d>
+      <a:camera prst="orthographicFront"/>
+      <a:lightRig rig="threePt" dir="t"/>
+    </dgm:scene3d>
+    <dgm:sp3d/>
+    <dgm:txPr/>
+    <dgm:style>
+      <a:lnRef idx="2">
+        <a:scrgbClr r="0" g="0" b="0"/>
+      </a:lnRef>
+      <a:fillRef idx="1">
+        <a:scrgbClr r="0" g="0" b="0"/>
+      </a:fillRef>
+      <a:effectRef idx="0">
+        <a:scrgbClr r="0" g="0" b="0"/>
+      </a:effectRef>
+      <a:fontRef idx="minor">
+        <a:schemeClr val="lt1"/>
+      </a:fontRef>
+    </dgm:style>
+  </dgm:styleLbl>
+  <dgm:styleLbl name="parChTrans2D2">
+    <dgm:scene3d>
+      <a:camera prst="orthographicFront"/>
+      <a:lightRig rig="threePt" dir="t"/>
+    </dgm:scene3d>
+    <dgm:sp3d/>
+    <dgm:txPr/>
+    <dgm:style>
+      <a:lnRef idx="2">
+        <a:scrgbClr r="0" g="0" b="0"/>
+      </a:lnRef>
+      <a:fillRef idx="1">
+        <a:scrgbClr r="0" g="0" b="0"/>
+      </a:fillRef>
+      <a:effectRef idx="0">
+        <a:scrgbClr r="0" g="0" b="0"/>
+      </a:effectRef>
+      <a:fontRef idx="minor">
+        <a:schemeClr val="lt1"/>
+      </a:fontRef>
+    </dgm:style>
+  </dgm:styleLbl>
+  <dgm:styleLbl name="parChTrans2D3">
+    <dgm:scene3d>
+      <a:camera prst="orthographicFront"/>
+      <a:lightRig rig="threePt" dir="t"/>
+    </dgm:scene3d>
+    <dgm:sp3d/>
+    <dgm:txPr/>
+    <dgm:style>
+      <a:lnRef idx="2">
+        <a:scrgbClr r="0" g="0" b="0"/>
+      </a:lnRef>
+      <a:fillRef idx="1">
+        <a:scrgbClr r="0" g="0" b="0"/>
+      </a:fillRef>
+      <a:effectRef idx="0">
+        <a:scrgbClr r="0" g="0" b="0"/>
+      </a:effectRef>
+      <a:fontRef idx="minor">
+        <a:schemeClr val="lt1"/>
+      </a:fontRef>
+    </dgm:style>
+  </dgm:styleLbl>
+  <dgm:styleLbl name="parChTrans2D4">
+    <dgm:scene3d>
+      <a:camera prst="orthographicFront"/>
+      <a:lightRig rig="threePt" dir="t"/>
+    </dgm:scene3d>
+    <dgm:sp3d/>
+    <dgm:txPr/>
+    <dgm:style>
+      <a:lnRef idx="2">
+        <a:scrgbClr r="0" g="0" b="0"/>
+      </a:lnRef>
+      <a:fillRef idx="1">
+        <a:scrgbClr r="0" g="0" b="0"/>
+      </a:fillRef>
+      <a:effectRef idx="0">
+        <a:scrgbClr r="0" g="0" b="0"/>
+      </a:effectRef>
+      <a:fontRef idx="minor">
+        <a:schemeClr val="lt1"/>
+      </a:fontRef>
+    </dgm:style>
+  </dgm:styleLbl>
+  <dgm:styleLbl name="parChTrans1D1">
+    <dgm:scene3d>
+      <a:camera prst="orthographicFront"/>
+      <a:lightRig rig="threePt" dir="t"/>
+    </dgm:scene3d>
+    <dgm:sp3d/>
+    <dgm:txPr/>
+    <dgm:style>
+      <a:lnRef idx="2">
+        <a:scrgbClr r="0" g="0" b="0"/>
+      </a:lnRef>
+      <a:fillRef idx="0">
+        <a:scrgbClr r="0" g="0" b="0"/>
+      </a:fillRef>
+      <a:effectRef idx="0">
+        <a:scrgbClr r="0" g="0" b="0"/>
+      </a:effectRef>
+      <a:fontRef idx="minor"/>
+    </dgm:style>
+  </dgm:styleLbl>
+  <dgm:styleLbl name="parChTrans1D2">
+    <dgm:scene3d>
+      <a:camera prst="orthographicFront"/>
+      <a:lightRig rig="threePt" dir="t"/>
+    </dgm:scene3d>
+    <dgm:sp3d/>
+    <dgm:txPr/>
+    <dgm:style>
+      <a:lnRef idx="2">
+        <a:scrgbClr r="0" g="0" b="0"/>
+      </a:lnRef>
+      <a:fillRef idx="0">
+        <a:scrgbClr r="0" g="0" b="0"/>
+      </a:fillRef>
+      <a:effectRef idx="0">
+        <a:scrgbClr r="0" g="0" b="0"/>
+      </a:effectRef>
+      <a:fontRef idx="minor"/>
+    </dgm:style>
+  </dgm:styleLbl>
+  <dgm:styleLbl name="parChTrans1D3">
+    <dgm:scene3d>
+      <a:camera prst="orthographicFront"/>
+      <a:lightRig rig="threePt" dir="t"/>
+    </dgm:scene3d>
+    <dgm:sp3d/>
+    <dgm:txPr/>
+    <dgm:style>
+      <a:lnRef idx="2">
+        <a:scrgbClr r="0" g="0" b="0"/>
+      </a:lnRef>
+      <a:fillRef idx="0">
+        <a:scrgbClr r="0" g="0" b="0"/>
+      </a:fillRef>
+      <a:effectRef idx="0">
+        <a:scrgbClr r="0" g="0" b="0"/>
+      </a:effectRef>
+      <a:fontRef idx="minor"/>
+    </dgm:style>
+  </dgm:styleLbl>
+  <dgm:styleLbl name="parChTrans1D4">
+    <dgm:scene3d>
+      <a:camera prst="orthographicFront"/>
+      <a:lightRig rig="threePt" dir="t"/>
+    </dgm:scene3d>
+    <dgm:sp3d/>
+    <dgm:txPr/>
+    <dgm:style>
+      <a:lnRef idx="2">
+        <a:scrgbClr r="0" g="0" b="0"/>
+      </a:lnRef>
+      <a:fillRef idx="0">
+        <a:scrgbClr r="0" g="0" b="0"/>
+      </a:fillRef>
+      <a:effectRef idx="0">
+        <a:scrgbClr r="0" g="0" b="0"/>
+      </a:effectRef>
+      <a:fontRef idx="minor"/>
+    </dgm:style>
+  </dgm:styleLbl>
+  <dgm:styleLbl name="fgAcc1">
+    <dgm:scene3d>
+      <a:camera prst="orthographicFront"/>
+      <a:lightRig rig="threePt" dir="t"/>
+    </dgm:scene3d>
+    <dgm:sp3d/>
+    <dgm:txPr/>
+    <dgm:style>
+      <a:lnRef idx="2">
+        <a:scrgbClr r="0" g="0" b="0"/>
+      </a:lnRef>
+      <a:fillRef idx="1">
+        <a:scrgbClr r="0" g="0" b="0"/>
+      </a:fillRef>
+      <a:effectRef idx="0">
+        <a:scrgbClr r="0" g="0" b="0"/>
+      </a:effectRef>
+      <a:fontRef idx="minor"/>
+    </dgm:style>
+  </dgm:styleLbl>
+  <dgm:styleLbl name="conFgAcc1">
+    <dgm:scene3d>
+      <a:camera prst="orthographicFront"/>
+      <a:lightRig rig="threePt" dir="t"/>
+    </dgm:scene3d>
+    <dgm:sp3d/>
+    <dgm:txPr/>
+    <dgm:style>
+      <a:lnRef idx="2">
+        <a:scrgbClr r="0" g="0" b="0"/>
+      </a:lnRef>
+      <a:fillRef idx="1">
+        <a:scrgbClr r="0" g="0" b="0"/>
+      </a:fillRef>
+      <a:effectRef idx="0">
+        <a:scrgbClr r="0" g="0" b="0"/>
+      </a:effectRef>
+      <a:fontRef idx="minor"/>
+    </dgm:style>
+  </dgm:styleLbl>
+  <dgm:styleLbl name="alignAcc1">
+    <dgm:scene3d>
+      <a:camera prst="orthographicFront"/>
+      <a:lightRig rig="threePt" dir="t"/>
+    </dgm:scene3d>
+    <dgm:sp3d/>
+    <dgm:txPr/>
+    <dgm:style>
+      <a:lnRef idx="2">
+        <a:scrgbClr r="0" g="0" b="0"/>
+      </a:lnRef>
+      <a:fillRef idx="1">
+        <a:scrgbClr r="0" g="0" b="0"/>
+      </a:fillRef>
+      <a:effectRef idx="0">
+        <a:scrgbClr r="0" g="0" b="0"/>
+      </a:effectRef>
+      <a:fontRef idx="minor"/>
+    </dgm:style>
+  </dgm:styleLbl>
+  <dgm:styleLbl name="trAlignAcc1">
+    <dgm:scene3d>
+      <a:camera prst="orthographicFront"/>
+      <a:lightRig rig="threePt" dir="t"/>
+    </dgm:scene3d>
+    <dgm:sp3d/>
+    <dgm:txPr/>
+    <dgm:style>
+      <a:lnRef idx="1">
+        <a:scrgbClr r="0" g="0" b="0"/>
+      </a:lnRef>
+      <a:fillRef idx="1">
+        <a:scrgbClr r="0" g="0" b="0"/>
+      </a:fillRef>
+      <a:effectRef idx="0">
+        <a:scrgbClr r="0" g="0" b="0"/>
+      </a:effectRef>
+      <a:fontRef idx="minor"/>
+    </dgm:style>
+  </dgm:styleLbl>
+  <dgm:styleLbl name="bgAcc1">
+    <dgm:scene3d>
+      <a:camera prst="orthographicFront"/>
+      <a:lightRig rig="threePt" dir="t"/>
+    </dgm:scene3d>
+    <dgm:sp3d/>
+    <dgm:txPr/>
+    <dgm:style>
+      <a:lnRef idx="2">
+        <a:scrgbClr r="0" g="0" b="0"/>
+      </a:lnRef>
+      <a:fillRef idx="1">
+        <a:scrgbClr r="0" g="0" b="0"/>
+      </a:fillRef>
+      <a:effectRef idx="0">
+        <a:scrgbClr r="0" g="0" b="0"/>
+      </a:effectRef>
+      <a:fontRef idx="minor"/>
+    </dgm:style>
+  </dgm:styleLbl>
+  <dgm:styleLbl name="solidFgAcc1">
+    <dgm:scene3d>
+      <a:camera prst="orthographicFront"/>
+      <a:lightRig rig="threePt" dir="t"/>
+    </dgm:scene3d>
+    <dgm:sp3d/>
+    <dgm:txPr/>
+    <dgm:style>
+      <a:lnRef idx="2">
+        <a:scrgbClr r="0" g="0" b="0"/>
+      </a:lnRef>
+      <a:fillRef idx="1">
+        <a:scrgbClr r="0" g="0" b="0"/>
+      </a:fillRef>
+      <a:effectRef idx="0">
+        <a:scrgbClr r="0" g="0" b="0"/>
+      </a:effectRef>
+      <a:fontRef idx="minor"/>
+    </dgm:style>
+  </dgm:styleLbl>
+  <dgm:styleLbl name="solidAlignAcc1">
+    <dgm:scene3d>
+      <a:camera prst="orthographicFront"/>
+      <a:lightRig rig="threePt" dir="t"/>
+    </dgm:scene3d>
+    <dgm:sp3d/>
+    <dgm:txPr/>
+    <dgm:style>
+      <a:lnRef idx="2">
+        <a:scrgbClr r="0" g="0" b="0"/>
+      </a:lnRef>
+      <a:fillRef idx="1">
+        <a:scrgbClr r="0" g="0" b="0"/>
+      </a:fillRef>
+      <a:effectRef idx="0">
+        <a:scrgbClr r="0" g="0" b="0"/>
+      </a:effectRef>
+      <a:fontRef idx="minor"/>
+    </dgm:style>
+  </dgm:styleLbl>
+  <dgm:styleLbl name="solidBgAcc1">
+    <dgm:scene3d>
+      <a:camera prst="orthographicFront"/>
+      <a:lightRig rig="threePt" dir="t"/>
+    </dgm:scene3d>
+    <dgm:sp3d/>
+    <dgm:txPr/>
+    <dgm:style>
+      <a:lnRef idx="2">
+        <a:scrgbClr r="0" g="0" b="0"/>
+      </a:lnRef>
+      <a:fillRef idx="1">
+        <a:scrgbClr r="0" g="0" b="0"/>
+      </a:fillRef>
+      <a:effectRef idx="0">
+        <a:scrgbClr r="0" g="0" b="0"/>
+      </a:effectRef>
+      <a:fontRef idx="minor"/>
+    </dgm:style>
+  </dgm:styleLbl>
+  <dgm:styleLbl name="fgAccFollowNode1">
+    <dgm:scene3d>
+      <a:camera prst="orthographicFront"/>
+      <a:lightRig rig="threePt" dir="t"/>
+    </dgm:scene3d>
+    <dgm:sp3d/>
+    <dgm:txPr/>
+    <dgm:style>
+      <a:lnRef idx="2">
+        <a:scrgbClr r="0" g="0" b="0"/>
+      </a:lnRef>
+      <a:fillRef idx="1">
+        <a:scrgbClr r="0" g="0" b="0"/>
+      </a:fillRef>
+      <a:effectRef idx="0">
+        <a:scrgbClr r="0" g="0" b="0"/>
+      </a:effectRef>
+      <a:fontRef idx="minor"/>
+    </dgm:style>
+  </dgm:styleLbl>
+  <dgm:styleLbl name="alignAccFollowNode1">
+    <dgm:scene3d>
+      <a:camera prst="orthographicFront"/>
+      <a:lightRig rig="threePt" dir="t"/>
+    </dgm:scene3d>
+    <dgm:sp3d/>
+    <dgm:txPr/>
+    <dgm:style>
+      <a:lnRef idx="2">
+        <a:scrgbClr r="0" g="0" b="0"/>
+      </a:lnRef>
+      <a:fillRef idx="1">
+        <a:scrgbClr r="0" g="0" b="0"/>
+      </a:fillRef>
+      <a:effectRef idx="0">
+        <a:scrgbClr r="0" g="0" b="0"/>
+      </a:effectRef>
+      <a:fontRef idx="minor"/>
+    </dgm:style>
+  </dgm:styleLbl>
+  <dgm:styleLbl name="bgAccFollowNode1">
+    <dgm:scene3d>
+      <a:camera prst="orthographicFront"/>
+      <a:lightRig rig="threePt" dir="t"/>
+    </dgm:scene3d>
+    <dgm:sp3d/>
+    <dgm:txPr/>
+    <dgm:style>
+      <a:lnRef idx="2">
+        <a:scrgbClr r="0" g="0" b="0"/>
+      </a:lnRef>
+      <a:fillRef idx="1">
+        <a:scrgbClr r="0" g="0" b="0"/>
+      </a:fillRef>
+      <a:effectRef idx="0">
+        <a:scrgbClr r="0" g="0" b="0"/>
+      </a:effectRef>
+      <a:fontRef idx="minor"/>
+    </dgm:style>
+  </dgm:styleLbl>
+  <dgm:styleLbl name="fgAcc0">
+    <dgm:scene3d>
+      <a:camera prst="orthographicFront"/>
+      <a:lightRig rig="threePt" dir="t"/>
+    </dgm:scene3d>
+    <dgm:sp3d/>
+    <dgm:txPr/>
+    <dgm:style>
+      <a:lnRef idx="2">
+        <a:scrgbClr r="0" g="0" b="0"/>
+      </a:lnRef>
+      <a:fillRef idx="1">
+        <a:scrgbClr r="0" g="0" b="0"/>
+      </a:fillRef>
+      <a:effectRef idx="0">
+        <a:scrgbClr r="0" g="0" b="0"/>
+      </a:effectRef>
+      <a:fontRef idx="minor"/>
+    </dgm:style>
+  </dgm:styleLbl>
+  <dgm:styleLbl name="fgAcc2">
+    <dgm:scene3d>
+      <a:camera prst="orthographicFront"/>
+      <a:lightRig rig="threePt" dir="t"/>
+    </dgm:scene3d>
+    <dgm:sp3d/>
+    <dgm:txPr/>
+    <dgm:style>
+      <a:lnRef idx="2">
+        <a:scrgbClr r="0" g="0" b="0"/>
+      </a:lnRef>
+      <a:fillRef idx="1">
+        <a:scrgbClr r="0" g="0" b="0"/>
+      </a:fillRef>
+      <a:effectRef idx="0">
+        <a:scrgbClr r="0" g="0" b="0"/>
+      </a:effectRef>
+      <a:fontRef idx="minor"/>
+    </dgm:style>
+  </dgm:styleLbl>
+  <dgm:styleLbl name="fgAcc3">
+    <dgm:scene3d>
+      <a:camera prst="orthographicFront"/>
+      <a:lightRig rig="threePt" dir="t"/>
+    </dgm:scene3d>
+    <dgm:sp3d/>
+    <dgm:txPr/>
+    <dgm:style>
+      <a:lnRef idx="2">
+        <a:scrgbClr r="0" g="0" b="0"/>
+      </a:lnRef>
+      <a:fillRef idx="1">
+        <a:scrgbClr r="0" g="0" b="0"/>
+      </a:fillRef>
+      <a:effectRef idx="0">
+        <a:scrgbClr r="0" g="0" b="0"/>
+      </a:effectRef>
+      <a:fontRef idx="minor"/>
+    </dgm:style>
+  </dgm:styleLbl>
+  <dgm:styleLbl name="fgAcc4">
+    <dgm:scene3d>
+      <a:camera prst="orthographicFront"/>
+      <a:lightRig rig="threePt" dir="t"/>
+    </dgm:scene3d>
+    <dgm:sp3d/>
+    <dgm:txPr/>
+    <dgm:style>
+      <a:lnRef idx="2">
+        <a:scrgbClr r="0" g="0" b="0"/>
+      </a:lnRef>
+      <a:fillRef idx="1">
+        <a:scrgbClr r="0" g="0" b="0"/>
+      </a:fillRef>
+      <a:effectRef idx="0">
+        <a:scrgbClr r="0" g="0" b="0"/>
+      </a:effectRef>
+      <a:fontRef idx="minor"/>
+    </dgm:style>
+  </dgm:styleLbl>
+  <dgm:styleLbl name="bgShp">
+    <dgm:scene3d>
+      <a:camera prst="orthographicFront"/>
+      <a:lightRig rig="threePt" dir="t"/>
+    </dgm:scene3d>
+    <dgm:sp3d/>
+    <dgm:txPr/>
+    <dgm:style>
+      <a:lnRef idx="0">
+        <a:scrgbClr r="0" g="0" b="0"/>
+      </a:lnRef>
+      <a:fillRef idx="1">
+        <a:scrgbClr r="0" g="0" b="0"/>
+      </a:fillRef>
+      <a:effectRef idx="0">
+        <a:scrgbClr r="0" g="0" b="0"/>
+      </a:effectRef>
+      <a:fontRef idx="minor"/>
+    </dgm:style>
+  </dgm:styleLbl>
+  <dgm:styleLbl name="dkBgShp">
+    <dgm:scene3d>
+      <a:camera prst="orthographicFront"/>
+      <a:lightRig rig="threePt" dir="t"/>
+    </dgm:scene3d>
+    <dgm:sp3d/>
+    <dgm:txPr/>
+    <dgm:style>
+      <a:lnRef idx="0">
+        <a:scrgbClr r="0" g="0" b="0"/>
+      </a:lnRef>
+      <a:fillRef idx="1">
+        <a:scrgbClr r="0" g="0" b="0"/>
+      </a:fillRef>
+      <a:effectRef idx="0">
+        <a:scrgbClr r="0" g="0" b="0"/>
+      </a:effectRef>
+      <a:fontRef idx="minor"/>
+    </dgm:style>
+  </dgm:styleLbl>
+  <dgm:styleLbl name="trBgShp">
+    <dgm:scene3d>
+      <a:camera prst="orthographicFront"/>
+      <a:lightRig rig="threePt" dir="t"/>
+    </dgm:scene3d>
+    <dgm:sp3d/>
+    <dgm:txPr/>
+    <dgm:style>
+      <a:lnRef idx="0">
+        <a:scrgbClr r="0" g="0" b="0"/>
+      </a:lnRef>
+      <a:fillRef idx="1">
+        <a:scrgbClr r="0" g="0" b="0"/>
+      </a:fillRef>
+      <a:effectRef idx="0">
+        <a:scrgbClr r="0" g="0" b="0"/>
+      </a:effectRef>
+      <a:fontRef idx="minor"/>
+    </dgm:style>
+  </dgm:styleLbl>
+  <dgm:styleLbl name="fgShp">
+    <dgm:scene3d>
+      <a:camera prst="orthographicFront"/>
+      <a:lightRig rig="threePt" dir="t"/>
+    </dgm:scene3d>
+    <dgm:sp3d/>
+    <dgm:txPr/>
+    <dgm:style>
+      <a:lnRef idx="2">
+        <a:scrgbClr r="0" g="0" b="0"/>
+      </a:lnRef>
+      <a:fillRef idx="1">
+        <a:scrgbClr r="0" g="0" b="0"/>
+      </a:fillRef>
+      <a:effectRef idx="0">
+        <a:scrgbClr r="0" g="0" b="0"/>
+      </a:effectRef>
+      <a:fontRef idx="minor"/>
+    </dgm:style>
+  </dgm:styleLbl>
+  <dgm:styleLbl name="revTx">
+    <dgm:scene3d>
+      <a:camera prst="orthographicFront"/>
+      <a:lightRig rig="threePt" dir="t"/>
+    </dgm:scene3d>
+    <dgm:sp3d/>
+    <dgm:txPr/>
+    <dgm:style>
+      <a:lnRef idx="0">
+        <a:scrgbClr r="0" g="0" b="0"/>
+      </a:lnRef>
+      <a:fillRef idx="0">
+        <a:scrgbClr r="0" g="0" b="0"/>
+      </a:fillRef>
+      <a:effectRef idx="0">
+        <a:scrgbClr r="0" g="0" b="0"/>
+      </a:effectRef>
+      <a:fontRef idx="minor"/>
+    </dgm:style>
+  </dgm:styleLbl>
+</dgm:styleDef>
 </file>
 
 <file path=ppt/slideLayouts/slideLayout1.xml><?xml version="1.0" encoding="utf-8"?>
@@ -673,7 +3748,7 @@
           <a:p>
             <a:fld id="{440EA803-8BE5-424C-9343-45256677A8CB}" type="datetimeFigureOut">
               <a:rPr lang="en-GB" smtClean="0"/>
-              <a:t>16/11/2025</a:t>
+              <a:t>18/11/2025</a:t>
             </a:fld>
             <a:endParaRPr lang="en-GB"/>
           </a:p>
@@ -871,7 +3946,7 @@
           <a:p>
             <a:fld id="{440EA803-8BE5-424C-9343-45256677A8CB}" type="datetimeFigureOut">
               <a:rPr lang="en-GB" smtClean="0"/>
-              <a:t>16/11/2025</a:t>
+              <a:t>18/11/2025</a:t>
             </a:fld>
             <a:endParaRPr lang="en-GB"/>
           </a:p>
@@ -1079,7 +4154,7 @@
           <a:p>
             <a:fld id="{440EA803-8BE5-424C-9343-45256677A8CB}" type="datetimeFigureOut">
               <a:rPr lang="en-GB" smtClean="0"/>
-              <a:t>16/11/2025</a:t>
+              <a:t>18/11/2025</a:t>
             </a:fld>
             <a:endParaRPr lang="en-GB"/>
           </a:p>
@@ -1277,7 +4352,7 @@
           <a:p>
             <a:fld id="{440EA803-8BE5-424C-9343-45256677A8CB}" type="datetimeFigureOut">
               <a:rPr lang="en-GB" smtClean="0"/>
-              <a:t>16/11/2025</a:t>
+              <a:t>18/11/2025</a:t>
             </a:fld>
             <a:endParaRPr lang="en-GB"/>
           </a:p>
@@ -1552,7 +4627,7 @@
           <a:p>
             <a:fld id="{440EA803-8BE5-424C-9343-45256677A8CB}" type="datetimeFigureOut">
               <a:rPr lang="en-GB" smtClean="0"/>
-              <a:t>16/11/2025</a:t>
+              <a:t>18/11/2025</a:t>
             </a:fld>
             <a:endParaRPr lang="en-GB"/>
           </a:p>
@@ -1817,7 +4892,7 @@
           <a:p>
             <a:fld id="{440EA803-8BE5-424C-9343-45256677A8CB}" type="datetimeFigureOut">
               <a:rPr lang="en-GB" smtClean="0"/>
-              <a:t>16/11/2025</a:t>
+              <a:t>18/11/2025</a:t>
             </a:fld>
             <a:endParaRPr lang="en-GB"/>
           </a:p>
@@ -2229,7 +5304,7 @@
           <a:p>
             <a:fld id="{440EA803-8BE5-424C-9343-45256677A8CB}" type="datetimeFigureOut">
               <a:rPr lang="en-GB" smtClean="0"/>
-              <a:t>16/11/2025</a:t>
+              <a:t>18/11/2025</a:t>
             </a:fld>
             <a:endParaRPr lang="en-GB"/>
           </a:p>
@@ -2370,7 +5445,7 @@
           <a:p>
             <a:fld id="{440EA803-8BE5-424C-9343-45256677A8CB}" type="datetimeFigureOut">
               <a:rPr lang="en-GB" smtClean="0"/>
-              <a:t>16/11/2025</a:t>
+              <a:t>18/11/2025</a:t>
             </a:fld>
             <a:endParaRPr lang="en-GB"/>
           </a:p>
@@ -2483,7 +5558,7 @@
           <a:p>
             <a:fld id="{440EA803-8BE5-424C-9343-45256677A8CB}" type="datetimeFigureOut">
               <a:rPr lang="en-GB" smtClean="0"/>
-              <a:t>16/11/2025</a:t>
+              <a:t>18/11/2025</a:t>
             </a:fld>
             <a:endParaRPr lang="en-GB"/>
           </a:p>
@@ -2794,7 +5869,7 @@
           <a:p>
             <a:fld id="{440EA803-8BE5-424C-9343-45256677A8CB}" type="datetimeFigureOut">
               <a:rPr lang="en-GB" smtClean="0"/>
-              <a:t>16/11/2025</a:t>
+              <a:t>18/11/2025</a:t>
             </a:fld>
             <a:endParaRPr lang="en-GB"/>
           </a:p>
@@ -3082,7 +6157,7 @@
           <a:p>
             <a:fld id="{440EA803-8BE5-424C-9343-45256677A8CB}" type="datetimeFigureOut">
               <a:rPr lang="en-GB" smtClean="0"/>
-              <a:t>16/11/2025</a:t>
+              <a:t>18/11/2025</a:t>
             </a:fld>
             <a:endParaRPr lang="en-GB"/>
           </a:p>
@@ -3323,7 +6398,7 @@
           <a:p>
             <a:fld id="{440EA803-8BE5-424C-9343-45256677A8CB}" type="datetimeFigureOut">
               <a:rPr lang="en-GB" smtClean="0"/>
-              <a:t>16/11/2025</a:t>
+              <a:t>18/11/2025</a:t>
             </a:fld>
             <a:endParaRPr lang="en-GB"/>
           </a:p>
@@ -3740,6 +6815,144 @@
           <a:chExt cx="0" cy="0"/>
         </a:xfrm>
       </p:grpSpPr>
+      <p:sp>
+        <p:nvSpPr>
+          <p:cNvPr id="7" name="TextBox 6">
+            <a:extLst>
+              <a:ext uri="{FF2B5EF4-FFF2-40B4-BE49-F238E27FC236}">
+                <a16:creationId xmlns:a16="http://schemas.microsoft.com/office/drawing/2014/main" id="{0CDEC4EC-4157-A423-AF96-DF013CC33AF5}"/>
+              </a:ext>
+            </a:extLst>
+          </p:cNvPr>
+          <p:cNvSpPr txBox="1"/>
+          <p:nvPr/>
+        </p:nvSpPr>
+        <p:spPr>
+          <a:xfrm>
+            <a:off x="729688" y="762994"/>
+            <a:ext cx="10807888" cy="338554"/>
+          </a:xfrm>
+          <a:prstGeom prst="rect">
+            <a:avLst/>
+          </a:prstGeom>
+          <a:noFill/>
+        </p:spPr>
+        <p:txBody>
+          <a:bodyPr wrap="square">
+            <a:spAutoFit/>
+          </a:bodyPr>
+          <a:lstStyle/>
+          <a:p>
+            <a:r>
+              <a:rPr lang="en-US" sz="1600"/>
+              <a:t>Share of valid and invalid estimations by solver method</a:t>
+            </a:r>
+            <a:endParaRPr lang="en-GB" sz="1600"/>
+          </a:p>
+        </p:txBody>
+      </p:sp>
+      <p:sp>
+        <p:nvSpPr>
+          <p:cNvPr id="8" name="TextBox 7">
+            <a:extLst>
+              <a:ext uri="{FF2B5EF4-FFF2-40B4-BE49-F238E27FC236}">
+                <a16:creationId xmlns:a16="http://schemas.microsoft.com/office/drawing/2014/main" id="{5CB157B4-481F-79FA-4289-54BA5685A926}"/>
+              </a:ext>
+            </a:extLst>
+          </p:cNvPr>
+          <p:cNvSpPr txBox="1"/>
+          <p:nvPr/>
+        </p:nvSpPr>
+        <p:spPr>
+          <a:xfrm>
+            <a:off x="729688" y="0"/>
+            <a:ext cx="10807888" cy="830997"/>
+          </a:xfrm>
+          <a:prstGeom prst="rect">
+            <a:avLst/>
+          </a:prstGeom>
+          <a:noFill/>
+        </p:spPr>
+        <p:txBody>
+          <a:bodyPr wrap="square">
+            <a:spAutoFit/>
+          </a:bodyPr>
+          <a:lstStyle/>
+          <a:p>
+            <a:r>
+              <a:rPr lang="en-US" sz="2400" b="1"/>
+              <a:t>Newton, L-BFGS-B, DE, BFGS, and SANN provide valid estimations while NM, PORT, CG, Nelder-Mead, and LM do not</a:t>
+            </a:r>
+            <a:endParaRPr lang="en-GB" sz="2400" b="1"/>
+          </a:p>
+        </p:txBody>
+      </p:sp>
+      <p:pic>
+        <p:nvPicPr>
+          <p:cNvPr id="12" name="Graphic 11">
+            <a:extLst>
+              <a:ext uri="{FF2B5EF4-FFF2-40B4-BE49-F238E27FC236}">
+                <a16:creationId xmlns:a16="http://schemas.microsoft.com/office/drawing/2014/main" id="{872101D7-FC0A-8F74-D2EC-723C0DB7C559}"/>
+              </a:ext>
+            </a:extLst>
+          </p:cNvPr>
+          <p:cNvPicPr>
+            <a:picLocks noChangeAspect="1"/>
+          </p:cNvPicPr>
+          <p:nvPr/>
+        </p:nvPicPr>
+        <p:blipFill>
+          <a:blip r:embed="rId2">
+            <a:extLst>
+              <a:ext uri="{96DAC541-7B7A-43D3-8B79-37D633B846F1}">
+                <asvg:svgBlip xmlns:asvg="http://schemas.microsoft.com/office/drawing/2016/SVG/main" r:embed="rId3"/>
+              </a:ext>
+            </a:extLst>
+          </a:blip>
+          <a:stretch>
+            <a:fillRect/>
+          </a:stretch>
+        </p:blipFill>
+        <p:spPr>
+          <a:xfrm>
+            <a:off x="2266950" y="1314450"/>
+            <a:ext cx="7658100" cy="4229100"/>
+          </a:xfrm>
+          <a:prstGeom prst="rect">
+            <a:avLst/>
+          </a:prstGeom>
+        </p:spPr>
+      </p:pic>
+    </p:spTree>
+    <p:extLst>
+      <p:ext uri="{BB962C8B-B14F-4D97-AF65-F5344CB8AC3E}">
+        <p14:creationId xmlns:p14="http://schemas.microsoft.com/office/powerpoint/2010/main" val="3115004336"/>
+      </p:ext>
+    </p:extLst>
+  </p:cSld>
+  <p:clrMapOvr>
+    <a:masterClrMapping/>
+  </p:clrMapOvr>
+</p:sld>
+</file>
+
+<file path=ppt/slides/slide2.xml><?xml version="1.0" encoding="utf-8"?>
+<p:sld xmlns:a="http://schemas.openxmlformats.org/drawingml/2006/main" xmlns:r="http://schemas.openxmlformats.org/officeDocument/2006/relationships" xmlns:p="http://schemas.openxmlformats.org/presentationml/2006/main">
+  <p:cSld>
+    <p:spTree>
+      <p:nvGrpSpPr>
+        <p:cNvPr id="1" name=""/>
+        <p:cNvGrpSpPr/>
+        <p:nvPr/>
+      </p:nvGrpSpPr>
+      <p:grpSpPr>
+        <a:xfrm>
+          <a:off x="0" y="0"/>
+          <a:ext cx="0" cy="0"/>
+          <a:chOff x="0" y="0"/>
+          <a:chExt cx="0" cy="0"/>
+        </a:xfrm>
+      </p:grpSpPr>
       <p:pic>
         <p:nvPicPr>
           <p:cNvPr id="5" name="Graphic 4">
@@ -3861,7 +7074,7 @@
           <a:lstStyle/>
           <a:p>
             <a:r>
-              <a:rPr lang="en-US" sz="1600" b="1" dirty="0">
+              <a:rPr lang="en-US" sz="1600" b="1">
                 <a:solidFill>
                   <a:schemeClr val="tx1">
                     <a:lumMod val="65000"/>
@@ -3872,7 +7085,7 @@
               <a:t>A</a:t>
             </a:r>
             <a:r>
-              <a:rPr lang="en-US" sz="1600" dirty="0">
+              <a:rPr lang="en-US" sz="1600">
                 <a:solidFill>
                   <a:schemeClr val="tx1">
                     <a:lumMod val="65000"/>
@@ -3885,7 +7098,7 @@
           </a:p>
           <a:p>
             <a:r>
-              <a:rPr lang="en-US" sz="1600" b="1" dirty="0">
+              <a:rPr lang="en-US" sz="1600" b="1">
                 <a:solidFill>
                   <a:schemeClr val="tx1">
                     <a:lumMod val="65000"/>
@@ -3896,7 +7109,7 @@
               <a:t>B</a:t>
             </a:r>
             <a:r>
-              <a:rPr lang="en-US" sz="1600" dirty="0">
+              <a:rPr lang="en-US" sz="1600">
                 <a:solidFill>
                   <a:schemeClr val="tx1">
                     <a:lumMod val="65000"/>
@@ -3906,7 +7119,7 @@
               </a:rPr>
               <a:t>  Value filter</a:t>
             </a:r>
-            <a:endParaRPr lang="en-GB" sz="1600" dirty="0">
+            <a:endParaRPr lang="en-GB" sz="1600">
               <a:solidFill>
                 <a:schemeClr val="tx1">
                   <a:lumMod val="65000"/>
@@ -3946,10 +7159,10 @@
           <a:lstStyle/>
           <a:p>
             <a:r>
-              <a:rPr lang="en-US" sz="1600" dirty="0"/>
+              <a:rPr lang="en-US" sz="1600"/>
               <a:t>Number of estimations by type of validity per solver</a:t>
             </a:r>
-            <a:endParaRPr lang="en-GB" sz="1600" dirty="0"/>
+            <a:endParaRPr lang="en-GB" sz="1600"/>
           </a:p>
         </p:txBody>
       </p:sp>
@@ -3982,10 +7195,10 @@
           <a:lstStyle/>
           <a:p>
             <a:r>
-              <a:rPr lang="en-US" sz="2400" b="1" dirty="0"/>
+              <a:rPr lang="en-US" sz="2400" b="1"/>
               <a:t>Invalid estimations are a mix of solvers having issues converging or returning parameter values outside of the validity filters</a:t>
             </a:r>
-            <a:endParaRPr lang="en-GB" sz="2400" b="1" dirty="0"/>
+            <a:endParaRPr lang="en-GB" sz="2400" b="1"/>
           </a:p>
         </p:txBody>
       </p:sp>
@@ -4019,7 +7232,7 @@
           <a:p>
             <a:pPr algn="ctr"/>
             <a:r>
-              <a:rPr lang="en-US" sz="1600" b="1" dirty="0">
+              <a:rPr lang="en-US" sz="1600" b="1">
                 <a:solidFill>
                   <a:schemeClr val="tx1">
                     <a:lumMod val="65000"/>
@@ -4029,7 +7242,7 @@
               </a:rPr>
               <a:t>B</a:t>
             </a:r>
-            <a:endParaRPr lang="en-GB" sz="1600" dirty="0"/>
+            <a:endParaRPr lang="en-GB" sz="1600"/>
           </a:p>
         </p:txBody>
       </p:sp>
@@ -4063,7 +7276,7 @@
           <a:p>
             <a:pPr algn="ctr"/>
             <a:r>
-              <a:rPr lang="en-US" sz="1600" b="1" dirty="0">
+              <a:rPr lang="en-US" sz="1600" b="1">
                 <a:solidFill>
                   <a:schemeClr val="tx1">
                     <a:lumMod val="65000"/>
@@ -4073,7 +7286,7 @@
               </a:rPr>
               <a:t>B</a:t>
             </a:r>
-            <a:endParaRPr lang="en-GB" sz="1600" dirty="0"/>
+            <a:endParaRPr lang="en-GB" sz="1600"/>
           </a:p>
         </p:txBody>
       </p:sp>
@@ -4107,7 +7320,7 @@
           <a:p>
             <a:pPr algn="ctr"/>
             <a:r>
-              <a:rPr lang="en-US" sz="1600" b="1" dirty="0">
+              <a:rPr lang="en-US" sz="1600" b="1">
                 <a:solidFill>
                   <a:schemeClr val="tx1">
                     <a:lumMod val="65000"/>
@@ -4117,7 +7330,7 @@
               </a:rPr>
               <a:t>B</a:t>
             </a:r>
-            <a:endParaRPr lang="en-GB" sz="1600" dirty="0"/>
+            <a:endParaRPr lang="en-GB" sz="1600"/>
           </a:p>
         </p:txBody>
       </p:sp>
@@ -4151,7 +7364,7 @@
           <a:p>
             <a:pPr algn="ctr"/>
             <a:r>
-              <a:rPr lang="en-US" sz="1600" b="1" dirty="0">
+              <a:rPr lang="en-US" sz="1600" b="1">
                 <a:solidFill>
                   <a:schemeClr val="tx1">
                     <a:lumMod val="65000"/>
@@ -4161,7 +7374,7 @@
               </a:rPr>
               <a:t>B</a:t>
             </a:r>
-            <a:endParaRPr lang="en-GB" sz="1600" dirty="0"/>
+            <a:endParaRPr lang="en-GB" sz="1600"/>
           </a:p>
         </p:txBody>
       </p:sp>
@@ -4195,7 +7408,7 @@
           <a:p>
             <a:pPr algn="ctr"/>
             <a:r>
-              <a:rPr lang="en-US" sz="1600" b="1" dirty="0">
+              <a:rPr lang="en-US" sz="1600" b="1">
                 <a:solidFill>
                   <a:schemeClr val="tx1">
                     <a:lumMod val="65000"/>
@@ -4205,7 +7418,7 @@
               </a:rPr>
               <a:t>A</a:t>
             </a:r>
-            <a:endParaRPr lang="en-GB" sz="1600" dirty="0"/>
+            <a:endParaRPr lang="en-GB" sz="1600"/>
           </a:p>
         </p:txBody>
       </p:sp>
@@ -4239,7 +7452,7 @@
           <a:p>
             <a:pPr algn="ctr"/>
             <a:r>
-              <a:rPr lang="en-US" sz="1600" b="1" dirty="0">
+              <a:rPr lang="en-US" sz="1600" b="1">
                 <a:solidFill>
                   <a:schemeClr val="tx1">
                     <a:lumMod val="65000"/>
@@ -4249,7 +7462,7 @@
               </a:rPr>
               <a:t>A</a:t>
             </a:r>
-            <a:endParaRPr lang="en-GB" sz="1600" dirty="0"/>
+            <a:endParaRPr lang="en-GB" sz="1600"/>
           </a:p>
         </p:txBody>
       </p:sp>
@@ -4283,7 +7496,7 @@
           <a:p>
             <a:pPr algn="ctr"/>
             <a:r>
-              <a:rPr lang="en-US" sz="1600" b="1" dirty="0">
+              <a:rPr lang="en-US" sz="1600" b="1">
                 <a:solidFill>
                   <a:schemeClr val="tx1">
                     <a:lumMod val="65000"/>
@@ -4293,7 +7506,7 @@
               </a:rPr>
               <a:t>A</a:t>
             </a:r>
-            <a:endParaRPr lang="en-GB" sz="1600" dirty="0"/>
+            <a:endParaRPr lang="en-GB" sz="1600"/>
           </a:p>
         </p:txBody>
       </p:sp>
@@ -4327,7 +7540,7 @@
           <a:p>
             <a:pPr algn="ctr"/>
             <a:r>
-              <a:rPr lang="en-US" sz="1600" b="1" dirty="0">
+              <a:rPr lang="en-US" sz="1600" b="1">
                 <a:solidFill>
                   <a:schemeClr val="tx1">
                     <a:lumMod val="65000"/>
@@ -4337,7 +7550,7 @@
               </a:rPr>
               <a:t>B</a:t>
             </a:r>
-            <a:endParaRPr lang="en-GB" sz="1600" dirty="0"/>
+            <a:endParaRPr lang="en-GB" sz="1600"/>
           </a:p>
         </p:txBody>
       </p:sp>
@@ -4371,7 +7584,7 @@
           <a:p>
             <a:pPr algn="ctr"/>
             <a:r>
-              <a:rPr lang="en-US" sz="1600" b="1" dirty="0">
+              <a:rPr lang="en-US" sz="1600" b="1">
                 <a:solidFill>
                   <a:schemeClr val="tx1">
                     <a:lumMod val="65000"/>
@@ -4381,7 +7594,7 @@
               </a:rPr>
               <a:t>A</a:t>
             </a:r>
-            <a:endParaRPr lang="en-GB" sz="1600" dirty="0"/>
+            <a:endParaRPr lang="en-GB" sz="1600"/>
           </a:p>
         </p:txBody>
       </p:sp>
@@ -4415,7 +7628,7 @@
           <a:p>
             <a:pPr algn="ctr"/>
             <a:r>
-              <a:rPr lang="en-US" sz="1600" b="1" dirty="0">
+              <a:rPr lang="en-US" sz="1600" b="1">
                 <a:solidFill>
                   <a:schemeClr val="tx1">
                     <a:lumMod val="65000"/>
@@ -4425,7 +7638,7 @@
               </a:rPr>
               <a:t>A</a:t>
             </a:r>
-            <a:endParaRPr lang="en-GB" sz="1600" dirty="0"/>
+            <a:endParaRPr lang="en-GB" sz="1600"/>
           </a:p>
         </p:txBody>
       </p:sp>
@@ -4442,7 +7655,7 @@
 </p:sld>
 </file>
 
-<file path=ppt/slides/slide2.xml><?xml version="1.0" encoding="utf-8"?>
+<file path=ppt/slides/slide3.xml><?xml version="1.0" encoding="utf-8"?>
 <p:sld xmlns:a="http://schemas.openxmlformats.org/drawingml/2006/main" xmlns:r="http://schemas.openxmlformats.org/officeDocument/2006/relationships" xmlns:p="http://schemas.openxmlformats.org/presentationml/2006/main">
   <p:cSld>
     <p:spTree>
@@ -4494,10 +7707,10 @@
           <a:lstStyle/>
           <a:p>
             <a:r>
-              <a:rPr lang="en-US" sz="1600" dirty="0"/>
+              <a:rPr lang="en-US" sz="1600"/>
               <a:t>Number of estimations by type of validity per solver</a:t>
             </a:r>
-            <a:endParaRPr lang="en-GB" sz="1600" dirty="0"/>
+            <a:endParaRPr lang="en-GB" sz="1600"/>
           </a:p>
         </p:txBody>
       </p:sp>
@@ -4530,10 +7743,10 @@
           <a:lstStyle/>
           <a:p>
             <a:r>
-              <a:rPr lang="en-US" sz="2400" b="1" dirty="0"/>
+              <a:rPr lang="en-US" sz="2400" b="1"/>
               <a:t>Invalid estimations are a mix of solvers having issues converging or returning parameter values outside of the validity filters</a:t>
             </a:r>
-            <a:endParaRPr lang="en-GB" sz="2400" b="1" dirty="0"/>
+            <a:endParaRPr lang="en-GB" sz="2400" b="1"/>
           </a:p>
         </p:txBody>
       </p:sp>
@@ -4559,14 +7772,15 @@
               </a:ext>
             </a:extLst>
           </a:blip>
+          <a:srcRect t="12016"/>
           <a:stretch>
             <a:fillRect/>
           </a:stretch>
         </p:blipFill>
         <p:spPr>
           <a:xfrm>
-            <a:off x="490537" y="1495426"/>
-            <a:ext cx="9277929" cy="4767262"/>
+            <a:off x="490537" y="1701800"/>
+            <a:ext cx="10088563" cy="4560888"/>
           </a:xfrm>
           <a:prstGeom prst="rect">
             <a:avLst/>
@@ -4586,12 +7800,18 @@
 </p:sld>
 </file>
 
-<file path=ppt/slides/slide3.xml><?xml version="1.0" encoding="utf-8"?>
+<file path=ppt/slides/slide4.xml><?xml version="1.0" encoding="utf-8"?>
 <p:sld xmlns:a="http://schemas.openxmlformats.org/drawingml/2006/main" xmlns:r="http://schemas.openxmlformats.org/officeDocument/2006/relationships" xmlns:p="http://schemas.openxmlformats.org/presentationml/2006/main">
   <p:cSld>
     <p:spTree>
       <p:nvGrpSpPr>
-        <p:cNvPr id="1" name=""/>
+        <p:cNvPr id="1" name="">
+          <a:extLst>
+            <a:ext uri="{FF2B5EF4-FFF2-40B4-BE49-F238E27FC236}">
+              <a16:creationId xmlns:a16="http://schemas.microsoft.com/office/drawing/2014/main" id="{7B10D0C3-6BF3-DDDD-5144-0D1A6FB16472}"/>
+            </a:ext>
+          </a:extLst>
+        </p:cNvPr>
         <p:cNvGrpSpPr/>
         <p:nvPr/>
       </p:nvGrpSpPr>
@@ -4605,62 +7825,108 @@
       </p:grpSpPr>
       <p:sp>
         <p:nvSpPr>
-          <p:cNvPr id="2" name="Title 1">
-            <a:extLst>
-              <a:ext uri="{FF2B5EF4-FFF2-40B4-BE49-F238E27FC236}">
-                <a16:creationId xmlns:a16="http://schemas.microsoft.com/office/drawing/2014/main" id="{57362C6B-CDE6-9A2D-6F67-9A014F61CE4B}"/>
-              </a:ext>
-            </a:extLst>
-          </p:cNvPr>
-          <p:cNvSpPr>
-            <a:spLocks noGrp="1"/>
-          </p:cNvSpPr>
-          <p:nvPr>
-            <p:ph type="title"/>
-          </p:nvPr>
+          <p:cNvPr id="36" name="TextBox 35">
+            <a:extLst>
+              <a:ext uri="{FF2B5EF4-FFF2-40B4-BE49-F238E27FC236}">
+                <a16:creationId xmlns:a16="http://schemas.microsoft.com/office/drawing/2014/main" id="{6706209D-6700-FDD3-8119-8E55A7CE07DF}"/>
+              </a:ext>
+            </a:extLst>
+          </p:cNvPr>
+          <p:cNvSpPr txBox="1"/>
+          <p:nvPr/>
         </p:nvSpPr>
-        <p:spPr/>
+        <p:spPr>
+          <a:xfrm>
+            <a:off x="729688" y="762994"/>
+            <a:ext cx="10807888" cy="338554"/>
+          </a:xfrm>
+          <a:prstGeom prst="rect">
+            <a:avLst/>
+          </a:prstGeom>
+          <a:noFill/>
+        </p:spPr>
         <p:txBody>
-          <a:bodyPr/>
+          <a:bodyPr wrap="square">
+            <a:spAutoFit/>
+          </a:bodyPr>
           <a:lstStyle/>
           <a:p>
             <a:r>
-              <a:rPr lang="en-US" dirty="0"/>
-              <a:t>s</a:t>
-            </a:r>
-            <a:endParaRPr lang="en-GB" dirty="0"/>
+              <a:rPr lang="en-US" sz="1600"/>
+              <a:t>Number of estimations by type of validity per solver</a:t>
+            </a:r>
+            <a:endParaRPr lang="en-GB" sz="1600"/>
           </a:p>
         </p:txBody>
       </p:sp>
       <p:sp>
         <p:nvSpPr>
-          <p:cNvPr id="3" name="Content Placeholder 2">
-            <a:extLst>
-              <a:ext uri="{FF2B5EF4-FFF2-40B4-BE49-F238E27FC236}">
-                <a16:creationId xmlns:a16="http://schemas.microsoft.com/office/drawing/2014/main" id="{2F0624FE-28C1-0593-CDCE-7E7D2AAF89E0}"/>
-              </a:ext>
-            </a:extLst>
-          </p:cNvPr>
-          <p:cNvSpPr>
-            <a:spLocks noGrp="1"/>
-          </p:cNvSpPr>
-          <p:nvPr>
-            <p:ph idx="1"/>
-          </p:nvPr>
+          <p:cNvPr id="37" name="TextBox 36">
+            <a:extLst>
+              <a:ext uri="{FF2B5EF4-FFF2-40B4-BE49-F238E27FC236}">
+                <a16:creationId xmlns:a16="http://schemas.microsoft.com/office/drawing/2014/main" id="{105AC2F7-FA46-54A9-D7CB-9A942FD2D708}"/>
+              </a:ext>
+            </a:extLst>
+          </p:cNvPr>
+          <p:cNvSpPr txBox="1"/>
+          <p:nvPr/>
         </p:nvSpPr>
-        <p:spPr/>
+        <p:spPr>
+          <a:xfrm>
+            <a:off x="729688" y="0"/>
+            <a:ext cx="10807888" cy="830997"/>
+          </a:xfrm>
+          <a:prstGeom prst="rect">
+            <a:avLst/>
+          </a:prstGeom>
+          <a:noFill/>
+        </p:spPr>
         <p:txBody>
-          <a:bodyPr/>
+          <a:bodyPr wrap="square">
+            <a:spAutoFit/>
+          </a:bodyPr>
           <a:lstStyle/>
           <a:p>
-            <a:endParaRPr lang="en-GB"/>
+            <a:r>
+              <a:rPr lang="en-US" sz="2400" b="1"/>
+              <a:t>Invalid estimations are a mix of solvers having issues converging or returning parameter values outside of the validity filters</a:t>
+            </a:r>
+            <a:endParaRPr lang="en-GB" sz="2400" b="1"/>
           </a:p>
         </p:txBody>
       </p:sp>
+      <p:graphicFrame>
+        <p:nvGraphicFramePr>
+          <p:cNvPr id="2" name="Diagram 1">
+            <a:extLst>
+              <a:ext uri="{FF2B5EF4-FFF2-40B4-BE49-F238E27FC236}">
+                <a16:creationId xmlns:a16="http://schemas.microsoft.com/office/drawing/2014/main" id="{C7D311A9-E6B0-C18A-7D74-00D3BF4C60AE}"/>
+              </a:ext>
+            </a:extLst>
+          </p:cNvPr>
+          <p:cNvGraphicFramePr/>
+          <p:nvPr>
+            <p:extLst>
+              <p:ext uri="{D42A27DB-BD31-4B8C-83A1-F6EECF244321}">
+                <p14:modId xmlns:p14="http://schemas.microsoft.com/office/powerpoint/2010/main" val="2663968088"/>
+              </p:ext>
+            </p:extLst>
+          </p:nvPr>
+        </p:nvGraphicFramePr>
+        <p:xfrm>
+          <a:off x="1915459" y="1212725"/>
+          <a:ext cx="8128000" cy="5418667"/>
+        </p:xfrm>
+        <a:graphic>
+          <a:graphicData uri="http://schemas.openxmlformats.org/drawingml/2006/diagram">
+            <dgm:relIds xmlns:dgm="http://schemas.openxmlformats.org/drawingml/2006/diagram" xmlns:r="http://schemas.openxmlformats.org/officeDocument/2006/relationships" r:dm="rId2" r:lo="rId3" r:qs="rId4" r:cs="rId5"/>
+          </a:graphicData>
+        </a:graphic>
+      </p:graphicFrame>
     </p:spTree>
     <p:extLst>
       <p:ext uri="{BB962C8B-B14F-4D97-AF65-F5344CB8AC3E}">
-        <p14:creationId xmlns:p14="http://schemas.microsoft.com/office/powerpoint/2010/main" val="3115004336"/>
+        <p14:creationId xmlns:p14="http://schemas.microsoft.com/office/powerpoint/2010/main" val="3692195626"/>
       </p:ext>
     </p:extLst>
   </p:cSld>

</xml_diff>